<commit_message>
Adding start and stop commands
</commit_message>
<xml_diff>
--- a/Documentation/Pulse Programmer Documentation.pptx
+++ b/Documentation/Pulse Programmer Documentation.pptx
@@ -265,7 +265,7 @@
           <a:p>
             <a:fld id="{2E7CC9F0-B487-409B-B9EC-A5FEB68BFF69}" type="datetimeFigureOut">
               <a:rPr lang="en-US" smtClean="0"/>
-              <a:t>12/19/2024</a:t>
+              <a:t>12/23/2024</a:t>
             </a:fld>
             <a:endParaRPr lang="en-US"/>
           </a:p>
@@ -463,7 +463,7 @@
           <a:p>
             <a:fld id="{2E7CC9F0-B487-409B-B9EC-A5FEB68BFF69}" type="datetimeFigureOut">
               <a:rPr lang="en-US" smtClean="0"/>
-              <a:t>12/19/2024</a:t>
+              <a:t>12/23/2024</a:t>
             </a:fld>
             <a:endParaRPr lang="en-US"/>
           </a:p>
@@ -671,7 +671,7 @@
           <a:p>
             <a:fld id="{2E7CC9F0-B487-409B-B9EC-A5FEB68BFF69}" type="datetimeFigureOut">
               <a:rPr lang="en-US" smtClean="0"/>
-              <a:t>12/19/2024</a:t>
+              <a:t>12/23/2024</a:t>
             </a:fld>
             <a:endParaRPr lang="en-US"/>
           </a:p>
@@ -869,7 +869,7 @@
           <a:p>
             <a:fld id="{2E7CC9F0-B487-409B-B9EC-A5FEB68BFF69}" type="datetimeFigureOut">
               <a:rPr lang="en-US" smtClean="0"/>
-              <a:t>12/19/2024</a:t>
+              <a:t>12/23/2024</a:t>
             </a:fld>
             <a:endParaRPr lang="en-US"/>
           </a:p>
@@ -1144,7 +1144,7 @@
           <a:p>
             <a:fld id="{2E7CC9F0-B487-409B-B9EC-A5FEB68BFF69}" type="datetimeFigureOut">
               <a:rPr lang="en-US" smtClean="0"/>
-              <a:t>12/19/2024</a:t>
+              <a:t>12/23/2024</a:t>
             </a:fld>
             <a:endParaRPr lang="en-US"/>
           </a:p>
@@ -1409,7 +1409,7 @@
           <a:p>
             <a:fld id="{2E7CC9F0-B487-409B-B9EC-A5FEB68BFF69}" type="datetimeFigureOut">
               <a:rPr lang="en-US" smtClean="0"/>
-              <a:t>12/19/2024</a:t>
+              <a:t>12/23/2024</a:t>
             </a:fld>
             <a:endParaRPr lang="en-US"/>
           </a:p>
@@ -1821,7 +1821,7 @@
           <a:p>
             <a:fld id="{2E7CC9F0-B487-409B-B9EC-A5FEB68BFF69}" type="datetimeFigureOut">
               <a:rPr lang="en-US" smtClean="0"/>
-              <a:t>12/19/2024</a:t>
+              <a:t>12/23/2024</a:t>
             </a:fld>
             <a:endParaRPr lang="en-US"/>
           </a:p>
@@ -1962,7 +1962,7 @@
           <a:p>
             <a:fld id="{2E7CC9F0-B487-409B-B9EC-A5FEB68BFF69}" type="datetimeFigureOut">
               <a:rPr lang="en-US" smtClean="0"/>
-              <a:t>12/19/2024</a:t>
+              <a:t>12/23/2024</a:t>
             </a:fld>
             <a:endParaRPr lang="en-US"/>
           </a:p>
@@ -2075,7 +2075,7 @@
           <a:p>
             <a:fld id="{2E7CC9F0-B487-409B-B9EC-A5FEB68BFF69}" type="datetimeFigureOut">
               <a:rPr lang="en-US" smtClean="0"/>
-              <a:t>12/19/2024</a:t>
+              <a:t>12/23/2024</a:t>
             </a:fld>
             <a:endParaRPr lang="en-US"/>
           </a:p>
@@ -2386,7 +2386,7 @@
           <a:p>
             <a:fld id="{2E7CC9F0-B487-409B-B9EC-A5FEB68BFF69}" type="datetimeFigureOut">
               <a:rPr lang="en-US" smtClean="0"/>
-              <a:t>12/19/2024</a:t>
+              <a:t>12/23/2024</a:t>
             </a:fld>
             <a:endParaRPr lang="en-US"/>
           </a:p>
@@ -2674,7 +2674,7 @@
           <a:p>
             <a:fld id="{2E7CC9F0-B487-409B-B9EC-A5FEB68BFF69}" type="datetimeFigureOut">
               <a:rPr lang="en-US" smtClean="0"/>
-              <a:t>12/19/2024</a:t>
+              <a:t>12/23/2024</a:t>
             </a:fld>
             <a:endParaRPr lang="en-US"/>
           </a:p>
@@ -2915,7 +2915,7 @@
           <a:p>
             <a:fld id="{2E7CC9F0-B487-409B-B9EC-A5FEB68BFF69}" type="datetimeFigureOut">
               <a:rPr lang="en-US" smtClean="0"/>
-              <a:t>12/19/2024</a:t>
+              <a:t>12/23/2024</a:t>
             </a:fld>
             <a:endParaRPr lang="en-US"/>
           </a:p>

</xml_diff>

<commit_message>
Adding python scripts to generate pulse sequence
</commit_message>
<xml_diff>
--- a/Documentation/Pulse Programmer Documentation.pptx
+++ b/Documentation/Pulse Programmer Documentation.pptx
@@ -265,7 +265,7 @@
           <a:p>
             <a:fld id="{2E7CC9F0-B487-409B-B9EC-A5FEB68BFF69}" type="datetimeFigureOut">
               <a:rPr lang="en-US" smtClean="0"/>
-              <a:t>12/23/2024</a:t>
+              <a:t>7/17/2025</a:t>
             </a:fld>
             <a:endParaRPr lang="en-US"/>
           </a:p>
@@ -463,7 +463,7 @@
           <a:p>
             <a:fld id="{2E7CC9F0-B487-409B-B9EC-A5FEB68BFF69}" type="datetimeFigureOut">
               <a:rPr lang="en-US" smtClean="0"/>
-              <a:t>12/23/2024</a:t>
+              <a:t>7/17/2025</a:t>
             </a:fld>
             <a:endParaRPr lang="en-US"/>
           </a:p>
@@ -671,7 +671,7 @@
           <a:p>
             <a:fld id="{2E7CC9F0-B487-409B-B9EC-A5FEB68BFF69}" type="datetimeFigureOut">
               <a:rPr lang="en-US" smtClean="0"/>
-              <a:t>12/23/2024</a:t>
+              <a:t>7/17/2025</a:t>
             </a:fld>
             <a:endParaRPr lang="en-US"/>
           </a:p>
@@ -869,7 +869,7 @@
           <a:p>
             <a:fld id="{2E7CC9F0-B487-409B-B9EC-A5FEB68BFF69}" type="datetimeFigureOut">
               <a:rPr lang="en-US" smtClean="0"/>
-              <a:t>12/23/2024</a:t>
+              <a:t>7/17/2025</a:t>
             </a:fld>
             <a:endParaRPr lang="en-US"/>
           </a:p>
@@ -1144,7 +1144,7 @@
           <a:p>
             <a:fld id="{2E7CC9F0-B487-409B-B9EC-A5FEB68BFF69}" type="datetimeFigureOut">
               <a:rPr lang="en-US" smtClean="0"/>
-              <a:t>12/23/2024</a:t>
+              <a:t>7/17/2025</a:t>
             </a:fld>
             <a:endParaRPr lang="en-US"/>
           </a:p>
@@ -1409,7 +1409,7 @@
           <a:p>
             <a:fld id="{2E7CC9F0-B487-409B-B9EC-A5FEB68BFF69}" type="datetimeFigureOut">
               <a:rPr lang="en-US" smtClean="0"/>
-              <a:t>12/23/2024</a:t>
+              <a:t>7/17/2025</a:t>
             </a:fld>
             <a:endParaRPr lang="en-US"/>
           </a:p>
@@ -1821,7 +1821,7 @@
           <a:p>
             <a:fld id="{2E7CC9F0-B487-409B-B9EC-A5FEB68BFF69}" type="datetimeFigureOut">
               <a:rPr lang="en-US" smtClean="0"/>
-              <a:t>12/23/2024</a:t>
+              <a:t>7/17/2025</a:t>
             </a:fld>
             <a:endParaRPr lang="en-US"/>
           </a:p>
@@ -1962,7 +1962,7 @@
           <a:p>
             <a:fld id="{2E7CC9F0-B487-409B-B9EC-A5FEB68BFF69}" type="datetimeFigureOut">
               <a:rPr lang="en-US" smtClean="0"/>
-              <a:t>12/23/2024</a:t>
+              <a:t>7/17/2025</a:t>
             </a:fld>
             <a:endParaRPr lang="en-US"/>
           </a:p>
@@ -2075,7 +2075,7 @@
           <a:p>
             <a:fld id="{2E7CC9F0-B487-409B-B9EC-A5FEB68BFF69}" type="datetimeFigureOut">
               <a:rPr lang="en-US" smtClean="0"/>
-              <a:t>12/23/2024</a:t>
+              <a:t>7/17/2025</a:t>
             </a:fld>
             <a:endParaRPr lang="en-US"/>
           </a:p>
@@ -2386,7 +2386,7 @@
           <a:p>
             <a:fld id="{2E7CC9F0-B487-409B-B9EC-A5FEB68BFF69}" type="datetimeFigureOut">
               <a:rPr lang="en-US" smtClean="0"/>
-              <a:t>12/23/2024</a:t>
+              <a:t>7/17/2025</a:t>
             </a:fld>
             <a:endParaRPr lang="en-US"/>
           </a:p>
@@ -2674,7 +2674,7 @@
           <a:p>
             <a:fld id="{2E7CC9F0-B487-409B-B9EC-A5FEB68BFF69}" type="datetimeFigureOut">
               <a:rPr lang="en-US" smtClean="0"/>
-              <a:t>12/23/2024</a:t>
+              <a:t>7/17/2025</a:t>
             </a:fld>
             <a:endParaRPr lang="en-US"/>
           </a:p>
@@ -2915,7 +2915,7 @@
           <a:p>
             <a:fld id="{2E7CC9F0-B487-409B-B9EC-A5FEB68BFF69}" type="datetimeFigureOut">
               <a:rPr lang="en-US" smtClean="0"/>
-              <a:t>12/23/2024</a:t>
+              <a:t>7/17/2025</a:t>
             </a:fld>
             <a:endParaRPr lang="en-US"/>
           </a:p>
@@ -3602,6 +3602,45 @@
             <a:r>
               <a:rPr lang="en-US" dirty="0"/>
               <a:t>[79:72]			[71:64]		[63:56]		[55:36]		[35:32]			[31:0]</a:t>
+            </a:r>
+          </a:p>
+        </p:txBody>
+      </p:sp>
+      <p:sp>
+        <p:nvSpPr>
+          <p:cNvPr id="3" name="TextBox 2">
+            <a:extLst>
+              <a:ext uri="{FF2B5EF4-FFF2-40B4-BE49-F238E27FC236}">
+                <a16:creationId xmlns:a16="http://schemas.microsoft.com/office/drawing/2014/main" id="{EE1C400D-7885-4AC1-9F1F-B344A2C40710}"/>
+              </a:ext>
+            </a:extLst>
+          </p:cNvPr>
+          <p:cNvSpPr txBox="1"/>
+          <p:nvPr/>
+        </p:nvSpPr>
+        <p:spPr>
+          <a:xfrm>
+            <a:off x="4535424" y="1883664"/>
+            <a:ext cx="1596912" cy="369332"/>
+          </a:xfrm>
+          <a:prstGeom prst="rect">
+            <a:avLst/>
+          </a:prstGeom>
+          <a:noFill/>
+        </p:spPr>
+        <p:txBody>
+          <a:bodyPr wrap="none" rtlCol="0">
+            <a:spAutoFit/>
+          </a:bodyPr>
+          <a:lstStyle/>
+          <a:p>
+            <a:r>
+              <a:rPr lang="en-US" dirty="0">
+                <a:solidFill>
+                  <a:srgbClr val="FF0000"/>
+                </a:solidFill>
+              </a:rPr>
+              <a:t>OLD VERSION</a:t>
             </a:r>
           </a:p>
         </p:txBody>

</xml_diff>

<commit_message>
Adding new pulse generator script
</commit_message>
<xml_diff>
--- a/Documentation/Pulse Programmer Documentation.pptx
+++ b/Documentation/Pulse Programmer Documentation.pptx
@@ -265,7 +265,7 @@
           <a:p>
             <a:fld id="{2E7CC9F0-B487-409B-B9EC-A5FEB68BFF69}" type="datetimeFigureOut">
               <a:rPr lang="en-US" smtClean="0"/>
-              <a:t>7/17/2025</a:t>
+              <a:t>7/18/2025</a:t>
             </a:fld>
             <a:endParaRPr lang="en-US"/>
           </a:p>
@@ -463,7 +463,7 @@
           <a:p>
             <a:fld id="{2E7CC9F0-B487-409B-B9EC-A5FEB68BFF69}" type="datetimeFigureOut">
               <a:rPr lang="en-US" smtClean="0"/>
-              <a:t>7/17/2025</a:t>
+              <a:t>7/18/2025</a:t>
             </a:fld>
             <a:endParaRPr lang="en-US"/>
           </a:p>
@@ -671,7 +671,7 @@
           <a:p>
             <a:fld id="{2E7CC9F0-B487-409B-B9EC-A5FEB68BFF69}" type="datetimeFigureOut">
               <a:rPr lang="en-US" smtClean="0"/>
-              <a:t>7/17/2025</a:t>
+              <a:t>7/18/2025</a:t>
             </a:fld>
             <a:endParaRPr lang="en-US"/>
           </a:p>
@@ -869,7 +869,7 @@
           <a:p>
             <a:fld id="{2E7CC9F0-B487-409B-B9EC-A5FEB68BFF69}" type="datetimeFigureOut">
               <a:rPr lang="en-US" smtClean="0"/>
-              <a:t>7/17/2025</a:t>
+              <a:t>7/18/2025</a:t>
             </a:fld>
             <a:endParaRPr lang="en-US"/>
           </a:p>
@@ -1144,7 +1144,7 @@
           <a:p>
             <a:fld id="{2E7CC9F0-B487-409B-B9EC-A5FEB68BFF69}" type="datetimeFigureOut">
               <a:rPr lang="en-US" smtClean="0"/>
-              <a:t>7/17/2025</a:t>
+              <a:t>7/18/2025</a:t>
             </a:fld>
             <a:endParaRPr lang="en-US"/>
           </a:p>
@@ -1409,7 +1409,7 @@
           <a:p>
             <a:fld id="{2E7CC9F0-B487-409B-B9EC-A5FEB68BFF69}" type="datetimeFigureOut">
               <a:rPr lang="en-US" smtClean="0"/>
-              <a:t>7/17/2025</a:t>
+              <a:t>7/18/2025</a:t>
             </a:fld>
             <a:endParaRPr lang="en-US"/>
           </a:p>
@@ -1821,7 +1821,7 @@
           <a:p>
             <a:fld id="{2E7CC9F0-B487-409B-B9EC-A5FEB68BFF69}" type="datetimeFigureOut">
               <a:rPr lang="en-US" smtClean="0"/>
-              <a:t>7/17/2025</a:t>
+              <a:t>7/18/2025</a:t>
             </a:fld>
             <a:endParaRPr lang="en-US"/>
           </a:p>
@@ -1962,7 +1962,7 @@
           <a:p>
             <a:fld id="{2E7CC9F0-B487-409B-B9EC-A5FEB68BFF69}" type="datetimeFigureOut">
               <a:rPr lang="en-US" smtClean="0"/>
-              <a:t>7/17/2025</a:t>
+              <a:t>7/18/2025</a:t>
             </a:fld>
             <a:endParaRPr lang="en-US"/>
           </a:p>
@@ -2075,7 +2075,7 @@
           <a:p>
             <a:fld id="{2E7CC9F0-B487-409B-B9EC-A5FEB68BFF69}" type="datetimeFigureOut">
               <a:rPr lang="en-US" smtClean="0"/>
-              <a:t>7/17/2025</a:t>
+              <a:t>7/18/2025</a:t>
             </a:fld>
             <a:endParaRPr lang="en-US"/>
           </a:p>
@@ -2386,7 +2386,7 @@
           <a:p>
             <a:fld id="{2E7CC9F0-B487-409B-B9EC-A5FEB68BFF69}" type="datetimeFigureOut">
               <a:rPr lang="en-US" smtClean="0"/>
-              <a:t>7/17/2025</a:t>
+              <a:t>7/18/2025</a:t>
             </a:fld>
             <a:endParaRPr lang="en-US"/>
           </a:p>
@@ -2674,7 +2674,7 @@
           <a:p>
             <a:fld id="{2E7CC9F0-B487-409B-B9EC-A5FEB68BFF69}" type="datetimeFigureOut">
               <a:rPr lang="en-US" smtClean="0"/>
-              <a:t>7/17/2025</a:t>
+              <a:t>7/18/2025</a:t>
             </a:fld>
             <a:endParaRPr lang="en-US"/>
           </a:p>
@@ -2915,7 +2915,7 @@
           <a:p>
             <a:fld id="{2E7CC9F0-B487-409B-B9EC-A5FEB68BFF69}" type="datetimeFigureOut">
               <a:rPr lang="en-US" smtClean="0"/>
-              <a:t>7/17/2025</a:t>
+              <a:t>7/18/2025</a:t>
             </a:fld>
             <a:endParaRPr lang="en-US"/>
           </a:p>
@@ -3008,6 +3008,56 @@
               <a:t>‹#›</a:t>
             </a:fld>
             <a:endParaRPr lang="en-US"/>
+          </a:p>
+        </p:txBody>
+      </p:sp>
+      <p:sp>
+        <p:nvSpPr>
+          <p:cNvPr id="8" name="TextBox 7">
+            <a:extLst>
+              <a:ext uri="{FF2B5EF4-FFF2-40B4-BE49-F238E27FC236}">
+                <a16:creationId xmlns:a16="http://schemas.microsoft.com/office/drawing/2014/main" id="{6AA614A2-33A3-8699-D0DE-0435563FF286}"/>
+              </a:ext>
+            </a:extLst>
+          </p:cNvPr>
+          <p:cNvSpPr txBox="1"/>
+          <p:nvPr userDrawn="1">
+            <p:extLst>
+              <p:ext uri="{1162E1C5-73C7-4A58-AE30-91384D911F3F}">
+                <p184:classification xmlns:p184="http://schemas.microsoft.com/office/powerpoint/2018/4/main" val="ftr"/>
+              </p:ext>
+            </p:extLst>
+          </p:nvPr>
+        </p:nvSpPr>
+        <p:spPr>
+          <a:xfrm>
+            <a:off x="5661787" y="6672580"/>
+            <a:ext cx="890588" cy="121920"/>
+          </a:xfrm>
+          <a:prstGeom prst="rect">
+            <a:avLst/>
+          </a:prstGeom>
+        </p:spPr>
+        <p:txBody>
+          <a:bodyPr horzOverflow="overflow" lIns="0" tIns="0" rIns="0" bIns="0">
+            <a:spAutoFit/>
+          </a:bodyPr>
+          <a:lstStyle/>
+          <a:p>
+            <a:pPr algn="l"/>
+            <a:r>
+              <a:rPr lang="en-US" sz="800">
+                <a:solidFill>
+                  <a:srgbClr val="000000">
+                    <a:alpha val="50000"/>
+                  </a:srgbClr>
+                </a:solidFill>
+                <a:latin typeface="Calibri" panose="020F0502020204030204" pitchFamily="34" charset="0"/>
+                <a:ea typeface="Calibri" panose="020F0502020204030204" pitchFamily="34" charset="0"/>
+                <a:cs typeface="Calibri" panose="020F0502020204030204" pitchFamily="34" charset="0"/>
+              </a:rPr>
+              <a:t>-Bruker Confidential-</a:t>
+            </a:r>
           </a:p>
         </p:txBody>
       </p:sp>
@@ -3747,7 +3797,7 @@
             </a:r>
             <a:r>
               <a:rPr lang="en-US" sz="800" dirty="0"/>
-              <a:t>	|	pulse	|	DDS 	|	data 	|	op code	|	delay</a:t>
+              <a:t>	|	pulse pattern	|	DDS 	|	data 	|	op code	|	delay</a:t>
             </a:r>
           </a:p>
           <a:p>
@@ -3778,7 +3828,7 @@
         </p:nvSpPr>
         <p:spPr>
           <a:xfrm>
-            <a:off x="4023360" y="1728847"/>
+            <a:off x="3321522" y="1959679"/>
             <a:ext cx="5548955" cy="369332"/>
           </a:xfrm>
           <a:prstGeom prst="rect">

</xml_diff>

<commit_message>
Updating documentation with photos
</commit_message>
<xml_diff>
--- a/Documentation/Pulse Programmer Documentation.pptx
+++ b/Documentation/Pulse Programmer Documentation.pptx
@@ -11,6 +11,7 @@
     <p:sldId id="261" r:id="rId5"/>
     <p:sldId id="262" r:id="rId6"/>
     <p:sldId id="258" r:id="rId7"/>
+    <p:sldId id="263" r:id="rId8"/>
   </p:sldIdLst>
   <p:sldSz cx="12192000" cy="6858000"/>
   <p:notesSz cx="6858000" cy="9144000"/>
@@ -264,7 +265,7 @@
           <a:p>
             <a:fld id="{2E7CC9F0-B487-409B-B9EC-A5FEB68BFF69}" type="datetimeFigureOut">
               <a:rPr lang="en-US" smtClean="0"/>
-              <a:t>7/19/2025</a:t>
+              <a:t>7/20/2025</a:t>
             </a:fld>
             <a:endParaRPr lang="en-US"/>
           </a:p>
@@ -462,7 +463,7 @@
           <a:p>
             <a:fld id="{2E7CC9F0-B487-409B-B9EC-A5FEB68BFF69}" type="datetimeFigureOut">
               <a:rPr lang="en-US" smtClean="0"/>
-              <a:t>7/19/2025</a:t>
+              <a:t>7/20/2025</a:t>
             </a:fld>
             <a:endParaRPr lang="en-US"/>
           </a:p>
@@ -670,7 +671,7 @@
           <a:p>
             <a:fld id="{2E7CC9F0-B487-409B-B9EC-A5FEB68BFF69}" type="datetimeFigureOut">
               <a:rPr lang="en-US" smtClean="0"/>
-              <a:t>7/19/2025</a:t>
+              <a:t>7/20/2025</a:t>
             </a:fld>
             <a:endParaRPr lang="en-US"/>
           </a:p>
@@ -868,7 +869,7 @@
           <a:p>
             <a:fld id="{2E7CC9F0-B487-409B-B9EC-A5FEB68BFF69}" type="datetimeFigureOut">
               <a:rPr lang="en-US" smtClean="0"/>
-              <a:t>7/19/2025</a:t>
+              <a:t>7/20/2025</a:t>
             </a:fld>
             <a:endParaRPr lang="en-US"/>
           </a:p>
@@ -1143,7 +1144,7 @@
           <a:p>
             <a:fld id="{2E7CC9F0-B487-409B-B9EC-A5FEB68BFF69}" type="datetimeFigureOut">
               <a:rPr lang="en-US" smtClean="0"/>
-              <a:t>7/19/2025</a:t>
+              <a:t>7/20/2025</a:t>
             </a:fld>
             <a:endParaRPr lang="en-US"/>
           </a:p>
@@ -1408,7 +1409,7 @@
           <a:p>
             <a:fld id="{2E7CC9F0-B487-409B-B9EC-A5FEB68BFF69}" type="datetimeFigureOut">
               <a:rPr lang="en-US" smtClean="0"/>
-              <a:t>7/19/2025</a:t>
+              <a:t>7/20/2025</a:t>
             </a:fld>
             <a:endParaRPr lang="en-US"/>
           </a:p>
@@ -1820,7 +1821,7 @@
           <a:p>
             <a:fld id="{2E7CC9F0-B487-409B-B9EC-A5FEB68BFF69}" type="datetimeFigureOut">
               <a:rPr lang="en-US" smtClean="0"/>
-              <a:t>7/19/2025</a:t>
+              <a:t>7/20/2025</a:t>
             </a:fld>
             <a:endParaRPr lang="en-US"/>
           </a:p>
@@ -1961,7 +1962,7 @@
           <a:p>
             <a:fld id="{2E7CC9F0-B487-409B-B9EC-A5FEB68BFF69}" type="datetimeFigureOut">
               <a:rPr lang="en-US" smtClean="0"/>
-              <a:t>7/19/2025</a:t>
+              <a:t>7/20/2025</a:t>
             </a:fld>
             <a:endParaRPr lang="en-US"/>
           </a:p>
@@ -2074,7 +2075,7 @@
           <a:p>
             <a:fld id="{2E7CC9F0-B487-409B-B9EC-A5FEB68BFF69}" type="datetimeFigureOut">
               <a:rPr lang="en-US" smtClean="0"/>
-              <a:t>7/19/2025</a:t>
+              <a:t>7/20/2025</a:t>
             </a:fld>
             <a:endParaRPr lang="en-US"/>
           </a:p>
@@ -2385,7 +2386,7 @@
           <a:p>
             <a:fld id="{2E7CC9F0-B487-409B-B9EC-A5FEB68BFF69}" type="datetimeFigureOut">
               <a:rPr lang="en-US" smtClean="0"/>
-              <a:t>7/19/2025</a:t>
+              <a:t>7/20/2025</a:t>
             </a:fld>
             <a:endParaRPr lang="en-US"/>
           </a:p>
@@ -2673,7 +2674,7 @@
           <a:p>
             <a:fld id="{2E7CC9F0-B487-409B-B9EC-A5FEB68BFF69}" type="datetimeFigureOut">
               <a:rPr lang="en-US" smtClean="0"/>
-              <a:t>7/19/2025</a:t>
+              <a:t>7/20/2025</a:t>
             </a:fld>
             <a:endParaRPr lang="en-US"/>
           </a:p>
@@ -2914,7 +2915,7 @@
           <a:p>
             <a:fld id="{2E7CC9F0-B487-409B-B9EC-A5FEB68BFF69}" type="datetimeFigureOut">
               <a:rPr lang="en-US" smtClean="0"/>
-              <a:t>7/19/2025</a:t>
+              <a:t>7/20/2025</a:t>
             </a:fld>
             <a:endParaRPr lang="en-US"/>
           </a:p>
@@ -4172,6 +4173,207 @@
     <p:extLst>
       <p:ext uri="{BB962C8B-B14F-4D97-AF65-F5344CB8AC3E}">
         <p14:creationId xmlns:p14="http://schemas.microsoft.com/office/powerpoint/2010/main" val="379861110"/>
+      </p:ext>
+    </p:extLst>
+  </p:cSld>
+  <p:clrMapOvr>
+    <a:masterClrMapping/>
+  </p:clrMapOvr>
+</p:sld>
+</file>
+
+<file path=ppt/slides/slide7.xml><?xml version="1.0" encoding="utf-8"?>
+<p:sld xmlns:a="http://schemas.openxmlformats.org/drawingml/2006/main" xmlns:r="http://schemas.openxmlformats.org/officeDocument/2006/relationships" xmlns:p="http://schemas.openxmlformats.org/presentationml/2006/main">
+  <p:cSld>
+    <p:spTree>
+      <p:nvGrpSpPr>
+        <p:cNvPr id="1" name=""/>
+        <p:cNvGrpSpPr/>
+        <p:nvPr/>
+      </p:nvGrpSpPr>
+      <p:grpSpPr>
+        <a:xfrm>
+          <a:off x="0" y="0"/>
+          <a:ext cx="0" cy="0"/>
+          <a:chOff x="0" y="0"/>
+          <a:chExt cx="0" cy="0"/>
+        </a:xfrm>
+      </p:grpSpPr>
+      <p:sp>
+        <p:nvSpPr>
+          <p:cNvPr id="2" name="Title 1">
+            <a:extLst>
+              <a:ext uri="{FF2B5EF4-FFF2-40B4-BE49-F238E27FC236}">
+                <a16:creationId xmlns:a16="http://schemas.microsoft.com/office/drawing/2014/main" id="{F4BA3CC6-714E-ABA4-DF99-3166C805F515}"/>
+              </a:ext>
+            </a:extLst>
+          </p:cNvPr>
+          <p:cNvSpPr>
+            <a:spLocks noGrp="1"/>
+          </p:cNvSpPr>
+          <p:nvPr>
+            <p:ph type="title"/>
+          </p:nvPr>
+        </p:nvSpPr>
+        <p:spPr/>
+        <p:txBody>
+          <a:bodyPr/>
+          <a:lstStyle/>
+          <a:p>
+            <a:r>
+              <a:rPr lang="en-US" dirty="0"/>
+              <a:t>Hardware Photos</a:t>
+            </a:r>
+          </a:p>
+        </p:txBody>
+      </p:sp>
+      <p:pic>
+        <p:nvPicPr>
+          <p:cNvPr id="5" name="Content Placeholder 4" descr="A green circuit board with black wires&#10;&#10;AI-generated content may be incorrect.">
+            <a:extLst>
+              <a:ext uri="{FF2B5EF4-FFF2-40B4-BE49-F238E27FC236}">
+                <a16:creationId xmlns:a16="http://schemas.microsoft.com/office/drawing/2014/main" id="{3592D1A4-EC3C-8C9A-95A4-B9BBF14BE5FF}"/>
+              </a:ext>
+            </a:extLst>
+          </p:cNvPr>
+          <p:cNvPicPr>
+            <a:picLocks noGrp="1" noChangeAspect="1"/>
+          </p:cNvPicPr>
+          <p:nvPr>
+            <p:ph idx="1"/>
+          </p:nvPr>
+        </p:nvPicPr>
+        <p:blipFill>
+          <a:blip r:embed="rId2">
+            <a:extLst>
+              <a:ext uri="{28A0092B-C50C-407E-A947-70E740481C1C}">
+                <a14:useLocalDpi xmlns:a14="http://schemas.microsoft.com/office/drawing/2010/main" val="0"/>
+              </a:ext>
+            </a:extLst>
+          </a:blip>
+          <a:stretch>
+            <a:fillRect/>
+          </a:stretch>
+        </p:blipFill>
+        <p:spPr>
+          <a:xfrm>
+            <a:off x="1750142" y="4042239"/>
+            <a:ext cx="3458496" cy="2593872"/>
+          </a:xfrm>
+        </p:spPr>
+      </p:pic>
+      <p:pic>
+        <p:nvPicPr>
+          <p:cNvPr id="7" name="Picture 6" descr="A group of electronic components on a table&#10;&#10;AI-generated content may be incorrect.">
+            <a:extLst>
+              <a:ext uri="{FF2B5EF4-FFF2-40B4-BE49-F238E27FC236}">
+                <a16:creationId xmlns:a16="http://schemas.microsoft.com/office/drawing/2014/main" id="{74132016-6BFA-7990-1D26-306E99903AB8}"/>
+              </a:ext>
+            </a:extLst>
+          </p:cNvPr>
+          <p:cNvPicPr>
+            <a:picLocks noChangeAspect="1"/>
+          </p:cNvPicPr>
+          <p:nvPr/>
+        </p:nvPicPr>
+        <p:blipFill>
+          <a:blip r:embed="rId3">
+            <a:extLst>
+              <a:ext uri="{28A0092B-C50C-407E-A947-70E740481C1C}">
+                <a14:useLocalDpi xmlns:a14="http://schemas.microsoft.com/office/drawing/2010/main" val="0"/>
+              </a:ext>
+            </a:extLst>
+          </a:blip>
+          <a:stretch>
+            <a:fillRect/>
+          </a:stretch>
+        </p:blipFill>
+        <p:spPr>
+          <a:xfrm>
+            <a:off x="6731103" y="4055961"/>
+            <a:ext cx="3571427" cy="2678570"/>
+          </a:xfrm>
+          <a:prstGeom prst="rect">
+            <a:avLst/>
+          </a:prstGeom>
+        </p:spPr>
+      </p:pic>
+      <p:pic>
+        <p:nvPicPr>
+          <p:cNvPr id="9" name="Picture 8" descr="A black electronic device with buttons and switches&#10;&#10;AI-generated content may be incorrect.">
+            <a:extLst>
+              <a:ext uri="{FF2B5EF4-FFF2-40B4-BE49-F238E27FC236}">
+                <a16:creationId xmlns:a16="http://schemas.microsoft.com/office/drawing/2014/main" id="{0DB086C0-887C-0B37-A1C2-9F375827392C}"/>
+              </a:ext>
+            </a:extLst>
+          </p:cNvPr>
+          <p:cNvPicPr>
+            <a:picLocks noChangeAspect="1"/>
+          </p:cNvPicPr>
+          <p:nvPr/>
+        </p:nvPicPr>
+        <p:blipFill>
+          <a:blip r:embed="rId4">
+            <a:extLst>
+              <a:ext uri="{28A0092B-C50C-407E-A947-70E740481C1C}">
+                <a14:useLocalDpi xmlns:a14="http://schemas.microsoft.com/office/drawing/2010/main" val="0"/>
+              </a:ext>
+            </a:extLst>
+          </a:blip>
+          <a:stretch>
+            <a:fillRect/>
+          </a:stretch>
+        </p:blipFill>
+        <p:spPr>
+          <a:xfrm>
+            <a:off x="1904674" y="1532038"/>
+            <a:ext cx="3149432" cy="2362074"/>
+          </a:xfrm>
+          <a:prstGeom prst="rect">
+            <a:avLst/>
+          </a:prstGeom>
+        </p:spPr>
+      </p:pic>
+      <p:pic>
+        <p:nvPicPr>
+          <p:cNvPr id="11" name="Picture 10" descr="A circuit board with lights on it&#10;&#10;AI-generated content may be incorrect.">
+            <a:extLst>
+              <a:ext uri="{FF2B5EF4-FFF2-40B4-BE49-F238E27FC236}">
+                <a16:creationId xmlns:a16="http://schemas.microsoft.com/office/drawing/2014/main" id="{5B9F0832-18A3-82DB-B7F3-D10BDFAC39F4}"/>
+              </a:ext>
+            </a:extLst>
+          </p:cNvPr>
+          <p:cNvPicPr>
+            <a:picLocks noChangeAspect="1"/>
+          </p:cNvPicPr>
+          <p:nvPr/>
+        </p:nvPicPr>
+        <p:blipFill>
+          <a:blip r:embed="rId5">
+            <a:extLst>
+              <a:ext uri="{28A0092B-C50C-407E-A947-70E740481C1C}">
+                <a14:useLocalDpi xmlns:a14="http://schemas.microsoft.com/office/drawing/2010/main" val="0"/>
+              </a:ext>
+            </a:extLst>
+          </a:blip>
+          <a:stretch>
+            <a:fillRect/>
+          </a:stretch>
+        </p:blipFill>
+        <p:spPr>
+          <a:xfrm>
+            <a:off x="6731102" y="1215541"/>
+            <a:ext cx="3571428" cy="2678571"/>
+          </a:xfrm>
+          <a:prstGeom prst="rect">
+            <a:avLst/>
+          </a:prstGeom>
+        </p:spPr>
+      </p:pic>
+    </p:spTree>
+    <p:extLst>
+      <p:ext uri="{BB962C8B-B14F-4D97-AF65-F5344CB8AC3E}">
+        <p14:creationId xmlns:p14="http://schemas.microsoft.com/office/powerpoint/2010/main" val="1820235582"/>
       </p:ext>
     </p:extLst>
   </p:cSld>

</xml_diff>

<commit_message>
Updating documentation for pulse programmer op codes
</commit_message>
<xml_diff>
--- a/Documentation/Pulse Programmer Documentation.pptx
+++ b/Documentation/Pulse Programmer Documentation.pptx
@@ -7,11 +7,11 @@
   <p:sldIdLst>
     <p:sldId id="256" r:id="rId2"/>
     <p:sldId id="257" r:id="rId3"/>
-    <p:sldId id="260" r:id="rId4"/>
-    <p:sldId id="261" r:id="rId5"/>
-    <p:sldId id="262" r:id="rId6"/>
-    <p:sldId id="258" r:id="rId7"/>
-    <p:sldId id="263" r:id="rId8"/>
+    <p:sldId id="261" r:id="rId4"/>
+    <p:sldId id="262" r:id="rId5"/>
+    <p:sldId id="258" r:id="rId6"/>
+    <p:sldId id="263" r:id="rId7"/>
+    <p:sldId id="260" r:id="rId8"/>
   </p:sldIdLst>
   <p:sldSz cx="12192000" cy="6858000"/>
   <p:notesSz cx="6858000" cy="9144000"/>
@@ -265,7 +265,7 @@
           <a:p>
             <a:fld id="{2E7CC9F0-B487-409B-B9EC-A5FEB68BFF69}" type="datetimeFigureOut">
               <a:rPr lang="en-US" smtClean="0"/>
-              <a:t>7/20/2025</a:t>
+              <a:t>3/14/2026</a:t>
             </a:fld>
             <a:endParaRPr lang="en-US"/>
           </a:p>
@@ -463,7 +463,7 @@
           <a:p>
             <a:fld id="{2E7CC9F0-B487-409B-B9EC-A5FEB68BFF69}" type="datetimeFigureOut">
               <a:rPr lang="en-US" smtClean="0"/>
-              <a:t>7/20/2025</a:t>
+              <a:t>3/14/2026</a:t>
             </a:fld>
             <a:endParaRPr lang="en-US"/>
           </a:p>
@@ -671,7 +671,7 @@
           <a:p>
             <a:fld id="{2E7CC9F0-B487-409B-B9EC-A5FEB68BFF69}" type="datetimeFigureOut">
               <a:rPr lang="en-US" smtClean="0"/>
-              <a:t>7/20/2025</a:t>
+              <a:t>3/14/2026</a:t>
             </a:fld>
             <a:endParaRPr lang="en-US"/>
           </a:p>
@@ -869,7 +869,7 @@
           <a:p>
             <a:fld id="{2E7CC9F0-B487-409B-B9EC-A5FEB68BFF69}" type="datetimeFigureOut">
               <a:rPr lang="en-US" smtClean="0"/>
-              <a:t>7/20/2025</a:t>
+              <a:t>3/14/2026</a:t>
             </a:fld>
             <a:endParaRPr lang="en-US"/>
           </a:p>
@@ -1144,7 +1144,7 @@
           <a:p>
             <a:fld id="{2E7CC9F0-B487-409B-B9EC-A5FEB68BFF69}" type="datetimeFigureOut">
               <a:rPr lang="en-US" smtClean="0"/>
-              <a:t>7/20/2025</a:t>
+              <a:t>3/14/2026</a:t>
             </a:fld>
             <a:endParaRPr lang="en-US"/>
           </a:p>
@@ -1409,7 +1409,7 @@
           <a:p>
             <a:fld id="{2E7CC9F0-B487-409B-B9EC-A5FEB68BFF69}" type="datetimeFigureOut">
               <a:rPr lang="en-US" smtClean="0"/>
-              <a:t>7/20/2025</a:t>
+              <a:t>3/14/2026</a:t>
             </a:fld>
             <a:endParaRPr lang="en-US"/>
           </a:p>
@@ -1821,7 +1821,7 @@
           <a:p>
             <a:fld id="{2E7CC9F0-B487-409B-B9EC-A5FEB68BFF69}" type="datetimeFigureOut">
               <a:rPr lang="en-US" smtClean="0"/>
-              <a:t>7/20/2025</a:t>
+              <a:t>3/14/2026</a:t>
             </a:fld>
             <a:endParaRPr lang="en-US"/>
           </a:p>
@@ -1962,7 +1962,7 @@
           <a:p>
             <a:fld id="{2E7CC9F0-B487-409B-B9EC-A5FEB68BFF69}" type="datetimeFigureOut">
               <a:rPr lang="en-US" smtClean="0"/>
-              <a:t>7/20/2025</a:t>
+              <a:t>3/14/2026</a:t>
             </a:fld>
             <a:endParaRPr lang="en-US"/>
           </a:p>
@@ -2075,7 +2075,7 @@
           <a:p>
             <a:fld id="{2E7CC9F0-B487-409B-B9EC-A5FEB68BFF69}" type="datetimeFigureOut">
               <a:rPr lang="en-US" smtClean="0"/>
-              <a:t>7/20/2025</a:t>
+              <a:t>3/14/2026</a:t>
             </a:fld>
             <a:endParaRPr lang="en-US"/>
           </a:p>
@@ -2386,7 +2386,7 @@
           <a:p>
             <a:fld id="{2E7CC9F0-B487-409B-B9EC-A5FEB68BFF69}" type="datetimeFigureOut">
               <a:rPr lang="en-US" smtClean="0"/>
-              <a:t>7/20/2025</a:t>
+              <a:t>3/14/2026</a:t>
             </a:fld>
             <a:endParaRPr lang="en-US"/>
           </a:p>
@@ -2674,7 +2674,7 @@
           <a:p>
             <a:fld id="{2E7CC9F0-B487-409B-B9EC-A5FEB68BFF69}" type="datetimeFigureOut">
               <a:rPr lang="en-US" smtClean="0"/>
-              <a:t>7/20/2025</a:t>
+              <a:t>3/14/2026</a:t>
             </a:fld>
             <a:endParaRPr lang="en-US"/>
           </a:p>
@@ -2915,7 +2915,7 @@
           <a:p>
             <a:fld id="{2E7CC9F0-B487-409B-B9EC-A5FEB68BFF69}" type="datetimeFigureOut">
               <a:rPr lang="en-US" smtClean="0"/>
-              <a:t>7/20/2025</a:t>
+              <a:t>3/14/2026</a:t>
             </a:fld>
             <a:endParaRPr lang="en-US"/>
           </a:p>
@@ -3543,6 +3543,66 @@
           </a:p>
         </p:txBody>
       </p:sp>
+      <p:pic>
+        <p:nvPicPr>
+          <p:cNvPr id="5" name="Picture 4">
+            <a:extLst>
+              <a:ext uri="{FF2B5EF4-FFF2-40B4-BE49-F238E27FC236}">
+                <a16:creationId xmlns:a16="http://schemas.microsoft.com/office/drawing/2014/main" id="{C1EF69F0-313B-92BA-39CF-167787B5E0FC}"/>
+              </a:ext>
+            </a:extLst>
+          </p:cNvPr>
+          <p:cNvPicPr>
+            <a:picLocks noChangeAspect="1"/>
+          </p:cNvPicPr>
+          <p:nvPr/>
+        </p:nvPicPr>
+        <p:blipFill>
+          <a:blip r:embed="rId2"/>
+          <a:stretch>
+            <a:fillRect/>
+          </a:stretch>
+        </p:blipFill>
+        <p:spPr>
+          <a:xfrm>
+            <a:off x="1437480" y="4167078"/>
+            <a:ext cx="2572109" cy="1228896"/>
+          </a:xfrm>
+          <a:prstGeom prst="rect">
+            <a:avLst/>
+          </a:prstGeom>
+        </p:spPr>
+      </p:pic>
+      <p:pic>
+        <p:nvPicPr>
+          <p:cNvPr id="7" name="Picture 6">
+            <a:extLst>
+              <a:ext uri="{FF2B5EF4-FFF2-40B4-BE49-F238E27FC236}">
+                <a16:creationId xmlns:a16="http://schemas.microsoft.com/office/drawing/2014/main" id="{65D1EA9E-0B9E-3915-633D-E0C93FFFA152}"/>
+              </a:ext>
+            </a:extLst>
+          </p:cNvPr>
+          <p:cNvPicPr>
+            <a:picLocks noChangeAspect="1"/>
+          </p:cNvPicPr>
+          <p:nvPr/>
+        </p:nvPicPr>
+        <p:blipFill>
+          <a:blip r:embed="rId3"/>
+          <a:stretch>
+            <a:fillRect/>
+          </a:stretch>
+        </p:blipFill>
+        <p:spPr>
+          <a:xfrm>
+            <a:off x="4866623" y="4510025"/>
+            <a:ext cx="2734057" cy="885949"/>
+          </a:xfrm>
+          <a:prstGeom prst="rect">
+            <a:avLst/>
+          </a:prstGeom>
+        </p:spPr>
+      </p:pic>
     </p:spTree>
     <p:extLst>
       <p:ext uri="{BB962C8B-B14F-4D97-AF65-F5344CB8AC3E}">
@@ -3561,13 +3621,7 @@
   <p:cSld>
     <p:spTree>
       <p:nvGrpSpPr>
-        <p:cNvPr id="1" name="">
-          <a:extLst>
-            <a:ext uri="{FF2B5EF4-FFF2-40B4-BE49-F238E27FC236}">
-              <a16:creationId xmlns:a16="http://schemas.microsoft.com/office/drawing/2014/main" id="{8BEEC054-DD2A-EB4E-682E-AB080E885367}"/>
-            </a:ext>
-          </a:extLst>
-        </p:cNvPr>
+        <p:cNvPr id="1" name=""/>
         <p:cNvGrpSpPr/>
         <p:nvPr/>
       </p:nvGrpSpPr>
@@ -3584,7 +3638,7 @@
           <p:cNvPr id="2" name="Title 1">
             <a:extLst>
               <a:ext uri="{FF2B5EF4-FFF2-40B4-BE49-F238E27FC236}">
-                <a16:creationId xmlns:a16="http://schemas.microsoft.com/office/drawing/2014/main" id="{52A3FB3F-242A-2982-140E-F63ACF6E10C4}"/>
+                <a16:creationId xmlns:a16="http://schemas.microsoft.com/office/drawing/2014/main" id="{45CAC404-D806-6C8D-A657-2B7AB09A4430}"/>
               </a:ext>
             </a:extLst>
           </p:cNvPr>
@@ -3602,105 +3656,658 @@
           <a:p>
             <a:r>
               <a:rPr lang="en-US" dirty="0"/>
-              <a:t>Programming Words (v1)</a:t>
-            </a:r>
-          </a:p>
-        </p:txBody>
-      </p:sp>
-      <p:sp>
-        <p:nvSpPr>
-          <p:cNvPr id="4" name="TextBox 3">
-            <a:extLst>
-              <a:ext uri="{FF2B5EF4-FFF2-40B4-BE49-F238E27FC236}">
-                <a16:creationId xmlns:a16="http://schemas.microsoft.com/office/drawing/2014/main" id="{C4988A63-7D86-337A-45C2-8FDE406C2480}"/>
-              </a:ext>
-            </a:extLst>
-          </p:cNvPr>
-          <p:cNvSpPr txBox="1"/>
-          <p:nvPr/>
-        </p:nvSpPr>
-        <p:spPr>
-          <a:xfrm>
-            <a:off x="454057" y="2967335"/>
-            <a:ext cx="11559619" cy="461665"/>
-          </a:xfrm>
-          <a:prstGeom prst="rect">
-            <a:avLst/>
-          </a:prstGeom>
-          <a:noFill/>
-        </p:spPr>
-        <p:txBody>
-          <a:bodyPr wrap="square" rtlCol="0">
-            <a:spAutoFit/>
-          </a:bodyPr>
-          <a:lstStyle/>
-          <a:p>
-            <a:r>
-              <a:rPr lang="en-US" sz="800" dirty="0"/>
-              <a:t>command	|	</a:t>
-            </a:r>
-            <a:r>
-              <a:rPr lang="en-US" sz="800" dirty="0" err="1"/>
-              <a:t>addr</a:t>
-            </a:r>
-            <a:r>
-              <a:rPr lang="en-US" sz="800" dirty="0"/>
-              <a:t>	|	pulse pattern	|	DDS 	|	data 	|	op code	|	delay</a:t>
-            </a:r>
-          </a:p>
-          <a:p>
-            <a:r>
-              <a:rPr lang="en-US" sz="800" dirty="0"/>
-              <a:t>4-bit	|	12-bit	|	8-bit	|	8-bit	|	12-bit 	|	4-bit	|	32-bit</a:t>
-            </a:r>
-          </a:p>
-          <a:p>
-            <a:r>
-              <a:rPr lang="en-US" sz="800" dirty="0"/>
-              <a:t>[79:76]	|	[75:64]	|	[63:56]	|	 [55:48] 	|	[47:36] 	|	[35:32]	|	[31:0]</a:t>
-            </a:r>
-          </a:p>
-        </p:txBody>
-      </p:sp>
-      <p:sp>
-        <p:nvSpPr>
-          <p:cNvPr id="3" name="TextBox 2">
-            <a:extLst>
-              <a:ext uri="{FF2B5EF4-FFF2-40B4-BE49-F238E27FC236}">
-                <a16:creationId xmlns:a16="http://schemas.microsoft.com/office/drawing/2014/main" id="{3595C6AF-0AA8-0F1E-E826-71D7A8E5D015}"/>
-              </a:ext>
-            </a:extLst>
-          </p:cNvPr>
-          <p:cNvSpPr txBox="1"/>
-          <p:nvPr/>
-        </p:nvSpPr>
-        <p:spPr>
-          <a:xfrm>
-            <a:off x="3321522" y="1959679"/>
-            <a:ext cx="5548955" cy="369332"/>
-          </a:xfrm>
-          <a:prstGeom prst="rect">
-            <a:avLst/>
-          </a:prstGeom>
-          <a:noFill/>
-        </p:spPr>
-        <p:txBody>
-          <a:bodyPr wrap="none" rtlCol="0">
-            <a:spAutoFit/>
-          </a:bodyPr>
-          <a:lstStyle/>
-          <a:p>
-            <a:r>
-              <a:rPr lang="en-US" dirty="0"/>
-              <a:t>Need at least 12-bit data for address in GOTO op-code</a:t>
-            </a:r>
-          </a:p>
-        </p:txBody>
-      </p:sp>
+              <a:t>Op Codes</a:t>
+            </a:r>
+          </a:p>
+        </p:txBody>
+      </p:sp>
+      <p:graphicFrame>
+        <p:nvGraphicFramePr>
+          <p:cNvPr id="4" name="Table 3">
+            <a:extLst>
+              <a:ext uri="{FF2B5EF4-FFF2-40B4-BE49-F238E27FC236}">
+                <a16:creationId xmlns:a16="http://schemas.microsoft.com/office/drawing/2014/main" id="{89A0579B-BB56-1EC4-3568-E92569F824EA}"/>
+              </a:ext>
+            </a:extLst>
+          </p:cNvPr>
+          <p:cNvGraphicFramePr>
+            <a:graphicFrameLocks noGrp="1"/>
+          </p:cNvGraphicFramePr>
+          <p:nvPr>
+            <p:extLst>
+              <p:ext uri="{D42A27DB-BD31-4B8C-83A1-F6EECF244321}">
+                <p14:modId xmlns:p14="http://schemas.microsoft.com/office/powerpoint/2010/main" val="1598966454"/>
+              </p:ext>
+            </p:extLst>
+          </p:nvPr>
+        </p:nvGraphicFramePr>
+        <p:xfrm>
+          <a:off x="566993" y="1845749"/>
+          <a:ext cx="11058014" cy="3571240"/>
+        </p:xfrm>
+        <a:graphic>
+          <a:graphicData uri="http://schemas.openxmlformats.org/drawingml/2006/table">
+            <a:tbl>
+              <a:tblPr firstRow="1" bandRow="1">
+                <a:tableStyleId>{5C22544A-7EE6-4342-B048-85BDC9FD1C3A}</a:tableStyleId>
+              </a:tblPr>
+              <a:tblGrid>
+                <a:gridCol w="1999786">
+                  <a:extLst>
+                    <a:ext uri="{9D8B030D-6E8A-4147-A177-3AD203B41FA5}">
+                      <a16:colId xmlns:a16="http://schemas.microsoft.com/office/drawing/2014/main" val="40757123"/>
+                    </a:ext>
+                  </a:extLst>
+                </a:gridCol>
+                <a:gridCol w="1547202">
+                  <a:extLst>
+                    <a:ext uri="{9D8B030D-6E8A-4147-A177-3AD203B41FA5}">
+                      <a16:colId xmlns:a16="http://schemas.microsoft.com/office/drawing/2014/main" val="4052018327"/>
+                    </a:ext>
+                  </a:extLst>
+                </a:gridCol>
+                <a:gridCol w="1504335">
+                  <a:extLst>
+                    <a:ext uri="{9D8B030D-6E8A-4147-A177-3AD203B41FA5}">
+                      <a16:colId xmlns:a16="http://schemas.microsoft.com/office/drawing/2014/main" val="978270031"/>
+                    </a:ext>
+                  </a:extLst>
+                </a:gridCol>
+                <a:gridCol w="2007121">
+                  <a:extLst>
+                    <a:ext uri="{9D8B030D-6E8A-4147-A177-3AD203B41FA5}">
+                      <a16:colId xmlns:a16="http://schemas.microsoft.com/office/drawing/2014/main" val="3865882804"/>
+                    </a:ext>
+                  </a:extLst>
+                </a:gridCol>
+                <a:gridCol w="1233428">
+                  <a:extLst>
+                    <a:ext uri="{9D8B030D-6E8A-4147-A177-3AD203B41FA5}">
+                      <a16:colId xmlns:a16="http://schemas.microsoft.com/office/drawing/2014/main" val="1540856599"/>
+                    </a:ext>
+                  </a:extLst>
+                </a:gridCol>
+                <a:gridCol w="2766142">
+                  <a:extLst>
+                    <a:ext uri="{9D8B030D-6E8A-4147-A177-3AD203B41FA5}">
+                      <a16:colId xmlns:a16="http://schemas.microsoft.com/office/drawing/2014/main" val="2786182465"/>
+                    </a:ext>
+                  </a:extLst>
+                </a:gridCol>
+              </a:tblGrid>
+              <a:tr h="370840">
+                <a:tc>
+                  <a:txBody>
+                    <a:bodyPr/>
+                    <a:lstStyle/>
+                    <a:p>
+                      <a:r>
+                        <a:rPr lang="en-US" dirty="0"/>
+                        <a:t>NAME</a:t>
+                      </a:r>
+                    </a:p>
+                  </a:txBody>
+                  <a:tcPr/>
+                </a:tc>
+                <a:tc>
+                  <a:txBody>
+                    <a:bodyPr/>
+                    <a:lstStyle/>
+                    <a:p>
+                      <a:r>
+                        <a:rPr lang="en-US" dirty="0"/>
+                        <a:t>OP CODE (BIN)</a:t>
+                      </a:r>
+                    </a:p>
+                  </a:txBody>
+                  <a:tcPr/>
+                </a:tc>
+                <a:tc>
+                  <a:txBody>
+                    <a:bodyPr/>
+                    <a:lstStyle/>
+                    <a:p>
+                      <a:r>
+                        <a:rPr lang="en-US" dirty="0"/>
+                        <a:t>OP CODE (INT)</a:t>
+                      </a:r>
+                    </a:p>
+                  </a:txBody>
+                  <a:tcPr/>
+                </a:tc>
+                <a:tc>
+                  <a:txBody>
+                    <a:bodyPr/>
+                    <a:lstStyle/>
+                    <a:p>
+                      <a:r>
+                        <a:rPr lang="en-US" dirty="0"/>
+                        <a:t>DELAY</a:t>
+                      </a:r>
+                    </a:p>
+                    <a:p>
+                      <a:r>
+                        <a:rPr lang="en-US" dirty="0"/>
+                        <a:t>VALUES</a:t>
+                      </a:r>
+                    </a:p>
+                  </a:txBody>
+                  <a:tcPr/>
+                </a:tc>
+                <a:tc>
+                  <a:txBody>
+                    <a:bodyPr/>
+                    <a:lstStyle/>
+                    <a:p>
+                      <a:r>
+                        <a:rPr lang="en-US" dirty="0"/>
+                        <a:t>DATA</a:t>
+                      </a:r>
+                    </a:p>
+                    <a:p>
+                      <a:r>
+                        <a:rPr lang="en-US" dirty="0"/>
+                        <a:t>VALUES</a:t>
+                      </a:r>
+                    </a:p>
+                  </a:txBody>
+                  <a:tcPr/>
+                </a:tc>
+                <a:tc>
+                  <a:txBody>
+                    <a:bodyPr/>
+                    <a:lstStyle/>
+                    <a:p>
+                      <a:r>
+                        <a:rPr lang="en-US" dirty="0"/>
+                        <a:t>DESC</a:t>
+                      </a:r>
+                    </a:p>
+                  </a:txBody>
+                  <a:tcPr/>
+                </a:tc>
+                <a:extLst>
+                  <a:ext uri="{0D108BD9-81ED-4DB2-BD59-A6C34878D82A}">
+                    <a16:rowId xmlns:a16="http://schemas.microsoft.com/office/drawing/2014/main" val="1433844262"/>
+                  </a:ext>
+                </a:extLst>
+              </a:tr>
+              <a:tr h="370840">
+                <a:tc>
+                  <a:txBody>
+                    <a:bodyPr/>
+                    <a:lstStyle/>
+                    <a:p>
+                      <a:r>
+                        <a:rPr lang="en-US" dirty="0"/>
+                        <a:t>NO OP</a:t>
+                      </a:r>
+                    </a:p>
+                  </a:txBody>
+                  <a:tcPr/>
+                </a:tc>
+                <a:tc>
+                  <a:txBody>
+                    <a:bodyPr/>
+                    <a:lstStyle/>
+                    <a:p>
+                      <a:r>
+                        <a:rPr lang="en-US" dirty="0"/>
+                        <a:t>0b0000</a:t>
+                      </a:r>
+                    </a:p>
+                  </a:txBody>
+                  <a:tcPr/>
+                </a:tc>
+                <a:tc>
+                  <a:txBody>
+                    <a:bodyPr/>
+                    <a:lstStyle/>
+                    <a:p>
+                      <a:r>
+                        <a:rPr lang="en-US" dirty="0"/>
+                        <a:t>0</a:t>
+                      </a:r>
+                    </a:p>
+                  </a:txBody>
+                  <a:tcPr/>
+                </a:tc>
+                <a:tc>
+                  <a:txBody>
+                    <a:bodyPr/>
+                    <a:lstStyle/>
+                    <a:p>
+                      <a:r>
+                        <a:rPr lang="en-US" dirty="0"/>
+                        <a:t>NA</a:t>
+                      </a:r>
+                    </a:p>
+                  </a:txBody>
+                  <a:tcPr/>
+                </a:tc>
+                <a:tc>
+                  <a:txBody>
+                    <a:bodyPr/>
+                    <a:lstStyle/>
+                    <a:p>
+                      <a:endParaRPr lang="en-US" dirty="0"/>
+                    </a:p>
+                  </a:txBody>
+                  <a:tcPr/>
+                </a:tc>
+                <a:tc>
+                  <a:txBody>
+                    <a:bodyPr/>
+                    <a:lstStyle/>
+                    <a:p>
+                      <a:r>
+                        <a:rPr lang="en-US" dirty="0"/>
+                        <a:t>NO OPERATION, GO TO NEXT ADDRESS</a:t>
+                      </a:r>
+                    </a:p>
+                  </a:txBody>
+                  <a:tcPr/>
+                </a:tc>
+                <a:extLst>
+                  <a:ext uri="{0D108BD9-81ED-4DB2-BD59-A6C34878D82A}">
+                    <a16:rowId xmlns:a16="http://schemas.microsoft.com/office/drawing/2014/main" val="3006052280"/>
+                  </a:ext>
+                </a:extLst>
+              </a:tr>
+              <a:tr h="370840">
+                <a:tc>
+                  <a:txBody>
+                    <a:bodyPr/>
+                    <a:lstStyle/>
+                    <a:p>
+                      <a:r>
+                        <a:rPr lang="en-US" dirty="0"/>
+                        <a:t>DELAY</a:t>
+                      </a:r>
+                    </a:p>
+                  </a:txBody>
+                  <a:tcPr/>
+                </a:tc>
+                <a:tc>
+                  <a:txBody>
+                    <a:bodyPr/>
+                    <a:lstStyle/>
+                    <a:p>
+                      <a:r>
+                        <a:rPr lang="en-US" dirty="0"/>
+                        <a:t>0b0001</a:t>
+                      </a:r>
+                    </a:p>
+                  </a:txBody>
+                  <a:tcPr/>
+                </a:tc>
+                <a:tc>
+                  <a:txBody>
+                    <a:bodyPr/>
+                    <a:lstStyle/>
+                    <a:p>
+                      <a:r>
+                        <a:rPr lang="en-US" dirty="0"/>
+                        <a:t>1</a:t>
+                      </a:r>
+                    </a:p>
+                  </a:txBody>
+                  <a:tcPr/>
+                </a:tc>
+                <a:tc>
+                  <a:txBody>
+                    <a:bodyPr/>
+                    <a:lstStyle/>
+                    <a:p>
+                      <a:r>
+                        <a:rPr lang="en-US" dirty="0"/>
+                        <a:t>0 to 2</a:t>
+                      </a:r>
+                      <a:r>
+                        <a:rPr lang="en-US" baseline="30000" dirty="0"/>
+                        <a:t>32</a:t>
+                      </a:r>
+                      <a:r>
+                        <a:rPr lang="en-US" baseline="0" dirty="0"/>
+                        <a:t>-1</a:t>
+                      </a:r>
+                    </a:p>
+                  </a:txBody>
+                  <a:tcPr/>
+                </a:tc>
+                <a:tc>
+                  <a:txBody>
+                    <a:bodyPr/>
+                    <a:lstStyle/>
+                    <a:p>
+                      <a:r>
+                        <a:rPr lang="en-US" dirty="0"/>
+                        <a:t>NA</a:t>
+                      </a:r>
+                    </a:p>
+                  </a:txBody>
+                  <a:tcPr/>
+                </a:tc>
+                <a:tc>
+                  <a:txBody>
+                    <a:bodyPr/>
+                    <a:lstStyle/>
+                    <a:p>
+                      <a:r>
+                        <a:rPr lang="en-US" dirty="0"/>
+                        <a:t>WAIT DELAY CLOCK CYCLES</a:t>
+                      </a:r>
+                    </a:p>
+                  </a:txBody>
+                  <a:tcPr/>
+                </a:tc>
+                <a:extLst>
+                  <a:ext uri="{0D108BD9-81ED-4DB2-BD59-A6C34878D82A}">
+                    <a16:rowId xmlns:a16="http://schemas.microsoft.com/office/drawing/2014/main" val="3071420913"/>
+                  </a:ext>
+                </a:extLst>
+              </a:tr>
+              <a:tr h="370840">
+                <a:tc>
+                  <a:txBody>
+                    <a:bodyPr/>
+                    <a:lstStyle/>
+                    <a:p>
+                      <a:r>
+                        <a:rPr lang="en-US" dirty="0"/>
+                        <a:t>LONG DELAY</a:t>
+                      </a:r>
+                    </a:p>
+                  </a:txBody>
+                  <a:tcPr/>
+                </a:tc>
+                <a:tc>
+                  <a:txBody>
+                    <a:bodyPr/>
+                    <a:lstStyle/>
+                    <a:p>
+                      <a:r>
+                        <a:rPr lang="en-US" dirty="0"/>
+                        <a:t>0b0010</a:t>
+                      </a:r>
+                    </a:p>
+                  </a:txBody>
+                  <a:tcPr/>
+                </a:tc>
+                <a:tc>
+                  <a:txBody>
+                    <a:bodyPr/>
+                    <a:lstStyle/>
+                    <a:p>
+                      <a:r>
+                        <a:rPr lang="en-US" dirty="0"/>
+                        <a:t>2</a:t>
+                      </a:r>
+                    </a:p>
+                  </a:txBody>
+                  <a:tcPr/>
+                </a:tc>
+                <a:tc>
+                  <a:txBody>
+                    <a:bodyPr/>
+                    <a:lstStyle/>
+                    <a:p>
+                      <a:r>
+                        <a:rPr lang="en-US" dirty="0"/>
+                        <a:t>0 to 2</a:t>
+                      </a:r>
+                      <a:r>
+                        <a:rPr lang="en-US" baseline="30000" dirty="0"/>
+                        <a:t>32</a:t>
+                      </a:r>
+                      <a:r>
+                        <a:rPr lang="en-US" baseline="0" dirty="0"/>
+                        <a:t>-1</a:t>
+                      </a:r>
+                      <a:endParaRPr lang="en-US" dirty="0"/>
+                    </a:p>
+                  </a:txBody>
+                  <a:tcPr/>
+                </a:tc>
+                <a:tc>
+                  <a:txBody>
+                    <a:bodyPr/>
+                    <a:lstStyle/>
+                    <a:p>
+                      <a:pPr marL="0" marR="0" lvl="0" indent="0" algn="l" defTabSz="914400" rtl="0" eaLnBrk="1" fontAlgn="auto" latinLnBrk="0" hangingPunct="1">
+                        <a:lnSpc>
+                          <a:spcPct val="100000"/>
+                        </a:lnSpc>
+                        <a:spcBef>
+                          <a:spcPts val="0"/>
+                        </a:spcBef>
+                        <a:spcAft>
+                          <a:spcPts val="0"/>
+                        </a:spcAft>
+                        <a:buClrTx/>
+                        <a:buSzTx/>
+                        <a:buFontTx/>
+                        <a:buNone/>
+                        <a:tabLst/>
+                        <a:defRPr/>
+                      </a:pPr>
+                      <a:r>
+                        <a:rPr lang="en-US" dirty="0"/>
+                        <a:t>0 to 2</a:t>
+                      </a:r>
+                      <a:r>
+                        <a:rPr lang="en-US" baseline="30000" dirty="0"/>
+                        <a:t>20</a:t>
+                      </a:r>
+                      <a:r>
+                        <a:rPr lang="en-US" baseline="0" dirty="0"/>
+                        <a:t>-1</a:t>
+                      </a:r>
+                      <a:endParaRPr lang="en-US" dirty="0"/>
+                    </a:p>
+                    <a:p>
+                      <a:endParaRPr lang="en-US" dirty="0"/>
+                    </a:p>
+                  </a:txBody>
+                  <a:tcPr/>
+                </a:tc>
+                <a:tc>
+                  <a:txBody>
+                    <a:bodyPr/>
+                    <a:lstStyle/>
+                    <a:p>
+                      <a:r>
+                        <a:rPr lang="en-US" dirty="0"/>
+                        <a:t>WAIT DELAY * DATA CLOCK CYCLES</a:t>
+                      </a:r>
+                    </a:p>
+                  </a:txBody>
+                  <a:tcPr/>
+                </a:tc>
+                <a:extLst>
+                  <a:ext uri="{0D108BD9-81ED-4DB2-BD59-A6C34878D82A}">
+                    <a16:rowId xmlns:a16="http://schemas.microsoft.com/office/drawing/2014/main" val="3244617026"/>
+                  </a:ext>
+                </a:extLst>
+              </a:tr>
+              <a:tr h="370840">
+                <a:tc>
+                  <a:txBody>
+                    <a:bodyPr/>
+                    <a:lstStyle/>
+                    <a:p>
+                      <a:r>
+                        <a:rPr lang="en-US" dirty="0"/>
+                        <a:t>JUMP</a:t>
+                      </a:r>
+                    </a:p>
+                  </a:txBody>
+                  <a:tcPr/>
+                </a:tc>
+                <a:tc>
+                  <a:txBody>
+                    <a:bodyPr/>
+                    <a:lstStyle/>
+                    <a:p>
+                      <a:r>
+                        <a:rPr lang="en-US" dirty="0"/>
+                        <a:t>0b0011</a:t>
+                      </a:r>
+                    </a:p>
+                  </a:txBody>
+                  <a:tcPr/>
+                </a:tc>
+                <a:tc>
+                  <a:txBody>
+                    <a:bodyPr/>
+                    <a:lstStyle/>
+                    <a:p>
+                      <a:r>
+                        <a:rPr lang="en-US" dirty="0"/>
+                        <a:t>3</a:t>
+                      </a:r>
+                    </a:p>
+                  </a:txBody>
+                  <a:tcPr/>
+                </a:tc>
+                <a:tc>
+                  <a:txBody>
+                    <a:bodyPr/>
+                    <a:lstStyle/>
+                    <a:p>
+                      <a:r>
+                        <a:rPr lang="en-US" dirty="0"/>
+                        <a:t>NA</a:t>
+                      </a:r>
+                    </a:p>
+                  </a:txBody>
+                  <a:tcPr/>
+                </a:tc>
+                <a:tc>
+                  <a:txBody>
+                    <a:bodyPr/>
+                    <a:lstStyle/>
+                    <a:p>
+                      <a:r>
+                        <a:rPr lang="en-US" dirty="0"/>
+                        <a:t>ADDRESS</a:t>
+                      </a:r>
+                    </a:p>
+                  </a:txBody>
+                  <a:tcPr/>
+                </a:tc>
+                <a:tc>
+                  <a:txBody>
+                    <a:bodyPr/>
+                    <a:lstStyle/>
+                    <a:p>
+                      <a:r>
+                        <a:rPr lang="en-US" dirty="0"/>
+                        <a:t>JUMP TO ADDRESS</a:t>
+                      </a:r>
+                    </a:p>
+                  </a:txBody>
+                  <a:tcPr/>
+                </a:tc>
+                <a:extLst>
+                  <a:ext uri="{0D108BD9-81ED-4DB2-BD59-A6C34878D82A}">
+                    <a16:rowId xmlns:a16="http://schemas.microsoft.com/office/drawing/2014/main" val="3161441252"/>
+                  </a:ext>
+                </a:extLst>
+              </a:tr>
+              <a:tr h="370840">
+                <a:tc>
+                  <a:txBody>
+                    <a:bodyPr/>
+                    <a:lstStyle/>
+                    <a:p>
+                      <a:r>
+                        <a:rPr lang="en-US" dirty="0"/>
+                        <a:t>WAIT</a:t>
+                      </a:r>
+                    </a:p>
+                  </a:txBody>
+                  <a:tcPr/>
+                </a:tc>
+                <a:tc>
+                  <a:txBody>
+                    <a:bodyPr/>
+                    <a:lstStyle/>
+                    <a:p>
+                      <a:r>
+                        <a:rPr lang="en-US" dirty="0"/>
+                        <a:t>0b0100</a:t>
+                      </a:r>
+                    </a:p>
+                  </a:txBody>
+                  <a:tcPr/>
+                </a:tc>
+                <a:tc>
+                  <a:txBody>
+                    <a:bodyPr/>
+                    <a:lstStyle/>
+                    <a:p>
+                      <a:r>
+                        <a:rPr lang="en-US" dirty="0"/>
+                        <a:t>4</a:t>
+                      </a:r>
+                    </a:p>
+                  </a:txBody>
+                  <a:tcPr/>
+                </a:tc>
+                <a:tc>
+                  <a:txBody>
+                    <a:bodyPr/>
+                    <a:lstStyle/>
+                    <a:p>
+                      <a:r>
+                        <a:rPr lang="en-US" dirty="0"/>
+                        <a:t>NA</a:t>
+                      </a:r>
+                    </a:p>
+                  </a:txBody>
+                  <a:tcPr/>
+                </a:tc>
+                <a:tc>
+                  <a:txBody>
+                    <a:bodyPr/>
+                    <a:lstStyle/>
+                    <a:p>
+                      <a:r>
+                        <a:rPr lang="en-US" dirty="0"/>
+                        <a:t>NA</a:t>
+                      </a:r>
+                    </a:p>
+                  </a:txBody>
+                  <a:tcPr/>
+                </a:tc>
+                <a:tc>
+                  <a:txBody>
+                    <a:bodyPr/>
+                    <a:lstStyle/>
+                    <a:p>
+                      <a:r>
+                        <a:rPr lang="en-US" dirty="0"/>
+                        <a:t>WAIT FOR TIGGER SIGNAL (POS ENABLE)</a:t>
+                      </a:r>
+                    </a:p>
+                  </a:txBody>
+                  <a:tcPr/>
+                </a:tc>
+                <a:extLst>
+                  <a:ext uri="{0D108BD9-81ED-4DB2-BD59-A6C34878D82A}">
+                    <a16:rowId xmlns:a16="http://schemas.microsoft.com/office/drawing/2014/main" val="1157835799"/>
+                  </a:ext>
+                </a:extLst>
+              </a:tr>
+            </a:tbl>
+          </a:graphicData>
+        </a:graphic>
+      </p:graphicFrame>
     </p:spTree>
     <p:extLst>
       <p:ext uri="{BB962C8B-B14F-4D97-AF65-F5344CB8AC3E}">
-        <p14:creationId xmlns:p14="http://schemas.microsoft.com/office/powerpoint/2010/main" val="2842314208"/>
+        <p14:creationId xmlns:p14="http://schemas.microsoft.com/office/powerpoint/2010/main" val="4279889304"/>
       </p:ext>
     </p:extLst>
   </p:cSld>
@@ -3732,119 +4339,6 @@
           <p:cNvPr id="2" name="Title 1">
             <a:extLst>
               <a:ext uri="{FF2B5EF4-FFF2-40B4-BE49-F238E27FC236}">
-                <a16:creationId xmlns:a16="http://schemas.microsoft.com/office/drawing/2014/main" id="{45CAC404-D806-6C8D-A657-2B7AB09A4430}"/>
-              </a:ext>
-            </a:extLst>
-          </p:cNvPr>
-          <p:cNvSpPr>
-            <a:spLocks noGrp="1"/>
-          </p:cNvSpPr>
-          <p:nvPr>
-            <p:ph type="title"/>
-          </p:nvPr>
-        </p:nvSpPr>
-        <p:spPr/>
-        <p:txBody>
-          <a:bodyPr/>
-          <a:lstStyle/>
-          <a:p>
-            <a:r>
-              <a:rPr lang="en-US" dirty="0"/>
-              <a:t>Op Codes</a:t>
-            </a:r>
-          </a:p>
-        </p:txBody>
-      </p:sp>
-      <p:sp>
-        <p:nvSpPr>
-          <p:cNvPr id="3" name="Content Placeholder 2">
-            <a:extLst>
-              <a:ext uri="{FF2B5EF4-FFF2-40B4-BE49-F238E27FC236}">
-                <a16:creationId xmlns:a16="http://schemas.microsoft.com/office/drawing/2014/main" id="{C394C9DA-22D7-AB79-1A15-3A2ECD340413}"/>
-              </a:ext>
-            </a:extLst>
-          </p:cNvPr>
-          <p:cNvSpPr>
-            <a:spLocks noGrp="1"/>
-          </p:cNvSpPr>
-          <p:nvPr>
-            <p:ph idx="1"/>
-          </p:nvPr>
-        </p:nvSpPr>
-        <p:spPr/>
-        <p:txBody>
-          <a:bodyPr/>
-          <a:lstStyle/>
-          <a:p>
-            <a:r>
-              <a:rPr lang="en-US" dirty="0"/>
-              <a:t>0 = No OP</a:t>
-            </a:r>
-          </a:p>
-          <a:p>
-            <a:r>
-              <a:rPr lang="en-US" dirty="0"/>
-              <a:t>1 = DELAY</a:t>
-            </a:r>
-          </a:p>
-          <a:p>
-            <a:r>
-              <a:rPr lang="en-US" dirty="0"/>
-              <a:t>2 = LONG DELAY</a:t>
-            </a:r>
-          </a:p>
-          <a:p>
-            <a:r>
-              <a:rPr lang="en-US" dirty="0"/>
-              <a:t>3 = GOTO</a:t>
-            </a:r>
-          </a:p>
-          <a:p>
-            <a:r>
-              <a:rPr lang="en-US" dirty="0"/>
-              <a:t>4 = WAIT</a:t>
-            </a:r>
-          </a:p>
-          <a:p>
-            <a:endParaRPr lang="en-US" dirty="0"/>
-          </a:p>
-        </p:txBody>
-      </p:sp>
-    </p:spTree>
-    <p:extLst>
-      <p:ext uri="{BB962C8B-B14F-4D97-AF65-F5344CB8AC3E}">
-        <p14:creationId xmlns:p14="http://schemas.microsoft.com/office/powerpoint/2010/main" val="4279889304"/>
-      </p:ext>
-    </p:extLst>
-  </p:cSld>
-  <p:clrMapOvr>
-    <a:masterClrMapping/>
-  </p:clrMapOvr>
-</p:sld>
-</file>
-
-<file path=ppt/slides/slide5.xml><?xml version="1.0" encoding="utf-8"?>
-<p:sld xmlns:a="http://schemas.openxmlformats.org/drawingml/2006/main" xmlns:r="http://schemas.openxmlformats.org/officeDocument/2006/relationships" xmlns:p="http://schemas.openxmlformats.org/presentationml/2006/main">
-  <p:cSld>
-    <p:spTree>
-      <p:nvGrpSpPr>
-        <p:cNvPr id="1" name=""/>
-        <p:cNvGrpSpPr/>
-        <p:nvPr/>
-      </p:nvGrpSpPr>
-      <p:grpSpPr>
-        <a:xfrm>
-          <a:off x="0" y="0"/>
-          <a:ext cx="0" cy="0"/>
-          <a:chOff x="0" y="0"/>
-          <a:chExt cx="0" cy="0"/>
-        </a:xfrm>
-      </p:grpSpPr>
-      <p:sp>
-        <p:nvSpPr>
-          <p:cNvPr id="2" name="Title 1">
-            <a:extLst>
-              <a:ext uri="{FF2B5EF4-FFF2-40B4-BE49-F238E27FC236}">
                 <a16:creationId xmlns:a16="http://schemas.microsoft.com/office/drawing/2014/main" id="{8984A156-FE75-3D8F-9580-18E11DDB2DE3}"/>
               </a:ext>
             </a:extLst>
@@ -3951,10 +4445,9 @@
           <a:p>
             <a:pPr lvl="1"/>
             <a:r>
-              <a:rPr lang="en-US"/>
+              <a:rPr lang="en-US" dirty="0"/>
               <a:t>External Clock?</a:t>
             </a:r>
-            <a:endParaRPr lang="en-US" dirty="0"/>
           </a:p>
         </p:txBody>
       </p:sp>
@@ -4031,7 +4524,7 @@
 </p:sld>
 </file>
 
-<file path=ppt/slides/slide6.xml><?xml version="1.0" encoding="utf-8"?>
+<file path=ppt/slides/slide5.xml><?xml version="1.0" encoding="utf-8"?>
 <p:sld xmlns:a="http://schemas.openxmlformats.org/drawingml/2006/main" xmlns:r="http://schemas.openxmlformats.org/officeDocument/2006/relationships" xmlns:p="http://schemas.openxmlformats.org/presentationml/2006/main">
   <p:cSld>
     <p:spTree>
@@ -4099,19 +4592,26 @@
           <a:p>
             <a:r>
               <a:rPr lang="en-US" dirty="0"/>
-              <a:t>125 MHz clock</a:t>
+              <a:t>250 MHz clock</a:t>
             </a:r>
           </a:p>
           <a:p>
             <a:r>
               <a:rPr lang="en-US" dirty="0"/>
-              <a:t>8 ns resolution</a:t>
+              <a:t>4 ns resolution</a:t>
             </a:r>
           </a:p>
           <a:p>
             <a:r>
               <a:rPr lang="en-US" dirty="0"/>
-              <a:t>Minimum delay/pulse = 16 ns (2 clock cycles)</a:t>
+              <a:t>Minimum delay/pulse = 4 ns (1 clock cycles)</a:t>
+            </a:r>
+          </a:p>
+          <a:p>
+            <a:pPr lvl="1"/>
+            <a:r>
+              <a:rPr lang="en-US" dirty="0"/>
+              <a:t>TESTING REQUIRED</a:t>
             </a:r>
           </a:p>
           <a:p>
@@ -4161,7 +4661,7 @@
         </p:blipFill>
         <p:spPr>
           <a:xfrm>
-            <a:off x="1072429" y="4991259"/>
+            <a:off x="1062597" y="5376751"/>
             <a:ext cx="3677163" cy="800212"/>
           </a:xfrm>
           <a:prstGeom prst="rect">
@@ -4182,7 +4682,7 @@
 </p:sld>
 </file>
 
-<file path=ppt/slides/slide7.xml><?xml version="1.0" encoding="utf-8"?>
+<file path=ppt/slides/slide6.xml><?xml version="1.0" encoding="utf-8"?>
 <p:sld xmlns:a="http://schemas.openxmlformats.org/drawingml/2006/main" xmlns:r="http://schemas.openxmlformats.org/officeDocument/2006/relationships" xmlns:p="http://schemas.openxmlformats.org/presentationml/2006/main">
   <p:cSld>
     <p:spTree>
@@ -4374,6 +4874,199 @@
     <p:extLst>
       <p:ext uri="{BB962C8B-B14F-4D97-AF65-F5344CB8AC3E}">
         <p14:creationId xmlns:p14="http://schemas.microsoft.com/office/powerpoint/2010/main" val="1820235582"/>
+      </p:ext>
+    </p:extLst>
+  </p:cSld>
+  <p:clrMapOvr>
+    <a:masterClrMapping/>
+  </p:clrMapOvr>
+</p:sld>
+</file>
+
+<file path=ppt/slides/slide7.xml><?xml version="1.0" encoding="utf-8"?>
+<p:sld xmlns:a="http://schemas.openxmlformats.org/drawingml/2006/main" xmlns:r="http://schemas.openxmlformats.org/officeDocument/2006/relationships" xmlns:p="http://schemas.openxmlformats.org/presentationml/2006/main">
+  <p:cSld>
+    <p:spTree>
+      <p:nvGrpSpPr>
+        <p:cNvPr id="1" name="">
+          <a:extLst>
+            <a:ext uri="{FF2B5EF4-FFF2-40B4-BE49-F238E27FC236}">
+              <a16:creationId xmlns:a16="http://schemas.microsoft.com/office/drawing/2014/main" id="{8BEEC054-DD2A-EB4E-682E-AB080E885367}"/>
+            </a:ext>
+          </a:extLst>
+        </p:cNvPr>
+        <p:cNvGrpSpPr/>
+        <p:nvPr/>
+      </p:nvGrpSpPr>
+      <p:grpSpPr>
+        <a:xfrm>
+          <a:off x="0" y="0"/>
+          <a:ext cx="0" cy="0"/>
+          <a:chOff x="0" y="0"/>
+          <a:chExt cx="0" cy="0"/>
+        </a:xfrm>
+      </p:grpSpPr>
+      <p:sp>
+        <p:nvSpPr>
+          <p:cNvPr id="2" name="Title 1">
+            <a:extLst>
+              <a:ext uri="{FF2B5EF4-FFF2-40B4-BE49-F238E27FC236}">
+                <a16:creationId xmlns:a16="http://schemas.microsoft.com/office/drawing/2014/main" id="{52A3FB3F-242A-2982-140E-F63ACF6E10C4}"/>
+              </a:ext>
+            </a:extLst>
+          </p:cNvPr>
+          <p:cNvSpPr>
+            <a:spLocks noGrp="1"/>
+          </p:cNvSpPr>
+          <p:nvPr>
+            <p:ph type="title"/>
+          </p:nvPr>
+        </p:nvSpPr>
+        <p:spPr/>
+        <p:txBody>
+          <a:bodyPr/>
+          <a:lstStyle/>
+          <a:p>
+            <a:r>
+              <a:rPr lang="en-US" dirty="0"/>
+              <a:t>Programming Words (v1)</a:t>
+            </a:r>
+          </a:p>
+        </p:txBody>
+      </p:sp>
+      <p:sp>
+        <p:nvSpPr>
+          <p:cNvPr id="4" name="TextBox 3">
+            <a:extLst>
+              <a:ext uri="{FF2B5EF4-FFF2-40B4-BE49-F238E27FC236}">
+                <a16:creationId xmlns:a16="http://schemas.microsoft.com/office/drawing/2014/main" id="{C4988A63-7D86-337A-45C2-8FDE406C2480}"/>
+              </a:ext>
+            </a:extLst>
+          </p:cNvPr>
+          <p:cNvSpPr txBox="1"/>
+          <p:nvPr/>
+        </p:nvSpPr>
+        <p:spPr>
+          <a:xfrm>
+            <a:off x="454057" y="2967335"/>
+            <a:ext cx="11559619" cy="461665"/>
+          </a:xfrm>
+          <a:prstGeom prst="rect">
+            <a:avLst/>
+          </a:prstGeom>
+          <a:noFill/>
+        </p:spPr>
+        <p:txBody>
+          <a:bodyPr wrap="square" rtlCol="0">
+            <a:spAutoFit/>
+          </a:bodyPr>
+          <a:lstStyle/>
+          <a:p>
+            <a:r>
+              <a:rPr lang="en-US" sz="800" dirty="0"/>
+              <a:t>command	|	</a:t>
+            </a:r>
+            <a:r>
+              <a:rPr lang="en-US" sz="800" dirty="0" err="1"/>
+              <a:t>addr</a:t>
+            </a:r>
+            <a:r>
+              <a:rPr lang="en-US" sz="800" dirty="0"/>
+              <a:t>	|	pulse pattern	|	DDS 	|	data 	|	op code	|	delay</a:t>
+            </a:r>
+          </a:p>
+          <a:p>
+            <a:r>
+              <a:rPr lang="en-US" sz="800" dirty="0"/>
+              <a:t>4-bit	|	12-bit	|	8-bit	|	8-bit	|	12-bit 	|	4-bit	|	32-bit</a:t>
+            </a:r>
+          </a:p>
+          <a:p>
+            <a:r>
+              <a:rPr lang="en-US" sz="800" dirty="0"/>
+              <a:t>[79:76]	|	[75:64]	|	[63:56]	|	 [55:48] 	|	[47:36] 	|	[35:32]	|	[31:0]</a:t>
+            </a:r>
+          </a:p>
+        </p:txBody>
+      </p:sp>
+      <p:sp>
+        <p:nvSpPr>
+          <p:cNvPr id="3" name="TextBox 2">
+            <a:extLst>
+              <a:ext uri="{FF2B5EF4-FFF2-40B4-BE49-F238E27FC236}">
+                <a16:creationId xmlns:a16="http://schemas.microsoft.com/office/drawing/2014/main" id="{3595C6AF-0AA8-0F1E-E826-71D7A8E5D015}"/>
+              </a:ext>
+            </a:extLst>
+          </p:cNvPr>
+          <p:cNvSpPr txBox="1"/>
+          <p:nvPr/>
+        </p:nvSpPr>
+        <p:spPr>
+          <a:xfrm>
+            <a:off x="3321522" y="1959679"/>
+            <a:ext cx="5548955" cy="369332"/>
+          </a:xfrm>
+          <a:prstGeom prst="rect">
+            <a:avLst/>
+          </a:prstGeom>
+          <a:noFill/>
+        </p:spPr>
+        <p:txBody>
+          <a:bodyPr wrap="none" rtlCol="0">
+            <a:spAutoFit/>
+          </a:bodyPr>
+          <a:lstStyle/>
+          <a:p>
+            <a:r>
+              <a:rPr lang="en-US" dirty="0"/>
+              <a:t>Need at least 12-bit data for address in GOTO op-code</a:t>
+            </a:r>
+          </a:p>
+        </p:txBody>
+      </p:sp>
+      <p:sp>
+        <p:nvSpPr>
+          <p:cNvPr id="5" name="TextBox 4">
+            <a:extLst>
+              <a:ext uri="{FF2B5EF4-FFF2-40B4-BE49-F238E27FC236}">
+                <a16:creationId xmlns:a16="http://schemas.microsoft.com/office/drawing/2014/main" id="{BE9AE51F-606F-EEE7-FA4C-52F64F031B79}"/>
+              </a:ext>
+            </a:extLst>
+          </p:cNvPr>
+          <p:cNvSpPr txBox="1"/>
+          <p:nvPr/>
+        </p:nvSpPr>
+        <p:spPr>
+          <a:xfrm>
+            <a:off x="3728725" y="2813446"/>
+            <a:ext cx="5010282" cy="769441"/>
+          </a:xfrm>
+          <a:prstGeom prst="rect">
+            <a:avLst/>
+          </a:prstGeom>
+          <a:noFill/>
+        </p:spPr>
+        <p:txBody>
+          <a:bodyPr wrap="none" rtlCol="0">
+            <a:spAutoFit/>
+          </a:bodyPr>
+          <a:lstStyle/>
+          <a:p>
+            <a:r>
+              <a:rPr lang="en-US" sz="4400" dirty="0">
+                <a:solidFill>
+                  <a:srgbClr val="FF0000"/>
+                </a:solidFill>
+              </a:rPr>
+              <a:t>NOT IMPLEMENTED</a:t>
+            </a:r>
+          </a:p>
+        </p:txBody>
+      </p:sp>
+    </p:spTree>
+    <p:extLst>
+      <p:ext uri="{BB962C8B-B14F-4D97-AF65-F5344CB8AC3E}">
+        <p14:creationId xmlns:p14="http://schemas.microsoft.com/office/powerpoint/2010/main" val="2842314208"/>
       </p:ext>
     </p:extLst>
   </p:cSld>

</xml_diff>

<commit_message>
Adding JUMP op code to pulse programmer
</commit_message>
<xml_diff>
--- a/Documentation/Pulse Programmer Documentation.pptx
+++ b/Documentation/Pulse Programmer Documentation.pptx
@@ -11,7 +11,10 @@
     <p:sldId id="262" r:id="rId5"/>
     <p:sldId id="258" r:id="rId6"/>
     <p:sldId id="263" r:id="rId7"/>
-    <p:sldId id="260" r:id="rId8"/>
+    <p:sldId id="266" r:id="rId8"/>
+    <p:sldId id="264" r:id="rId9"/>
+    <p:sldId id="265" r:id="rId10"/>
+    <p:sldId id="260" r:id="rId11"/>
   </p:sldIdLst>
   <p:sldSz cx="12192000" cy="6858000"/>
   <p:notesSz cx="6858000" cy="9144000"/>
@@ -3442,6 +3445,199 @@
     <p:extLst>
       <p:ext uri="{BB962C8B-B14F-4D97-AF65-F5344CB8AC3E}">
         <p14:creationId xmlns:p14="http://schemas.microsoft.com/office/powerpoint/2010/main" val="3877000392"/>
+      </p:ext>
+    </p:extLst>
+  </p:cSld>
+  <p:clrMapOvr>
+    <a:masterClrMapping/>
+  </p:clrMapOvr>
+</p:sld>
+</file>
+
+<file path=ppt/slides/slide10.xml><?xml version="1.0" encoding="utf-8"?>
+<p:sld xmlns:a="http://schemas.openxmlformats.org/drawingml/2006/main" xmlns:r="http://schemas.openxmlformats.org/officeDocument/2006/relationships" xmlns:p="http://schemas.openxmlformats.org/presentationml/2006/main">
+  <p:cSld>
+    <p:spTree>
+      <p:nvGrpSpPr>
+        <p:cNvPr id="1" name="">
+          <a:extLst>
+            <a:ext uri="{FF2B5EF4-FFF2-40B4-BE49-F238E27FC236}">
+              <a16:creationId xmlns:a16="http://schemas.microsoft.com/office/drawing/2014/main" id="{8BEEC054-DD2A-EB4E-682E-AB080E885367}"/>
+            </a:ext>
+          </a:extLst>
+        </p:cNvPr>
+        <p:cNvGrpSpPr/>
+        <p:nvPr/>
+      </p:nvGrpSpPr>
+      <p:grpSpPr>
+        <a:xfrm>
+          <a:off x="0" y="0"/>
+          <a:ext cx="0" cy="0"/>
+          <a:chOff x="0" y="0"/>
+          <a:chExt cx="0" cy="0"/>
+        </a:xfrm>
+      </p:grpSpPr>
+      <p:sp>
+        <p:nvSpPr>
+          <p:cNvPr id="2" name="Title 1">
+            <a:extLst>
+              <a:ext uri="{FF2B5EF4-FFF2-40B4-BE49-F238E27FC236}">
+                <a16:creationId xmlns:a16="http://schemas.microsoft.com/office/drawing/2014/main" id="{52A3FB3F-242A-2982-140E-F63ACF6E10C4}"/>
+              </a:ext>
+            </a:extLst>
+          </p:cNvPr>
+          <p:cNvSpPr>
+            <a:spLocks noGrp="1"/>
+          </p:cNvSpPr>
+          <p:nvPr>
+            <p:ph type="title"/>
+          </p:nvPr>
+        </p:nvSpPr>
+        <p:spPr/>
+        <p:txBody>
+          <a:bodyPr/>
+          <a:lstStyle/>
+          <a:p>
+            <a:r>
+              <a:rPr lang="en-US" dirty="0"/>
+              <a:t>Programming Words (v1)</a:t>
+            </a:r>
+          </a:p>
+        </p:txBody>
+      </p:sp>
+      <p:sp>
+        <p:nvSpPr>
+          <p:cNvPr id="4" name="TextBox 3">
+            <a:extLst>
+              <a:ext uri="{FF2B5EF4-FFF2-40B4-BE49-F238E27FC236}">
+                <a16:creationId xmlns:a16="http://schemas.microsoft.com/office/drawing/2014/main" id="{C4988A63-7D86-337A-45C2-8FDE406C2480}"/>
+              </a:ext>
+            </a:extLst>
+          </p:cNvPr>
+          <p:cNvSpPr txBox="1"/>
+          <p:nvPr/>
+        </p:nvSpPr>
+        <p:spPr>
+          <a:xfrm>
+            <a:off x="454057" y="2967335"/>
+            <a:ext cx="11559619" cy="461665"/>
+          </a:xfrm>
+          <a:prstGeom prst="rect">
+            <a:avLst/>
+          </a:prstGeom>
+          <a:noFill/>
+        </p:spPr>
+        <p:txBody>
+          <a:bodyPr wrap="square" rtlCol="0">
+            <a:spAutoFit/>
+          </a:bodyPr>
+          <a:lstStyle/>
+          <a:p>
+            <a:r>
+              <a:rPr lang="en-US" sz="800" dirty="0"/>
+              <a:t>command	|	</a:t>
+            </a:r>
+            <a:r>
+              <a:rPr lang="en-US" sz="800" dirty="0" err="1"/>
+              <a:t>addr</a:t>
+            </a:r>
+            <a:r>
+              <a:rPr lang="en-US" sz="800" dirty="0"/>
+              <a:t>	|	pulse pattern	|	DDS 	|	data 	|	op code	|	delay</a:t>
+            </a:r>
+          </a:p>
+          <a:p>
+            <a:r>
+              <a:rPr lang="en-US" sz="800" dirty="0"/>
+              <a:t>4-bit	|	12-bit	|	8-bit	|	8-bit	|	12-bit 	|	4-bit	|	32-bit</a:t>
+            </a:r>
+          </a:p>
+          <a:p>
+            <a:r>
+              <a:rPr lang="en-US" sz="800" dirty="0"/>
+              <a:t>[79:76]	|	[75:64]	|	[63:56]	|	 [55:48] 	|	[47:36] 	|	[35:32]	|	[31:0]</a:t>
+            </a:r>
+          </a:p>
+        </p:txBody>
+      </p:sp>
+      <p:sp>
+        <p:nvSpPr>
+          <p:cNvPr id="3" name="TextBox 2">
+            <a:extLst>
+              <a:ext uri="{FF2B5EF4-FFF2-40B4-BE49-F238E27FC236}">
+                <a16:creationId xmlns:a16="http://schemas.microsoft.com/office/drawing/2014/main" id="{3595C6AF-0AA8-0F1E-E826-71D7A8E5D015}"/>
+              </a:ext>
+            </a:extLst>
+          </p:cNvPr>
+          <p:cNvSpPr txBox="1"/>
+          <p:nvPr/>
+        </p:nvSpPr>
+        <p:spPr>
+          <a:xfrm>
+            <a:off x="3321522" y="1959679"/>
+            <a:ext cx="5548955" cy="369332"/>
+          </a:xfrm>
+          <a:prstGeom prst="rect">
+            <a:avLst/>
+          </a:prstGeom>
+          <a:noFill/>
+        </p:spPr>
+        <p:txBody>
+          <a:bodyPr wrap="none" rtlCol="0">
+            <a:spAutoFit/>
+          </a:bodyPr>
+          <a:lstStyle/>
+          <a:p>
+            <a:r>
+              <a:rPr lang="en-US" dirty="0"/>
+              <a:t>Need at least 12-bit data for address in GOTO op-code</a:t>
+            </a:r>
+          </a:p>
+        </p:txBody>
+      </p:sp>
+      <p:sp>
+        <p:nvSpPr>
+          <p:cNvPr id="5" name="TextBox 4">
+            <a:extLst>
+              <a:ext uri="{FF2B5EF4-FFF2-40B4-BE49-F238E27FC236}">
+                <a16:creationId xmlns:a16="http://schemas.microsoft.com/office/drawing/2014/main" id="{BE9AE51F-606F-EEE7-FA4C-52F64F031B79}"/>
+              </a:ext>
+            </a:extLst>
+          </p:cNvPr>
+          <p:cNvSpPr txBox="1"/>
+          <p:nvPr/>
+        </p:nvSpPr>
+        <p:spPr>
+          <a:xfrm>
+            <a:off x="3728725" y="2813446"/>
+            <a:ext cx="5010282" cy="769441"/>
+          </a:xfrm>
+          <a:prstGeom prst="rect">
+            <a:avLst/>
+          </a:prstGeom>
+          <a:noFill/>
+        </p:spPr>
+        <p:txBody>
+          <a:bodyPr wrap="none" rtlCol="0">
+            <a:spAutoFit/>
+          </a:bodyPr>
+          <a:lstStyle/>
+          <a:p>
+            <a:r>
+              <a:rPr lang="en-US" sz="4400" dirty="0">
+                <a:solidFill>
+                  <a:srgbClr val="FF0000"/>
+                </a:solidFill>
+              </a:rPr>
+              <a:t>NOT IMPLEMENTED</a:t>
+            </a:r>
+          </a:p>
+        </p:txBody>
+      </p:sp>
+    </p:spTree>
+    <p:extLst>
+      <p:ext uri="{BB962C8B-B14F-4D97-AF65-F5344CB8AC3E}">
+        <p14:creationId xmlns:p14="http://schemas.microsoft.com/office/powerpoint/2010/main" val="2842314208"/>
       </p:ext>
     </p:extLst>
   </p:cSld>
@@ -4888,13 +5084,7 @@
   <p:cSld>
     <p:spTree>
       <p:nvGrpSpPr>
-        <p:cNvPr id="1" name="">
-          <a:extLst>
-            <a:ext uri="{FF2B5EF4-FFF2-40B4-BE49-F238E27FC236}">
-              <a16:creationId xmlns:a16="http://schemas.microsoft.com/office/drawing/2014/main" id="{8BEEC054-DD2A-EB4E-682E-AB080E885367}"/>
-            </a:ext>
-          </a:extLst>
-        </p:cNvPr>
+        <p:cNvPr id="1" name=""/>
         <p:cNvGrpSpPr/>
         <p:nvPr/>
       </p:nvGrpSpPr>
@@ -4911,7 +5101,7 @@
           <p:cNvPr id="2" name="Title 1">
             <a:extLst>
               <a:ext uri="{FF2B5EF4-FFF2-40B4-BE49-F238E27FC236}">
-                <a16:creationId xmlns:a16="http://schemas.microsoft.com/office/drawing/2014/main" id="{52A3FB3F-242A-2982-140E-F63ACF6E10C4}"/>
+                <a16:creationId xmlns:a16="http://schemas.microsoft.com/office/drawing/2014/main" id="{BD5D0770-C4F4-F98C-EC6D-F569008110B1}"/>
               </a:ext>
             </a:extLst>
           </p:cNvPr>
@@ -4929,17 +5119,174 @@
           <a:p>
             <a:r>
               <a:rPr lang="en-US" dirty="0"/>
-              <a:t>Programming Words (v1)</a:t>
-            </a:r>
-          </a:p>
-        </p:txBody>
-      </p:sp>
-      <p:sp>
-        <p:nvSpPr>
-          <p:cNvPr id="4" name="TextBox 3">
-            <a:extLst>
-              <a:ext uri="{FF2B5EF4-FFF2-40B4-BE49-F238E27FC236}">
-                <a16:creationId xmlns:a16="http://schemas.microsoft.com/office/drawing/2014/main" id="{C4988A63-7D86-337A-45C2-8FDE406C2480}"/>
+              <a:t>Programming Device (Development)</a:t>
+            </a:r>
+          </a:p>
+        </p:txBody>
+      </p:sp>
+      <p:pic>
+        <p:nvPicPr>
+          <p:cNvPr id="5" name="Content Placeholder 4">
+            <a:extLst>
+              <a:ext uri="{FF2B5EF4-FFF2-40B4-BE49-F238E27FC236}">
+                <a16:creationId xmlns:a16="http://schemas.microsoft.com/office/drawing/2014/main" id="{E6F1FBF8-C3D5-DCD9-E821-AAB9247DA208}"/>
+              </a:ext>
+            </a:extLst>
+          </p:cNvPr>
+          <p:cNvPicPr>
+            <a:picLocks noGrp="1" noChangeAspect="1"/>
+          </p:cNvPicPr>
+          <p:nvPr>
+            <p:ph idx="1"/>
+          </p:nvPr>
+        </p:nvPicPr>
+        <p:blipFill>
+          <a:blip r:embed="rId2"/>
+          <a:stretch>
+            <a:fillRect/>
+          </a:stretch>
+        </p:blipFill>
+        <p:spPr>
+          <a:xfrm>
+            <a:off x="666281" y="3330563"/>
+            <a:ext cx="2305372" cy="2010056"/>
+          </a:xfrm>
+          <a:prstGeom prst="rect">
+            <a:avLst/>
+          </a:prstGeom>
+        </p:spPr>
+      </p:pic>
+      <p:pic>
+        <p:nvPicPr>
+          <p:cNvPr id="7" name="Picture 6">
+            <a:extLst>
+              <a:ext uri="{FF2B5EF4-FFF2-40B4-BE49-F238E27FC236}">
+                <a16:creationId xmlns:a16="http://schemas.microsoft.com/office/drawing/2014/main" id="{2D3EB675-C311-DA5F-2496-E472B810AE23}"/>
+              </a:ext>
+            </a:extLst>
+          </p:cNvPr>
+          <p:cNvPicPr>
+            <a:picLocks noChangeAspect="1"/>
+          </p:cNvPicPr>
+          <p:nvPr/>
+        </p:nvPicPr>
+        <p:blipFill>
+          <a:blip r:embed="rId3"/>
+          <a:stretch>
+            <a:fillRect/>
+          </a:stretch>
+        </p:blipFill>
+        <p:spPr>
+          <a:xfrm>
+            <a:off x="3450527" y="1988911"/>
+            <a:ext cx="8535591" cy="4001058"/>
+          </a:xfrm>
+          <a:prstGeom prst="rect">
+            <a:avLst/>
+          </a:prstGeom>
+        </p:spPr>
+      </p:pic>
+    </p:spTree>
+    <p:extLst>
+      <p:ext uri="{BB962C8B-B14F-4D97-AF65-F5344CB8AC3E}">
+        <p14:creationId xmlns:p14="http://schemas.microsoft.com/office/powerpoint/2010/main" val="3148821995"/>
+      </p:ext>
+    </p:extLst>
+  </p:cSld>
+  <p:clrMapOvr>
+    <a:masterClrMapping/>
+  </p:clrMapOvr>
+</p:sld>
+</file>
+
+<file path=ppt/slides/slide8.xml><?xml version="1.0" encoding="utf-8"?>
+<p:sld xmlns:a="http://schemas.openxmlformats.org/drawingml/2006/main" xmlns:r="http://schemas.openxmlformats.org/officeDocument/2006/relationships" xmlns:p="http://schemas.openxmlformats.org/presentationml/2006/main">
+  <p:cSld>
+    <p:spTree>
+      <p:nvGrpSpPr>
+        <p:cNvPr id="1" name=""/>
+        <p:cNvGrpSpPr/>
+        <p:nvPr/>
+      </p:nvGrpSpPr>
+      <p:grpSpPr>
+        <a:xfrm>
+          <a:off x="0" y="0"/>
+          <a:ext cx="0" cy="0"/>
+          <a:chOff x="0" y="0"/>
+          <a:chExt cx="0" cy="0"/>
+        </a:xfrm>
+      </p:grpSpPr>
+      <p:sp>
+        <p:nvSpPr>
+          <p:cNvPr id="2" name="Title 1">
+            <a:extLst>
+              <a:ext uri="{FF2B5EF4-FFF2-40B4-BE49-F238E27FC236}">
+                <a16:creationId xmlns:a16="http://schemas.microsoft.com/office/drawing/2014/main" id="{AE7EDC0B-7999-44C2-69A7-DD2F09BD0728}"/>
+              </a:ext>
+            </a:extLst>
+          </p:cNvPr>
+          <p:cNvSpPr>
+            <a:spLocks noGrp="1"/>
+          </p:cNvSpPr>
+          <p:nvPr>
+            <p:ph type="title"/>
+          </p:nvPr>
+        </p:nvSpPr>
+        <p:spPr/>
+        <p:txBody>
+          <a:bodyPr/>
+          <a:lstStyle/>
+          <a:p>
+            <a:r>
+              <a:rPr lang="en-US" dirty="0"/>
+              <a:t>Creating Memory Config in </a:t>
+            </a:r>
+            <a:r>
+              <a:rPr lang="en-US" dirty="0" err="1"/>
+              <a:t>Vivado</a:t>
+            </a:r>
+            <a:endParaRPr lang="en-US" dirty="0"/>
+          </a:p>
+        </p:txBody>
+      </p:sp>
+      <p:pic>
+        <p:nvPicPr>
+          <p:cNvPr id="5" name="Content Placeholder 4">
+            <a:extLst>
+              <a:ext uri="{FF2B5EF4-FFF2-40B4-BE49-F238E27FC236}">
+                <a16:creationId xmlns:a16="http://schemas.microsoft.com/office/drawing/2014/main" id="{FBEF7FE2-2519-C2B5-8733-E223665C4BFE}"/>
+              </a:ext>
+            </a:extLst>
+          </p:cNvPr>
+          <p:cNvPicPr>
+            <a:picLocks noGrp="1" noChangeAspect="1"/>
+          </p:cNvPicPr>
+          <p:nvPr>
+            <p:ph idx="1"/>
+          </p:nvPr>
+        </p:nvPicPr>
+        <p:blipFill>
+          <a:blip r:embed="rId2"/>
+          <a:stretch>
+            <a:fillRect/>
+          </a:stretch>
+        </p:blipFill>
+        <p:spPr>
+          <a:xfrm>
+            <a:off x="1448316" y="2141537"/>
+            <a:ext cx="9295367" cy="4351338"/>
+          </a:xfrm>
+          <a:prstGeom prst="rect">
+            <a:avLst/>
+          </a:prstGeom>
+        </p:spPr>
+      </p:pic>
+      <p:sp>
+        <p:nvSpPr>
+          <p:cNvPr id="6" name="TextBox 5">
+            <a:extLst>
+              <a:ext uri="{FF2B5EF4-FFF2-40B4-BE49-F238E27FC236}">
+                <a16:creationId xmlns:a16="http://schemas.microsoft.com/office/drawing/2014/main" id="{E9A6F9EE-D96F-38FD-6B4E-5F6BC82E69D5}"/>
               </a:ext>
             </a:extLst>
           </p:cNvPr>
@@ -4948,8 +5295,8 @@
         </p:nvSpPr>
         <p:spPr>
           <a:xfrm>
-            <a:off x="454057" y="2967335"/>
-            <a:ext cx="11559619" cy="461665"/>
+            <a:off x="1219200" y="1514168"/>
+            <a:ext cx="4576317" cy="369332"/>
           </a:xfrm>
           <a:prstGeom prst="rect">
             <a:avLst/>
@@ -4957,116 +5304,142 @@
           <a:noFill/>
         </p:spPr>
         <p:txBody>
-          <a:bodyPr wrap="square" rtlCol="0">
+          <a:bodyPr wrap="none" rtlCol="0">
             <a:spAutoFit/>
           </a:bodyPr>
           <a:lstStyle/>
           <a:p>
             <a:r>
-              <a:rPr lang="en-US" sz="800" dirty="0"/>
-              <a:t>command	|	</a:t>
-            </a:r>
-            <a:r>
-              <a:rPr lang="en-US" sz="800" dirty="0" err="1"/>
-              <a:t>addr</a:t>
-            </a:r>
-            <a:r>
-              <a:rPr lang="en-US" sz="800" dirty="0"/>
-              <a:t>	|	pulse pattern	|	DDS 	|	data 	|	op code	|	delay</a:t>
-            </a:r>
-          </a:p>
-          <a:p>
-            <a:r>
-              <a:rPr lang="en-US" sz="800" dirty="0"/>
-              <a:t>4-bit	|	12-bit	|	8-bit	|	8-bit	|	12-bit 	|	4-bit	|	32-bit</a:t>
-            </a:r>
-          </a:p>
-          <a:p>
-            <a:r>
-              <a:rPr lang="en-US" sz="800" dirty="0"/>
-              <a:t>[79:76]	|	[75:64]	|	[63:56]	|	 [55:48] 	|	[47:36] 	|	[35:32]	|	[31:0]</a:t>
-            </a:r>
-          </a:p>
-        </p:txBody>
-      </p:sp>
-      <p:sp>
-        <p:nvSpPr>
-          <p:cNvPr id="3" name="TextBox 2">
-            <a:extLst>
-              <a:ext uri="{FF2B5EF4-FFF2-40B4-BE49-F238E27FC236}">
-                <a16:creationId xmlns:a16="http://schemas.microsoft.com/office/drawing/2014/main" id="{3595C6AF-0AA8-0F1E-E826-71D7A8E5D015}"/>
-              </a:ext>
-            </a:extLst>
-          </p:cNvPr>
-          <p:cNvSpPr txBox="1"/>
-          <p:nvPr/>
-        </p:nvSpPr>
+              <a:rPr lang="en-US" dirty="0"/>
+              <a:t>Tools -&gt; Generate Memory Configuration File</a:t>
+            </a:r>
+          </a:p>
+        </p:txBody>
+      </p:sp>
+    </p:spTree>
+    <p:extLst>
+      <p:ext uri="{BB962C8B-B14F-4D97-AF65-F5344CB8AC3E}">
+        <p14:creationId xmlns:p14="http://schemas.microsoft.com/office/powerpoint/2010/main" val="1146547650"/>
+      </p:ext>
+    </p:extLst>
+  </p:cSld>
+  <p:clrMapOvr>
+    <a:masterClrMapping/>
+  </p:clrMapOvr>
+</p:sld>
+</file>
+
+<file path=ppt/slides/slide9.xml><?xml version="1.0" encoding="utf-8"?>
+<p:sld xmlns:a="http://schemas.openxmlformats.org/drawingml/2006/main" xmlns:r="http://schemas.openxmlformats.org/officeDocument/2006/relationships" xmlns:p="http://schemas.openxmlformats.org/presentationml/2006/main">
+  <p:cSld>
+    <p:spTree>
+      <p:nvGrpSpPr>
+        <p:cNvPr id="1" name=""/>
+        <p:cNvGrpSpPr/>
+        <p:nvPr/>
+      </p:nvGrpSpPr>
+      <p:grpSpPr>
+        <a:xfrm>
+          <a:off x="0" y="0"/>
+          <a:ext cx="0" cy="0"/>
+          <a:chOff x="0" y="0"/>
+          <a:chExt cx="0" cy="0"/>
+        </a:xfrm>
+      </p:grpSpPr>
+      <p:sp>
+        <p:nvSpPr>
+          <p:cNvPr id="2" name="Title 1">
+            <a:extLst>
+              <a:ext uri="{FF2B5EF4-FFF2-40B4-BE49-F238E27FC236}">
+                <a16:creationId xmlns:a16="http://schemas.microsoft.com/office/drawing/2014/main" id="{5FBF23FC-361E-3111-2F16-8D4660CC4FD7}"/>
+              </a:ext>
+            </a:extLst>
+          </p:cNvPr>
+          <p:cNvSpPr>
+            <a:spLocks noGrp="1"/>
+          </p:cNvSpPr>
+          <p:nvPr>
+            <p:ph type="title"/>
+          </p:nvPr>
+        </p:nvSpPr>
+        <p:spPr/>
+        <p:txBody>
+          <a:bodyPr/>
+          <a:lstStyle/>
+          <a:p>
+            <a:r>
+              <a:rPr lang="en-US" dirty="0"/>
+              <a:t>Writing Memory Configuration</a:t>
+            </a:r>
+          </a:p>
+        </p:txBody>
+      </p:sp>
+      <p:pic>
+        <p:nvPicPr>
+          <p:cNvPr id="5" name="Content Placeholder 4">
+            <a:extLst>
+              <a:ext uri="{FF2B5EF4-FFF2-40B4-BE49-F238E27FC236}">
+                <a16:creationId xmlns:a16="http://schemas.microsoft.com/office/drawing/2014/main" id="{32F04DB4-F764-86EA-9211-116ADB5AADFB}"/>
+              </a:ext>
+            </a:extLst>
+          </p:cNvPr>
+          <p:cNvPicPr>
+            <a:picLocks noGrp="1" noChangeAspect="1"/>
+          </p:cNvPicPr>
+          <p:nvPr>
+            <p:ph idx="1"/>
+          </p:nvPr>
+        </p:nvPicPr>
+        <p:blipFill>
+          <a:blip r:embed="rId2"/>
+          <a:stretch>
+            <a:fillRect/>
+          </a:stretch>
+        </p:blipFill>
         <p:spPr>
           <a:xfrm>
-            <a:off x="3321522" y="1959679"/>
-            <a:ext cx="5548955" cy="369332"/>
+            <a:off x="4992918" y="2141537"/>
+            <a:ext cx="6571688" cy="4351338"/>
           </a:xfrm>
           <a:prstGeom prst="rect">
             <a:avLst/>
           </a:prstGeom>
-          <a:noFill/>
         </p:spPr>
-        <p:txBody>
-          <a:bodyPr wrap="none" rtlCol="0">
-            <a:spAutoFit/>
-          </a:bodyPr>
-          <a:lstStyle/>
-          <a:p>
-            <a:r>
-              <a:rPr lang="en-US" dirty="0"/>
-              <a:t>Need at least 12-bit data for address in GOTO op-code</a:t>
-            </a:r>
-          </a:p>
-        </p:txBody>
-      </p:sp>
-      <p:sp>
-        <p:nvSpPr>
-          <p:cNvPr id="5" name="TextBox 4">
-            <a:extLst>
-              <a:ext uri="{FF2B5EF4-FFF2-40B4-BE49-F238E27FC236}">
-                <a16:creationId xmlns:a16="http://schemas.microsoft.com/office/drawing/2014/main" id="{BE9AE51F-606F-EEE7-FA4C-52F64F031B79}"/>
-              </a:ext>
-            </a:extLst>
-          </p:cNvPr>
-          <p:cNvSpPr txBox="1"/>
+      </p:pic>
+      <p:pic>
+        <p:nvPicPr>
+          <p:cNvPr id="7" name="Picture 6">
+            <a:extLst>
+              <a:ext uri="{FF2B5EF4-FFF2-40B4-BE49-F238E27FC236}">
+                <a16:creationId xmlns:a16="http://schemas.microsoft.com/office/drawing/2014/main" id="{D29B073B-D39B-37AC-D41B-27B6B94DC3E0}"/>
+              </a:ext>
+            </a:extLst>
+          </p:cNvPr>
+          <p:cNvPicPr>
+            <a:picLocks noChangeAspect="1"/>
+          </p:cNvPicPr>
           <p:nvPr/>
-        </p:nvSpPr>
+        </p:nvPicPr>
+        <p:blipFill>
+          <a:blip r:embed="rId3"/>
+          <a:stretch>
+            <a:fillRect/>
+          </a:stretch>
+        </p:blipFill>
         <p:spPr>
           <a:xfrm>
-            <a:off x="3728725" y="2813446"/>
-            <a:ext cx="5010282" cy="769441"/>
+            <a:off x="237656" y="2141537"/>
+            <a:ext cx="3559256" cy="2779145"/>
           </a:xfrm>
           <a:prstGeom prst="rect">
             <a:avLst/>
           </a:prstGeom>
-          <a:noFill/>
         </p:spPr>
-        <p:txBody>
-          <a:bodyPr wrap="none" rtlCol="0">
-            <a:spAutoFit/>
-          </a:bodyPr>
-          <a:lstStyle/>
-          <a:p>
-            <a:r>
-              <a:rPr lang="en-US" sz="4400" dirty="0">
-                <a:solidFill>
-                  <a:srgbClr val="FF0000"/>
-                </a:solidFill>
-              </a:rPr>
-              <a:t>NOT IMPLEMENTED</a:t>
-            </a:r>
-          </a:p>
-        </p:txBody>
-      </p:sp>
+      </p:pic>
     </p:spTree>
     <p:extLst>
       <p:ext uri="{BB962C8B-B14F-4D97-AF65-F5344CB8AC3E}">
-        <p14:creationId xmlns:p14="http://schemas.microsoft.com/office/powerpoint/2010/main" val="2842314208"/>
+        <p14:creationId xmlns:p14="http://schemas.microsoft.com/office/powerpoint/2010/main" val="2170002627"/>
       </p:ext>
     </p:extLst>
   </p:cSld>

</xml_diff>

<commit_message>
Changing clock to 125 MHz
</commit_message>
<xml_diff>
--- a/Documentation/Pulse Programmer Documentation.pptx
+++ b/Documentation/Pulse Programmer Documentation.pptx
@@ -7,14 +7,14 @@
   <p:sldIdLst>
     <p:sldId id="256" r:id="rId2"/>
     <p:sldId id="257" r:id="rId3"/>
-    <p:sldId id="261" r:id="rId4"/>
-    <p:sldId id="262" r:id="rId5"/>
-    <p:sldId id="258" r:id="rId6"/>
-    <p:sldId id="263" r:id="rId7"/>
-    <p:sldId id="266" r:id="rId8"/>
-    <p:sldId id="264" r:id="rId9"/>
-    <p:sldId id="265" r:id="rId10"/>
-    <p:sldId id="260" r:id="rId11"/>
+    <p:sldId id="258" r:id="rId4"/>
+    <p:sldId id="259" r:id="rId5"/>
+    <p:sldId id="260" r:id="rId6"/>
+    <p:sldId id="261" r:id="rId7"/>
+    <p:sldId id="262" r:id="rId8"/>
+    <p:sldId id="263" r:id="rId9"/>
+    <p:sldId id="264" r:id="rId10"/>
+    <p:sldId id="265" r:id="rId11"/>
   </p:sldIdLst>
   <p:sldSz cx="12192000" cy="6858000"/>
   <p:notesSz cx="6858000" cy="9144000"/>
@@ -113,11 +113,6 @@
       </a:defRPr>
     </a:lvl9pPr>
   </p:defaultTextStyle>
-  <p:extLst>
-    <p:ext uri="{EFAFB233-063F-42B5-8137-9DF3F51BA10A}">
-      <p15:sldGuideLst xmlns:p15="http://schemas.microsoft.com/office/powerpoint/2012/main"/>
-    </p:ext>
-  </p:extLst>
 </p:presentation>
 </file>
 
@@ -143,7 +138,7 @@
           <p:cNvPr id="2" name="Title 1">
             <a:extLst>
               <a:ext uri="{FF2B5EF4-FFF2-40B4-BE49-F238E27FC236}">
-                <a16:creationId xmlns:a16="http://schemas.microsoft.com/office/drawing/2014/main" id="{0A72C08D-CC3E-BCB4-6503-27396283E20B}"/>
+                <a16:creationId xmlns:a16="http://schemas.microsoft.com/office/drawing/2014/main" id="{F9E83B71-6EC1-9C32-4A11-18CAACD5B4A0}"/>
               </a:ext>
             </a:extLst>
           </p:cNvPr>
@@ -180,7 +175,7 @@
           <p:cNvPr id="3" name="Subtitle 2">
             <a:extLst>
               <a:ext uri="{FF2B5EF4-FFF2-40B4-BE49-F238E27FC236}">
-                <a16:creationId xmlns:a16="http://schemas.microsoft.com/office/drawing/2014/main" id="{9147107D-A96E-8DF0-2B05-F36BDAECDE78}"/>
+                <a16:creationId xmlns:a16="http://schemas.microsoft.com/office/drawing/2014/main" id="{B06D7AF9-0EA2-8E29-BD53-32B4F450B122}"/>
               </a:ext>
             </a:extLst>
           </p:cNvPr>
@@ -250,7 +245,7 @@
           <p:cNvPr id="4" name="Date Placeholder 3">
             <a:extLst>
               <a:ext uri="{FF2B5EF4-FFF2-40B4-BE49-F238E27FC236}">
-                <a16:creationId xmlns:a16="http://schemas.microsoft.com/office/drawing/2014/main" id="{7067E667-6205-0F94-88FD-E8136E3D5972}"/>
+                <a16:creationId xmlns:a16="http://schemas.microsoft.com/office/drawing/2014/main" id="{BDA9BA4E-EED5-D13A-601B-B6F417116164}"/>
               </a:ext>
             </a:extLst>
           </p:cNvPr>
@@ -266,9 +261,9 @@
           <a:bodyPr/>
           <a:lstStyle/>
           <a:p>
-            <a:fld id="{2E7CC9F0-B487-409B-B9EC-A5FEB68BFF69}" type="datetimeFigureOut">
+            <a:fld id="{786828E8-20EE-4859-BAAE-B9CDE9EE438F}" type="datetimeFigureOut">
               <a:rPr lang="en-US" smtClean="0"/>
-              <a:t>3/14/2026</a:t>
+              <a:t>3/15/2026</a:t>
             </a:fld>
             <a:endParaRPr lang="en-US"/>
           </a:p>
@@ -279,7 +274,7 @@
           <p:cNvPr id="5" name="Footer Placeholder 4">
             <a:extLst>
               <a:ext uri="{FF2B5EF4-FFF2-40B4-BE49-F238E27FC236}">
-                <a16:creationId xmlns:a16="http://schemas.microsoft.com/office/drawing/2014/main" id="{B02F0D5E-0446-37A4-BA56-EC2CD71D7EA9}"/>
+                <a16:creationId xmlns:a16="http://schemas.microsoft.com/office/drawing/2014/main" id="{0EDBFFF6-4FB8-BA58-B681-E22B015509E7}"/>
               </a:ext>
             </a:extLst>
           </p:cNvPr>
@@ -304,7 +299,7 @@
           <p:cNvPr id="6" name="Slide Number Placeholder 5">
             <a:extLst>
               <a:ext uri="{FF2B5EF4-FFF2-40B4-BE49-F238E27FC236}">
-                <a16:creationId xmlns:a16="http://schemas.microsoft.com/office/drawing/2014/main" id="{13B6193B-32F4-50BD-C81D-C8E9B80068B2}"/>
+                <a16:creationId xmlns:a16="http://schemas.microsoft.com/office/drawing/2014/main" id="{62A06621-E277-967D-A1D4-A54F9D98D1EF}"/>
               </a:ext>
             </a:extLst>
           </p:cNvPr>
@@ -320,7 +315,7 @@
           <a:bodyPr/>
           <a:lstStyle/>
           <a:p>
-            <a:fld id="{7995F91C-4081-451F-BC6A-865794E1C2C2}" type="slidenum">
+            <a:fld id="{054C1CFB-DF71-4524-B094-74DF5D3566FA}" type="slidenum">
               <a:rPr lang="en-US" smtClean="0"/>
               <a:t>‹#›</a:t>
             </a:fld>
@@ -331,7 +326,7 @@
     </p:spTree>
     <p:extLst>
       <p:ext uri="{BB962C8B-B14F-4D97-AF65-F5344CB8AC3E}">
-        <p14:creationId xmlns:p14="http://schemas.microsoft.com/office/powerpoint/2010/main" val="3428267303"/>
+        <p14:creationId xmlns:p14="http://schemas.microsoft.com/office/powerpoint/2010/main" val="1131842563"/>
       </p:ext>
     </p:extLst>
   </p:cSld>
@@ -363,7 +358,7 @@
           <p:cNvPr id="2" name="Title 1">
             <a:extLst>
               <a:ext uri="{FF2B5EF4-FFF2-40B4-BE49-F238E27FC236}">
-                <a16:creationId xmlns:a16="http://schemas.microsoft.com/office/drawing/2014/main" id="{6777E36D-E4CC-6161-2BA4-FAD323FE2B89}"/>
+                <a16:creationId xmlns:a16="http://schemas.microsoft.com/office/drawing/2014/main" id="{C442E0A4-2B1B-A39D-782A-2EE3F873E0E5}"/>
               </a:ext>
             </a:extLst>
           </p:cNvPr>
@@ -391,7 +386,7 @@
           <p:cNvPr id="3" name="Vertical Text Placeholder 2">
             <a:extLst>
               <a:ext uri="{FF2B5EF4-FFF2-40B4-BE49-F238E27FC236}">
-                <a16:creationId xmlns:a16="http://schemas.microsoft.com/office/drawing/2014/main" id="{089D3753-2631-6812-75FD-EA1E5EE8276D}"/>
+                <a16:creationId xmlns:a16="http://schemas.microsoft.com/office/drawing/2014/main" id="{5AF404CD-682C-6D0F-2B20-F5AD657BA37D}"/>
               </a:ext>
             </a:extLst>
           </p:cNvPr>
@@ -448,7 +443,7 @@
           <p:cNvPr id="4" name="Date Placeholder 3">
             <a:extLst>
               <a:ext uri="{FF2B5EF4-FFF2-40B4-BE49-F238E27FC236}">
-                <a16:creationId xmlns:a16="http://schemas.microsoft.com/office/drawing/2014/main" id="{AE2DAC04-4CCF-4634-ECB1-C7697DFF59DD}"/>
+                <a16:creationId xmlns:a16="http://schemas.microsoft.com/office/drawing/2014/main" id="{C6B7147D-D9F9-B457-5115-755387187CFF}"/>
               </a:ext>
             </a:extLst>
           </p:cNvPr>
@@ -464,9 +459,9 @@
           <a:bodyPr/>
           <a:lstStyle/>
           <a:p>
-            <a:fld id="{2E7CC9F0-B487-409B-B9EC-A5FEB68BFF69}" type="datetimeFigureOut">
+            <a:fld id="{786828E8-20EE-4859-BAAE-B9CDE9EE438F}" type="datetimeFigureOut">
               <a:rPr lang="en-US" smtClean="0"/>
-              <a:t>3/14/2026</a:t>
+              <a:t>3/15/2026</a:t>
             </a:fld>
             <a:endParaRPr lang="en-US"/>
           </a:p>
@@ -477,7 +472,7 @@
           <p:cNvPr id="5" name="Footer Placeholder 4">
             <a:extLst>
               <a:ext uri="{FF2B5EF4-FFF2-40B4-BE49-F238E27FC236}">
-                <a16:creationId xmlns:a16="http://schemas.microsoft.com/office/drawing/2014/main" id="{A0F3E957-DB57-ED80-44A6-8358C115BC24}"/>
+                <a16:creationId xmlns:a16="http://schemas.microsoft.com/office/drawing/2014/main" id="{038BF48E-16D3-B82F-7BC7-2DCB6176A1AC}"/>
               </a:ext>
             </a:extLst>
           </p:cNvPr>
@@ -502,7 +497,7 @@
           <p:cNvPr id="6" name="Slide Number Placeholder 5">
             <a:extLst>
               <a:ext uri="{FF2B5EF4-FFF2-40B4-BE49-F238E27FC236}">
-                <a16:creationId xmlns:a16="http://schemas.microsoft.com/office/drawing/2014/main" id="{A77B693E-66D2-2BB5-A13F-A66C3141F1AC}"/>
+                <a16:creationId xmlns:a16="http://schemas.microsoft.com/office/drawing/2014/main" id="{3D48C02F-8973-25E9-6F57-28DBB4866470}"/>
               </a:ext>
             </a:extLst>
           </p:cNvPr>
@@ -518,7 +513,7 @@
           <a:bodyPr/>
           <a:lstStyle/>
           <a:p>
-            <a:fld id="{7995F91C-4081-451F-BC6A-865794E1C2C2}" type="slidenum">
+            <a:fld id="{054C1CFB-DF71-4524-B094-74DF5D3566FA}" type="slidenum">
               <a:rPr lang="en-US" smtClean="0"/>
               <a:t>‹#›</a:t>
             </a:fld>
@@ -529,7 +524,7 @@
     </p:spTree>
     <p:extLst>
       <p:ext uri="{BB962C8B-B14F-4D97-AF65-F5344CB8AC3E}">
-        <p14:creationId xmlns:p14="http://schemas.microsoft.com/office/powerpoint/2010/main" val="3139613413"/>
+        <p14:creationId xmlns:p14="http://schemas.microsoft.com/office/powerpoint/2010/main" val="2885070893"/>
       </p:ext>
     </p:extLst>
   </p:cSld>
@@ -561,7 +556,7 @@
           <p:cNvPr id="2" name="Vertical Title 1">
             <a:extLst>
               <a:ext uri="{FF2B5EF4-FFF2-40B4-BE49-F238E27FC236}">
-                <a16:creationId xmlns:a16="http://schemas.microsoft.com/office/drawing/2014/main" id="{6DE15976-DEDE-8A82-8585-E5A5C38FE99F}"/>
+                <a16:creationId xmlns:a16="http://schemas.microsoft.com/office/drawing/2014/main" id="{757BC47C-B1C6-8316-2205-73220EFB6923}"/>
               </a:ext>
             </a:extLst>
           </p:cNvPr>
@@ -594,7 +589,7 @@
           <p:cNvPr id="3" name="Vertical Text Placeholder 2">
             <a:extLst>
               <a:ext uri="{FF2B5EF4-FFF2-40B4-BE49-F238E27FC236}">
-                <a16:creationId xmlns:a16="http://schemas.microsoft.com/office/drawing/2014/main" id="{74849726-CD70-9173-6D4C-77C45EDF338F}"/>
+                <a16:creationId xmlns:a16="http://schemas.microsoft.com/office/drawing/2014/main" id="{9570EA76-DE39-9390-F02B-BDC01CC3594A}"/>
               </a:ext>
             </a:extLst>
           </p:cNvPr>
@@ -656,7 +651,7 @@
           <p:cNvPr id="4" name="Date Placeholder 3">
             <a:extLst>
               <a:ext uri="{FF2B5EF4-FFF2-40B4-BE49-F238E27FC236}">
-                <a16:creationId xmlns:a16="http://schemas.microsoft.com/office/drawing/2014/main" id="{F0E04750-DC57-A5E9-4B09-BCD1B269B66B}"/>
+                <a16:creationId xmlns:a16="http://schemas.microsoft.com/office/drawing/2014/main" id="{2A27F63D-D032-FE0E-F78E-1D73A9B007E5}"/>
               </a:ext>
             </a:extLst>
           </p:cNvPr>
@@ -672,9 +667,9 @@
           <a:bodyPr/>
           <a:lstStyle/>
           <a:p>
-            <a:fld id="{2E7CC9F0-B487-409B-B9EC-A5FEB68BFF69}" type="datetimeFigureOut">
+            <a:fld id="{786828E8-20EE-4859-BAAE-B9CDE9EE438F}" type="datetimeFigureOut">
               <a:rPr lang="en-US" smtClean="0"/>
-              <a:t>3/14/2026</a:t>
+              <a:t>3/15/2026</a:t>
             </a:fld>
             <a:endParaRPr lang="en-US"/>
           </a:p>
@@ -685,7 +680,7 @@
           <p:cNvPr id="5" name="Footer Placeholder 4">
             <a:extLst>
               <a:ext uri="{FF2B5EF4-FFF2-40B4-BE49-F238E27FC236}">
-                <a16:creationId xmlns:a16="http://schemas.microsoft.com/office/drawing/2014/main" id="{6072B221-55FC-B91D-CE19-51227B40D194}"/>
+                <a16:creationId xmlns:a16="http://schemas.microsoft.com/office/drawing/2014/main" id="{1B3F013E-971F-0F2B-1B84-A780AE2BF919}"/>
               </a:ext>
             </a:extLst>
           </p:cNvPr>
@@ -710,7 +705,7 @@
           <p:cNvPr id="6" name="Slide Number Placeholder 5">
             <a:extLst>
               <a:ext uri="{FF2B5EF4-FFF2-40B4-BE49-F238E27FC236}">
-                <a16:creationId xmlns:a16="http://schemas.microsoft.com/office/drawing/2014/main" id="{21BD667F-AB16-1941-0832-D1B05217C4AF}"/>
+                <a16:creationId xmlns:a16="http://schemas.microsoft.com/office/drawing/2014/main" id="{3DC985D4-3A8E-9EA6-1BCA-56BEC8C0D748}"/>
               </a:ext>
             </a:extLst>
           </p:cNvPr>
@@ -726,7 +721,7 @@
           <a:bodyPr/>
           <a:lstStyle/>
           <a:p>
-            <a:fld id="{7995F91C-4081-451F-BC6A-865794E1C2C2}" type="slidenum">
+            <a:fld id="{054C1CFB-DF71-4524-B094-74DF5D3566FA}" type="slidenum">
               <a:rPr lang="en-US" smtClean="0"/>
               <a:t>‹#›</a:t>
             </a:fld>
@@ -737,7 +732,7 @@
     </p:spTree>
     <p:extLst>
       <p:ext uri="{BB962C8B-B14F-4D97-AF65-F5344CB8AC3E}">
-        <p14:creationId xmlns:p14="http://schemas.microsoft.com/office/powerpoint/2010/main" val="2047374509"/>
+        <p14:creationId xmlns:p14="http://schemas.microsoft.com/office/powerpoint/2010/main" val="1748808222"/>
       </p:ext>
     </p:extLst>
   </p:cSld>
@@ -769,7 +764,7 @@
           <p:cNvPr id="2" name="Title 1">
             <a:extLst>
               <a:ext uri="{FF2B5EF4-FFF2-40B4-BE49-F238E27FC236}">
-                <a16:creationId xmlns:a16="http://schemas.microsoft.com/office/drawing/2014/main" id="{077F6988-BFD0-DC21-EFE0-A915235487CA}"/>
+                <a16:creationId xmlns:a16="http://schemas.microsoft.com/office/drawing/2014/main" id="{F5BFF31B-534F-0DFD-847C-D985D9282A84}"/>
               </a:ext>
             </a:extLst>
           </p:cNvPr>
@@ -797,7 +792,7 @@
           <p:cNvPr id="3" name="Content Placeholder 2">
             <a:extLst>
               <a:ext uri="{FF2B5EF4-FFF2-40B4-BE49-F238E27FC236}">
-                <a16:creationId xmlns:a16="http://schemas.microsoft.com/office/drawing/2014/main" id="{EEF139A6-C79E-E550-081F-4CD81E2A6FD6}"/>
+                <a16:creationId xmlns:a16="http://schemas.microsoft.com/office/drawing/2014/main" id="{10E184C8-6B23-85EF-BB8B-BB5FA5ACA39E}"/>
               </a:ext>
             </a:extLst>
           </p:cNvPr>
@@ -854,7 +849,7 @@
           <p:cNvPr id="4" name="Date Placeholder 3">
             <a:extLst>
               <a:ext uri="{FF2B5EF4-FFF2-40B4-BE49-F238E27FC236}">
-                <a16:creationId xmlns:a16="http://schemas.microsoft.com/office/drawing/2014/main" id="{B06DFFB1-EFC5-5CC6-8734-3FC6A11104B3}"/>
+                <a16:creationId xmlns:a16="http://schemas.microsoft.com/office/drawing/2014/main" id="{69C4F41D-D8D8-045C-C7DC-CFA646762423}"/>
               </a:ext>
             </a:extLst>
           </p:cNvPr>
@@ -870,9 +865,9 @@
           <a:bodyPr/>
           <a:lstStyle/>
           <a:p>
-            <a:fld id="{2E7CC9F0-B487-409B-B9EC-A5FEB68BFF69}" type="datetimeFigureOut">
+            <a:fld id="{786828E8-20EE-4859-BAAE-B9CDE9EE438F}" type="datetimeFigureOut">
               <a:rPr lang="en-US" smtClean="0"/>
-              <a:t>3/14/2026</a:t>
+              <a:t>3/15/2026</a:t>
             </a:fld>
             <a:endParaRPr lang="en-US"/>
           </a:p>
@@ -883,7 +878,7 @@
           <p:cNvPr id="5" name="Footer Placeholder 4">
             <a:extLst>
               <a:ext uri="{FF2B5EF4-FFF2-40B4-BE49-F238E27FC236}">
-                <a16:creationId xmlns:a16="http://schemas.microsoft.com/office/drawing/2014/main" id="{A4CC5039-D545-F0BD-F4BD-55FE042A4FB4}"/>
+                <a16:creationId xmlns:a16="http://schemas.microsoft.com/office/drawing/2014/main" id="{9F56B629-FF1D-3120-20CB-739209DA84E2}"/>
               </a:ext>
             </a:extLst>
           </p:cNvPr>
@@ -908,7 +903,7 @@
           <p:cNvPr id="6" name="Slide Number Placeholder 5">
             <a:extLst>
               <a:ext uri="{FF2B5EF4-FFF2-40B4-BE49-F238E27FC236}">
-                <a16:creationId xmlns:a16="http://schemas.microsoft.com/office/drawing/2014/main" id="{B45DB052-3BDA-5C0B-8ADF-AE287F8579A7}"/>
+                <a16:creationId xmlns:a16="http://schemas.microsoft.com/office/drawing/2014/main" id="{1BF571E7-0E46-E111-487E-0C8A1A24B70F}"/>
               </a:ext>
             </a:extLst>
           </p:cNvPr>
@@ -924,7 +919,7 @@
           <a:bodyPr/>
           <a:lstStyle/>
           <a:p>
-            <a:fld id="{7995F91C-4081-451F-BC6A-865794E1C2C2}" type="slidenum">
+            <a:fld id="{054C1CFB-DF71-4524-B094-74DF5D3566FA}" type="slidenum">
               <a:rPr lang="en-US" smtClean="0"/>
               <a:t>‹#›</a:t>
             </a:fld>
@@ -935,7 +930,7 @@
     </p:spTree>
     <p:extLst>
       <p:ext uri="{BB962C8B-B14F-4D97-AF65-F5344CB8AC3E}">
-        <p14:creationId xmlns:p14="http://schemas.microsoft.com/office/powerpoint/2010/main" val="1761961394"/>
+        <p14:creationId xmlns:p14="http://schemas.microsoft.com/office/powerpoint/2010/main" val="1306615846"/>
       </p:ext>
     </p:extLst>
   </p:cSld>
@@ -967,7 +962,7 @@
           <p:cNvPr id="2" name="Title 1">
             <a:extLst>
               <a:ext uri="{FF2B5EF4-FFF2-40B4-BE49-F238E27FC236}">
-                <a16:creationId xmlns:a16="http://schemas.microsoft.com/office/drawing/2014/main" id="{47E7A6B2-DA8F-AB98-5F7B-1492C295405A}"/>
+                <a16:creationId xmlns:a16="http://schemas.microsoft.com/office/drawing/2014/main" id="{960A1C3A-AB13-A002-B03E-2BC93FC856D2}"/>
               </a:ext>
             </a:extLst>
           </p:cNvPr>
@@ -1004,7 +999,7 @@
           <p:cNvPr id="3" name="Text Placeholder 2">
             <a:extLst>
               <a:ext uri="{FF2B5EF4-FFF2-40B4-BE49-F238E27FC236}">
-                <a16:creationId xmlns:a16="http://schemas.microsoft.com/office/drawing/2014/main" id="{90F0C16B-C768-5A89-7D93-BE1F1E3602A0}"/>
+                <a16:creationId xmlns:a16="http://schemas.microsoft.com/office/drawing/2014/main" id="{ED3EEB51-FE8D-946C-799E-D898718C35ED}"/>
               </a:ext>
             </a:extLst>
           </p:cNvPr>
@@ -1129,7 +1124,7 @@
           <p:cNvPr id="4" name="Date Placeholder 3">
             <a:extLst>
               <a:ext uri="{FF2B5EF4-FFF2-40B4-BE49-F238E27FC236}">
-                <a16:creationId xmlns:a16="http://schemas.microsoft.com/office/drawing/2014/main" id="{4347D6B4-EA4B-88B7-D6C2-5F7FEA25C370}"/>
+                <a16:creationId xmlns:a16="http://schemas.microsoft.com/office/drawing/2014/main" id="{81A65EE7-3651-9BF7-9686-83E4B12C9BF8}"/>
               </a:ext>
             </a:extLst>
           </p:cNvPr>
@@ -1145,9 +1140,9 @@
           <a:bodyPr/>
           <a:lstStyle/>
           <a:p>
-            <a:fld id="{2E7CC9F0-B487-409B-B9EC-A5FEB68BFF69}" type="datetimeFigureOut">
+            <a:fld id="{786828E8-20EE-4859-BAAE-B9CDE9EE438F}" type="datetimeFigureOut">
               <a:rPr lang="en-US" smtClean="0"/>
-              <a:t>3/14/2026</a:t>
+              <a:t>3/15/2026</a:t>
             </a:fld>
             <a:endParaRPr lang="en-US"/>
           </a:p>
@@ -1158,7 +1153,7 @@
           <p:cNvPr id="5" name="Footer Placeholder 4">
             <a:extLst>
               <a:ext uri="{FF2B5EF4-FFF2-40B4-BE49-F238E27FC236}">
-                <a16:creationId xmlns:a16="http://schemas.microsoft.com/office/drawing/2014/main" id="{AC188FF0-B8AB-8EEC-3C30-6A22DDC3565B}"/>
+                <a16:creationId xmlns:a16="http://schemas.microsoft.com/office/drawing/2014/main" id="{D78BFA92-2168-82C6-7F9C-884F12BE545F}"/>
               </a:ext>
             </a:extLst>
           </p:cNvPr>
@@ -1183,7 +1178,7 @@
           <p:cNvPr id="6" name="Slide Number Placeholder 5">
             <a:extLst>
               <a:ext uri="{FF2B5EF4-FFF2-40B4-BE49-F238E27FC236}">
-                <a16:creationId xmlns:a16="http://schemas.microsoft.com/office/drawing/2014/main" id="{BEC72884-FED0-F090-64AC-16474D42E3CA}"/>
+                <a16:creationId xmlns:a16="http://schemas.microsoft.com/office/drawing/2014/main" id="{BD825879-8EA6-EFC1-94E7-81F0183473FB}"/>
               </a:ext>
             </a:extLst>
           </p:cNvPr>
@@ -1199,7 +1194,7 @@
           <a:bodyPr/>
           <a:lstStyle/>
           <a:p>
-            <a:fld id="{7995F91C-4081-451F-BC6A-865794E1C2C2}" type="slidenum">
+            <a:fld id="{054C1CFB-DF71-4524-B094-74DF5D3566FA}" type="slidenum">
               <a:rPr lang="en-US" smtClean="0"/>
               <a:t>‹#›</a:t>
             </a:fld>
@@ -1210,7 +1205,7 @@
     </p:spTree>
     <p:extLst>
       <p:ext uri="{BB962C8B-B14F-4D97-AF65-F5344CB8AC3E}">
-        <p14:creationId xmlns:p14="http://schemas.microsoft.com/office/powerpoint/2010/main" val="1978323495"/>
+        <p14:creationId xmlns:p14="http://schemas.microsoft.com/office/powerpoint/2010/main" val="1576023595"/>
       </p:ext>
     </p:extLst>
   </p:cSld>
@@ -1242,7 +1237,7 @@
           <p:cNvPr id="2" name="Title 1">
             <a:extLst>
               <a:ext uri="{FF2B5EF4-FFF2-40B4-BE49-F238E27FC236}">
-                <a16:creationId xmlns:a16="http://schemas.microsoft.com/office/drawing/2014/main" id="{49651D86-D0E0-8638-5512-63B4BF42397E}"/>
+                <a16:creationId xmlns:a16="http://schemas.microsoft.com/office/drawing/2014/main" id="{CD4001EB-0AF0-B0EF-A5C9-E27148AB47D2}"/>
               </a:ext>
             </a:extLst>
           </p:cNvPr>
@@ -1270,7 +1265,7 @@
           <p:cNvPr id="3" name="Content Placeholder 2">
             <a:extLst>
               <a:ext uri="{FF2B5EF4-FFF2-40B4-BE49-F238E27FC236}">
-                <a16:creationId xmlns:a16="http://schemas.microsoft.com/office/drawing/2014/main" id="{DBAE950E-2AEA-69D0-093B-DBA6567C350E}"/>
+                <a16:creationId xmlns:a16="http://schemas.microsoft.com/office/drawing/2014/main" id="{F705B968-D150-59D6-1B8E-3A18AD04593C}"/>
               </a:ext>
             </a:extLst>
           </p:cNvPr>
@@ -1332,7 +1327,7 @@
           <p:cNvPr id="4" name="Content Placeholder 3">
             <a:extLst>
               <a:ext uri="{FF2B5EF4-FFF2-40B4-BE49-F238E27FC236}">
-                <a16:creationId xmlns:a16="http://schemas.microsoft.com/office/drawing/2014/main" id="{F7CEACBC-D227-E363-3999-40C8B18B4E06}"/>
+                <a16:creationId xmlns:a16="http://schemas.microsoft.com/office/drawing/2014/main" id="{97792001-ADBC-8437-5B34-F3546D5B54B1}"/>
               </a:ext>
             </a:extLst>
           </p:cNvPr>
@@ -1394,7 +1389,7 @@
           <p:cNvPr id="5" name="Date Placeholder 4">
             <a:extLst>
               <a:ext uri="{FF2B5EF4-FFF2-40B4-BE49-F238E27FC236}">
-                <a16:creationId xmlns:a16="http://schemas.microsoft.com/office/drawing/2014/main" id="{6BE27C44-89CC-0707-B8E3-250191E57224}"/>
+                <a16:creationId xmlns:a16="http://schemas.microsoft.com/office/drawing/2014/main" id="{6A649AAE-AFD2-465C-65A1-54F9E2C92559}"/>
               </a:ext>
             </a:extLst>
           </p:cNvPr>
@@ -1410,9 +1405,9 @@
           <a:bodyPr/>
           <a:lstStyle/>
           <a:p>
-            <a:fld id="{2E7CC9F0-B487-409B-B9EC-A5FEB68BFF69}" type="datetimeFigureOut">
+            <a:fld id="{786828E8-20EE-4859-BAAE-B9CDE9EE438F}" type="datetimeFigureOut">
               <a:rPr lang="en-US" smtClean="0"/>
-              <a:t>3/14/2026</a:t>
+              <a:t>3/15/2026</a:t>
             </a:fld>
             <a:endParaRPr lang="en-US"/>
           </a:p>
@@ -1423,7 +1418,7 @@
           <p:cNvPr id="6" name="Footer Placeholder 5">
             <a:extLst>
               <a:ext uri="{FF2B5EF4-FFF2-40B4-BE49-F238E27FC236}">
-                <a16:creationId xmlns:a16="http://schemas.microsoft.com/office/drawing/2014/main" id="{4AD63899-6395-16AC-7A09-983176D14F68}"/>
+                <a16:creationId xmlns:a16="http://schemas.microsoft.com/office/drawing/2014/main" id="{3A52C368-D4FA-BE52-54C7-BA55333C9EA2}"/>
               </a:ext>
             </a:extLst>
           </p:cNvPr>
@@ -1448,7 +1443,7 @@
           <p:cNvPr id="7" name="Slide Number Placeholder 6">
             <a:extLst>
               <a:ext uri="{FF2B5EF4-FFF2-40B4-BE49-F238E27FC236}">
-                <a16:creationId xmlns:a16="http://schemas.microsoft.com/office/drawing/2014/main" id="{0FF99210-AB92-61B3-58BA-4B6FAC82FA5D}"/>
+                <a16:creationId xmlns:a16="http://schemas.microsoft.com/office/drawing/2014/main" id="{7BA82B5E-CEB0-6BE3-C127-41048E5A4BC4}"/>
               </a:ext>
             </a:extLst>
           </p:cNvPr>
@@ -1464,7 +1459,7 @@
           <a:bodyPr/>
           <a:lstStyle/>
           <a:p>
-            <a:fld id="{7995F91C-4081-451F-BC6A-865794E1C2C2}" type="slidenum">
+            <a:fld id="{054C1CFB-DF71-4524-B094-74DF5D3566FA}" type="slidenum">
               <a:rPr lang="en-US" smtClean="0"/>
               <a:t>‹#›</a:t>
             </a:fld>
@@ -1475,7 +1470,7 @@
     </p:spTree>
     <p:extLst>
       <p:ext uri="{BB962C8B-B14F-4D97-AF65-F5344CB8AC3E}">
-        <p14:creationId xmlns:p14="http://schemas.microsoft.com/office/powerpoint/2010/main" val="3624898445"/>
+        <p14:creationId xmlns:p14="http://schemas.microsoft.com/office/powerpoint/2010/main" val="4014518511"/>
       </p:ext>
     </p:extLst>
   </p:cSld>
@@ -1507,7 +1502,7 @@
           <p:cNvPr id="2" name="Title 1">
             <a:extLst>
               <a:ext uri="{FF2B5EF4-FFF2-40B4-BE49-F238E27FC236}">
-                <a16:creationId xmlns:a16="http://schemas.microsoft.com/office/drawing/2014/main" id="{83F4F9C0-6D7E-17C1-C49C-26A6C3A88D13}"/>
+                <a16:creationId xmlns:a16="http://schemas.microsoft.com/office/drawing/2014/main" id="{6EDBE4A2-7481-22FB-E25B-E0704075B865}"/>
               </a:ext>
             </a:extLst>
           </p:cNvPr>
@@ -1540,7 +1535,7 @@
           <p:cNvPr id="3" name="Text Placeholder 2">
             <a:extLst>
               <a:ext uri="{FF2B5EF4-FFF2-40B4-BE49-F238E27FC236}">
-                <a16:creationId xmlns:a16="http://schemas.microsoft.com/office/drawing/2014/main" id="{FC5FC86A-4728-0316-B89B-0F7CCD8EBD38}"/>
+                <a16:creationId xmlns:a16="http://schemas.microsoft.com/office/drawing/2014/main" id="{32AA48B0-23B0-F481-4A09-A93782569302}"/>
               </a:ext>
             </a:extLst>
           </p:cNvPr>
@@ -1611,7 +1606,7 @@
           <p:cNvPr id="4" name="Content Placeholder 3">
             <a:extLst>
               <a:ext uri="{FF2B5EF4-FFF2-40B4-BE49-F238E27FC236}">
-                <a16:creationId xmlns:a16="http://schemas.microsoft.com/office/drawing/2014/main" id="{D3681141-3743-94D4-7FDA-2BAEC0F86326}"/>
+                <a16:creationId xmlns:a16="http://schemas.microsoft.com/office/drawing/2014/main" id="{BE081A35-2875-8FAE-2D5A-91897A1CE276}"/>
               </a:ext>
             </a:extLst>
           </p:cNvPr>
@@ -1673,7 +1668,7 @@
           <p:cNvPr id="5" name="Text Placeholder 4">
             <a:extLst>
               <a:ext uri="{FF2B5EF4-FFF2-40B4-BE49-F238E27FC236}">
-                <a16:creationId xmlns:a16="http://schemas.microsoft.com/office/drawing/2014/main" id="{F308BE56-8FC0-2CB3-0D98-A84AB78E7C85}"/>
+                <a16:creationId xmlns:a16="http://schemas.microsoft.com/office/drawing/2014/main" id="{F9F9B216-8ACF-ED01-A18C-F65D7116B0AD}"/>
               </a:ext>
             </a:extLst>
           </p:cNvPr>
@@ -1744,7 +1739,7 @@
           <p:cNvPr id="6" name="Content Placeholder 5">
             <a:extLst>
               <a:ext uri="{FF2B5EF4-FFF2-40B4-BE49-F238E27FC236}">
-                <a16:creationId xmlns:a16="http://schemas.microsoft.com/office/drawing/2014/main" id="{120DA587-8883-B72E-B9BB-84734521F53A}"/>
+                <a16:creationId xmlns:a16="http://schemas.microsoft.com/office/drawing/2014/main" id="{2DCDEE70-9CF1-FFDA-F9AE-F59DC7537020}"/>
               </a:ext>
             </a:extLst>
           </p:cNvPr>
@@ -1806,7 +1801,7 @@
           <p:cNvPr id="7" name="Date Placeholder 6">
             <a:extLst>
               <a:ext uri="{FF2B5EF4-FFF2-40B4-BE49-F238E27FC236}">
-                <a16:creationId xmlns:a16="http://schemas.microsoft.com/office/drawing/2014/main" id="{9F83B737-90D1-E227-BAF6-DA6DB3DE3851}"/>
+                <a16:creationId xmlns:a16="http://schemas.microsoft.com/office/drawing/2014/main" id="{F836D15A-2588-59AB-A7B1-4E471AA6A396}"/>
               </a:ext>
             </a:extLst>
           </p:cNvPr>
@@ -1822,9 +1817,9 @@
           <a:bodyPr/>
           <a:lstStyle/>
           <a:p>
-            <a:fld id="{2E7CC9F0-B487-409B-B9EC-A5FEB68BFF69}" type="datetimeFigureOut">
+            <a:fld id="{786828E8-20EE-4859-BAAE-B9CDE9EE438F}" type="datetimeFigureOut">
               <a:rPr lang="en-US" smtClean="0"/>
-              <a:t>3/14/2026</a:t>
+              <a:t>3/15/2026</a:t>
             </a:fld>
             <a:endParaRPr lang="en-US"/>
           </a:p>
@@ -1835,7 +1830,7 @@
           <p:cNvPr id="8" name="Footer Placeholder 7">
             <a:extLst>
               <a:ext uri="{FF2B5EF4-FFF2-40B4-BE49-F238E27FC236}">
-                <a16:creationId xmlns:a16="http://schemas.microsoft.com/office/drawing/2014/main" id="{C8BC8979-D0BB-D9E8-185A-34FEE97606BD}"/>
+                <a16:creationId xmlns:a16="http://schemas.microsoft.com/office/drawing/2014/main" id="{6A151DA3-2A20-EB90-EEAE-FAA192A7C96A}"/>
               </a:ext>
             </a:extLst>
           </p:cNvPr>
@@ -1860,7 +1855,7 @@
           <p:cNvPr id="9" name="Slide Number Placeholder 8">
             <a:extLst>
               <a:ext uri="{FF2B5EF4-FFF2-40B4-BE49-F238E27FC236}">
-                <a16:creationId xmlns:a16="http://schemas.microsoft.com/office/drawing/2014/main" id="{7D8E4148-453A-FB12-7BE4-FA123BB701E3}"/>
+                <a16:creationId xmlns:a16="http://schemas.microsoft.com/office/drawing/2014/main" id="{20EABBBE-BA08-4ECD-B0F1-D55A121F7BFF}"/>
               </a:ext>
             </a:extLst>
           </p:cNvPr>
@@ -1876,7 +1871,7 @@
           <a:bodyPr/>
           <a:lstStyle/>
           <a:p>
-            <a:fld id="{7995F91C-4081-451F-BC6A-865794E1C2C2}" type="slidenum">
+            <a:fld id="{054C1CFB-DF71-4524-B094-74DF5D3566FA}" type="slidenum">
               <a:rPr lang="en-US" smtClean="0"/>
               <a:t>‹#›</a:t>
             </a:fld>
@@ -1887,7 +1882,7 @@
     </p:spTree>
     <p:extLst>
       <p:ext uri="{BB962C8B-B14F-4D97-AF65-F5344CB8AC3E}">
-        <p14:creationId xmlns:p14="http://schemas.microsoft.com/office/powerpoint/2010/main" val="1556256115"/>
+        <p14:creationId xmlns:p14="http://schemas.microsoft.com/office/powerpoint/2010/main" val="2992586798"/>
       </p:ext>
     </p:extLst>
   </p:cSld>
@@ -1919,7 +1914,7 @@
           <p:cNvPr id="2" name="Title 1">
             <a:extLst>
               <a:ext uri="{FF2B5EF4-FFF2-40B4-BE49-F238E27FC236}">
-                <a16:creationId xmlns:a16="http://schemas.microsoft.com/office/drawing/2014/main" id="{DBDF42E2-F9C7-60D4-C733-419BD82ED78F}"/>
+                <a16:creationId xmlns:a16="http://schemas.microsoft.com/office/drawing/2014/main" id="{5E884B30-1083-3792-BAE9-CDBAFD420817}"/>
               </a:ext>
             </a:extLst>
           </p:cNvPr>
@@ -1947,7 +1942,7 @@
           <p:cNvPr id="3" name="Date Placeholder 2">
             <a:extLst>
               <a:ext uri="{FF2B5EF4-FFF2-40B4-BE49-F238E27FC236}">
-                <a16:creationId xmlns:a16="http://schemas.microsoft.com/office/drawing/2014/main" id="{AE156ECD-C71D-3DC9-CF01-7DCE969DE41C}"/>
+                <a16:creationId xmlns:a16="http://schemas.microsoft.com/office/drawing/2014/main" id="{60AF5657-E2A4-2923-D3A8-492CD3225589}"/>
               </a:ext>
             </a:extLst>
           </p:cNvPr>
@@ -1963,9 +1958,9 @@
           <a:bodyPr/>
           <a:lstStyle/>
           <a:p>
-            <a:fld id="{2E7CC9F0-B487-409B-B9EC-A5FEB68BFF69}" type="datetimeFigureOut">
+            <a:fld id="{786828E8-20EE-4859-BAAE-B9CDE9EE438F}" type="datetimeFigureOut">
               <a:rPr lang="en-US" smtClean="0"/>
-              <a:t>3/14/2026</a:t>
+              <a:t>3/15/2026</a:t>
             </a:fld>
             <a:endParaRPr lang="en-US"/>
           </a:p>
@@ -1976,7 +1971,7 @@
           <p:cNvPr id="4" name="Footer Placeholder 3">
             <a:extLst>
               <a:ext uri="{FF2B5EF4-FFF2-40B4-BE49-F238E27FC236}">
-                <a16:creationId xmlns:a16="http://schemas.microsoft.com/office/drawing/2014/main" id="{AEFC6467-2B66-D31B-5599-553C484BAEA5}"/>
+                <a16:creationId xmlns:a16="http://schemas.microsoft.com/office/drawing/2014/main" id="{B676D700-033D-125D-CC4A-5FAFD02B50FC}"/>
               </a:ext>
             </a:extLst>
           </p:cNvPr>
@@ -2001,7 +1996,7 @@
           <p:cNvPr id="5" name="Slide Number Placeholder 4">
             <a:extLst>
               <a:ext uri="{FF2B5EF4-FFF2-40B4-BE49-F238E27FC236}">
-                <a16:creationId xmlns:a16="http://schemas.microsoft.com/office/drawing/2014/main" id="{CA39FC1A-378F-108A-7841-2DB17D136A6A}"/>
+                <a16:creationId xmlns:a16="http://schemas.microsoft.com/office/drawing/2014/main" id="{85FCBD1F-A18A-B7A6-13C0-E2E1435BDC74}"/>
               </a:ext>
             </a:extLst>
           </p:cNvPr>
@@ -2017,7 +2012,7 @@
           <a:bodyPr/>
           <a:lstStyle/>
           <a:p>
-            <a:fld id="{7995F91C-4081-451F-BC6A-865794E1C2C2}" type="slidenum">
+            <a:fld id="{054C1CFB-DF71-4524-B094-74DF5D3566FA}" type="slidenum">
               <a:rPr lang="en-US" smtClean="0"/>
               <a:t>‹#›</a:t>
             </a:fld>
@@ -2028,7 +2023,7 @@
     </p:spTree>
     <p:extLst>
       <p:ext uri="{BB962C8B-B14F-4D97-AF65-F5344CB8AC3E}">
-        <p14:creationId xmlns:p14="http://schemas.microsoft.com/office/powerpoint/2010/main" val="1287662742"/>
+        <p14:creationId xmlns:p14="http://schemas.microsoft.com/office/powerpoint/2010/main" val="1142045396"/>
       </p:ext>
     </p:extLst>
   </p:cSld>
@@ -2060,7 +2055,7 @@
           <p:cNvPr id="2" name="Date Placeholder 1">
             <a:extLst>
               <a:ext uri="{FF2B5EF4-FFF2-40B4-BE49-F238E27FC236}">
-                <a16:creationId xmlns:a16="http://schemas.microsoft.com/office/drawing/2014/main" id="{B85CE73C-EEC6-30B9-CD5A-B296616FB4D3}"/>
+                <a16:creationId xmlns:a16="http://schemas.microsoft.com/office/drawing/2014/main" id="{31A21FBD-5E8F-BBCF-5276-F6981E406BEE}"/>
               </a:ext>
             </a:extLst>
           </p:cNvPr>
@@ -2076,9 +2071,9 @@
           <a:bodyPr/>
           <a:lstStyle/>
           <a:p>
-            <a:fld id="{2E7CC9F0-B487-409B-B9EC-A5FEB68BFF69}" type="datetimeFigureOut">
+            <a:fld id="{786828E8-20EE-4859-BAAE-B9CDE9EE438F}" type="datetimeFigureOut">
               <a:rPr lang="en-US" smtClean="0"/>
-              <a:t>3/14/2026</a:t>
+              <a:t>3/15/2026</a:t>
             </a:fld>
             <a:endParaRPr lang="en-US"/>
           </a:p>
@@ -2089,7 +2084,7 @@
           <p:cNvPr id="3" name="Footer Placeholder 2">
             <a:extLst>
               <a:ext uri="{FF2B5EF4-FFF2-40B4-BE49-F238E27FC236}">
-                <a16:creationId xmlns:a16="http://schemas.microsoft.com/office/drawing/2014/main" id="{337B5DD3-E618-D238-F00E-1DD20FF615DD}"/>
+                <a16:creationId xmlns:a16="http://schemas.microsoft.com/office/drawing/2014/main" id="{F6342555-BF4A-3EEA-7E0B-CDEC795C134B}"/>
               </a:ext>
             </a:extLst>
           </p:cNvPr>
@@ -2114,7 +2109,7 @@
           <p:cNvPr id="4" name="Slide Number Placeholder 3">
             <a:extLst>
               <a:ext uri="{FF2B5EF4-FFF2-40B4-BE49-F238E27FC236}">
-                <a16:creationId xmlns:a16="http://schemas.microsoft.com/office/drawing/2014/main" id="{CB63D1BD-4930-184C-9858-F2E14B4BEE23}"/>
+                <a16:creationId xmlns:a16="http://schemas.microsoft.com/office/drawing/2014/main" id="{1663E464-96E5-B4E4-4776-872363E290B7}"/>
               </a:ext>
             </a:extLst>
           </p:cNvPr>
@@ -2130,7 +2125,7 @@
           <a:bodyPr/>
           <a:lstStyle/>
           <a:p>
-            <a:fld id="{7995F91C-4081-451F-BC6A-865794E1C2C2}" type="slidenum">
+            <a:fld id="{054C1CFB-DF71-4524-B094-74DF5D3566FA}" type="slidenum">
               <a:rPr lang="en-US" smtClean="0"/>
               <a:t>‹#›</a:t>
             </a:fld>
@@ -2141,7 +2136,7 @@
     </p:spTree>
     <p:extLst>
       <p:ext uri="{BB962C8B-B14F-4D97-AF65-F5344CB8AC3E}">
-        <p14:creationId xmlns:p14="http://schemas.microsoft.com/office/powerpoint/2010/main" val="2120169339"/>
+        <p14:creationId xmlns:p14="http://schemas.microsoft.com/office/powerpoint/2010/main" val="454363575"/>
       </p:ext>
     </p:extLst>
   </p:cSld>
@@ -2173,7 +2168,7 @@
           <p:cNvPr id="2" name="Title 1">
             <a:extLst>
               <a:ext uri="{FF2B5EF4-FFF2-40B4-BE49-F238E27FC236}">
-                <a16:creationId xmlns:a16="http://schemas.microsoft.com/office/drawing/2014/main" id="{12BF7B19-D6A2-1CF9-80EC-9A547294D830}"/>
+                <a16:creationId xmlns:a16="http://schemas.microsoft.com/office/drawing/2014/main" id="{93D9FA1D-648A-91AF-DDA5-09EC9FA7F203}"/>
               </a:ext>
             </a:extLst>
           </p:cNvPr>
@@ -2210,7 +2205,7 @@
           <p:cNvPr id="3" name="Content Placeholder 2">
             <a:extLst>
               <a:ext uri="{FF2B5EF4-FFF2-40B4-BE49-F238E27FC236}">
-                <a16:creationId xmlns:a16="http://schemas.microsoft.com/office/drawing/2014/main" id="{D201B92E-5068-3D17-E393-2F4E90F8A034}"/>
+                <a16:creationId xmlns:a16="http://schemas.microsoft.com/office/drawing/2014/main" id="{E024285E-209B-F1CD-3222-7022AC3F01D3}"/>
               </a:ext>
             </a:extLst>
           </p:cNvPr>
@@ -2300,7 +2295,7 @@
           <p:cNvPr id="4" name="Text Placeholder 3">
             <a:extLst>
               <a:ext uri="{FF2B5EF4-FFF2-40B4-BE49-F238E27FC236}">
-                <a16:creationId xmlns:a16="http://schemas.microsoft.com/office/drawing/2014/main" id="{E5F2DAEF-DC68-D014-D50E-7A20FD680CEC}"/>
+                <a16:creationId xmlns:a16="http://schemas.microsoft.com/office/drawing/2014/main" id="{1719BD0F-67A9-6C85-7113-2804507406E5}"/>
               </a:ext>
             </a:extLst>
           </p:cNvPr>
@@ -2371,7 +2366,7 @@
           <p:cNvPr id="5" name="Date Placeholder 4">
             <a:extLst>
               <a:ext uri="{FF2B5EF4-FFF2-40B4-BE49-F238E27FC236}">
-                <a16:creationId xmlns:a16="http://schemas.microsoft.com/office/drawing/2014/main" id="{B867F43A-D2B4-B4F3-2095-A166FF11AC04}"/>
+                <a16:creationId xmlns:a16="http://schemas.microsoft.com/office/drawing/2014/main" id="{5D84DBE4-0473-683D-5C37-066667486C55}"/>
               </a:ext>
             </a:extLst>
           </p:cNvPr>
@@ -2387,9 +2382,9 @@
           <a:bodyPr/>
           <a:lstStyle/>
           <a:p>
-            <a:fld id="{2E7CC9F0-B487-409B-B9EC-A5FEB68BFF69}" type="datetimeFigureOut">
+            <a:fld id="{786828E8-20EE-4859-BAAE-B9CDE9EE438F}" type="datetimeFigureOut">
               <a:rPr lang="en-US" smtClean="0"/>
-              <a:t>3/14/2026</a:t>
+              <a:t>3/15/2026</a:t>
             </a:fld>
             <a:endParaRPr lang="en-US"/>
           </a:p>
@@ -2400,7 +2395,7 @@
           <p:cNvPr id="6" name="Footer Placeholder 5">
             <a:extLst>
               <a:ext uri="{FF2B5EF4-FFF2-40B4-BE49-F238E27FC236}">
-                <a16:creationId xmlns:a16="http://schemas.microsoft.com/office/drawing/2014/main" id="{C0097C96-4C32-DCCA-46C7-645A408F5663}"/>
+                <a16:creationId xmlns:a16="http://schemas.microsoft.com/office/drawing/2014/main" id="{CB1425A7-16E7-8C5C-C3C9-CFD6E9CBB9A8}"/>
               </a:ext>
             </a:extLst>
           </p:cNvPr>
@@ -2425,7 +2420,7 @@
           <p:cNvPr id="7" name="Slide Number Placeholder 6">
             <a:extLst>
               <a:ext uri="{FF2B5EF4-FFF2-40B4-BE49-F238E27FC236}">
-                <a16:creationId xmlns:a16="http://schemas.microsoft.com/office/drawing/2014/main" id="{40A9F324-680B-5DB3-A634-5BCC8BAE1654}"/>
+                <a16:creationId xmlns:a16="http://schemas.microsoft.com/office/drawing/2014/main" id="{C0696EDE-936B-B49E-F6F6-067D9B826CE2}"/>
               </a:ext>
             </a:extLst>
           </p:cNvPr>
@@ -2441,7 +2436,7 @@
           <a:bodyPr/>
           <a:lstStyle/>
           <a:p>
-            <a:fld id="{7995F91C-4081-451F-BC6A-865794E1C2C2}" type="slidenum">
+            <a:fld id="{054C1CFB-DF71-4524-B094-74DF5D3566FA}" type="slidenum">
               <a:rPr lang="en-US" smtClean="0"/>
               <a:t>‹#›</a:t>
             </a:fld>
@@ -2452,7 +2447,7 @@
     </p:spTree>
     <p:extLst>
       <p:ext uri="{BB962C8B-B14F-4D97-AF65-F5344CB8AC3E}">
-        <p14:creationId xmlns:p14="http://schemas.microsoft.com/office/powerpoint/2010/main" val="1922225120"/>
+        <p14:creationId xmlns:p14="http://schemas.microsoft.com/office/powerpoint/2010/main" val="3563731944"/>
       </p:ext>
     </p:extLst>
   </p:cSld>
@@ -2484,7 +2479,7 @@
           <p:cNvPr id="2" name="Title 1">
             <a:extLst>
               <a:ext uri="{FF2B5EF4-FFF2-40B4-BE49-F238E27FC236}">
-                <a16:creationId xmlns:a16="http://schemas.microsoft.com/office/drawing/2014/main" id="{93D5BC86-FD3F-C2A1-942B-C385C89F7F9A}"/>
+                <a16:creationId xmlns:a16="http://schemas.microsoft.com/office/drawing/2014/main" id="{86FC773E-7F77-B262-198E-4B4C5394E6F9}"/>
               </a:ext>
             </a:extLst>
           </p:cNvPr>
@@ -2521,7 +2516,7 @@
           <p:cNvPr id="3" name="Picture Placeholder 2">
             <a:extLst>
               <a:ext uri="{FF2B5EF4-FFF2-40B4-BE49-F238E27FC236}">
-                <a16:creationId xmlns:a16="http://schemas.microsoft.com/office/drawing/2014/main" id="{CF30F860-6C78-E6DC-452F-4F8B41FC3084}"/>
+                <a16:creationId xmlns:a16="http://schemas.microsoft.com/office/drawing/2014/main" id="{7048E2D5-F8DB-76E8-522A-498939CA4BA3}"/>
               </a:ext>
             </a:extLst>
           </p:cNvPr>
@@ -2588,7 +2583,7 @@
           <p:cNvPr id="4" name="Text Placeholder 3">
             <a:extLst>
               <a:ext uri="{FF2B5EF4-FFF2-40B4-BE49-F238E27FC236}">
-                <a16:creationId xmlns:a16="http://schemas.microsoft.com/office/drawing/2014/main" id="{B168E3EC-DD3A-2CF5-B6AB-256EA8AAB883}"/>
+                <a16:creationId xmlns:a16="http://schemas.microsoft.com/office/drawing/2014/main" id="{4FA8656F-9EE6-41DC-3D40-05ADD4EAF9B0}"/>
               </a:ext>
             </a:extLst>
           </p:cNvPr>
@@ -2659,7 +2654,7 @@
           <p:cNvPr id="5" name="Date Placeholder 4">
             <a:extLst>
               <a:ext uri="{FF2B5EF4-FFF2-40B4-BE49-F238E27FC236}">
-                <a16:creationId xmlns:a16="http://schemas.microsoft.com/office/drawing/2014/main" id="{ABCCF8DF-ABB7-0D91-3481-E0AB5A9EC45E}"/>
+                <a16:creationId xmlns:a16="http://schemas.microsoft.com/office/drawing/2014/main" id="{CC0B8812-4C0F-9A48-A1A9-C3737B9184E8}"/>
               </a:ext>
             </a:extLst>
           </p:cNvPr>
@@ -2675,9 +2670,9 @@
           <a:bodyPr/>
           <a:lstStyle/>
           <a:p>
-            <a:fld id="{2E7CC9F0-B487-409B-B9EC-A5FEB68BFF69}" type="datetimeFigureOut">
+            <a:fld id="{786828E8-20EE-4859-BAAE-B9CDE9EE438F}" type="datetimeFigureOut">
               <a:rPr lang="en-US" smtClean="0"/>
-              <a:t>3/14/2026</a:t>
+              <a:t>3/15/2026</a:t>
             </a:fld>
             <a:endParaRPr lang="en-US"/>
           </a:p>
@@ -2688,7 +2683,7 @@
           <p:cNvPr id="6" name="Footer Placeholder 5">
             <a:extLst>
               <a:ext uri="{FF2B5EF4-FFF2-40B4-BE49-F238E27FC236}">
-                <a16:creationId xmlns:a16="http://schemas.microsoft.com/office/drawing/2014/main" id="{0098B97B-51EA-A78D-ADEC-05832F345FCF}"/>
+                <a16:creationId xmlns:a16="http://schemas.microsoft.com/office/drawing/2014/main" id="{07BA516D-FB46-04FA-AC1B-A3D67E521471}"/>
               </a:ext>
             </a:extLst>
           </p:cNvPr>
@@ -2713,7 +2708,7 @@
           <p:cNvPr id="7" name="Slide Number Placeholder 6">
             <a:extLst>
               <a:ext uri="{FF2B5EF4-FFF2-40B4-BE49-F238E27FC236}">
-                <a16:creationId xmlns:a16="http://schemas.microsoft.com/office/drawing/2014/main" id="{10131244-3580-C0A3-817D-B3E8E57D2B90}"/>
+                <a16:creationId xmlns:a16="http://schemas.microsoft.com/office/drawing/2014/main" id="{2B090F50-1D77-C3C7-8630-7BAFBEAF3DED}"/>
               </a:ext>
             </a:extLst>
           </p:cNvPr>
@@ -2729,7 +2724,7 @@
           <a:bodyPr/>
           <a:lstStyle/>
           <a:p>
-            <a:fld id="{7995F91C-4081-451F-BC6A-865794E1C2C2}" type="slidenum">
+            <a:fld id="{054C1CFB-DF71-4524-B094-74DF5D3566FA}" type="slidenum">
               <a:rPr lang="en-US" smtClean="0"/>
               <a:t>‹#›</a:t>
             </a:fld>
@@ -2740,7 +2735,7 @@
     </p:spTree>
     <p:extLst>
       <p:ext uri="{BB962C8B-B14F-4D97-AF65-F5344CB8AC3E}">
-        <p14:creationId xmlns:p14="http://schemas.microsoft.com/office/powerpoint/2010/main" val="259810496"/>
+        <p14:creationId xmlns:p14="http://schemas.microsoft.com/office/powerpoint/2010/main" val="3168977514"/>
       </p:ext>
     </p:extLst>
   </p:cSld>
@@ -2777,7 +2772,7 @@
           <p:cNvPr id="2" name="Title Placeholder 1">
             <a:extLst>
               <a:ext uri="{FF2B5EF4-FFF2-40B4-BE49-F238E27FC236}">
-                <a16:creationId xmlns:a16="http://schemas.microsoft.com/office/drawing/2014/main" id="{D1DB79D7-710F-6C6B-D0EA-78126DF559C7}"/>
+                <a16:creationId xmlns:a16="http://schemas.microsoft.com/office/drawing/2014/main" id="{84F57DFE-D4AF-777A-559D-5D22E7C876B5}"/>
               </a:ext>
             </a:extLst>
           </p:cNvPr>
@@ -2815,7 +2810,7 @@
           <p:cNvPr id="3" name="Text Placeholder 2">
             <a:extLst>
               <a:ext uri="{FF2B5EF4-FFF2-40B4-BE49-F238E27FC236}">
-                <a16:creationId xmlns:a16="http://schemas.microsoft.com/office/drawing/2014/main" id="{AEA04CE5-03CB-57AE-C6A6-2B121BB8DBAC}"/>
+                <a16:creationId xmlns:a16="http://schemas.microsoft.com/office/drawing/2014/main" id="{820C2225-1F7C-3688-2A00-EC68669BB3CE}"/>
               </a:ext>
             </a:extLst>
           </p:cNvPr>
@@ -2882,7 +2877,7 @@
           <p:cNvPr id="4" name="Date Placeholder 3">
             <a:extLst>
               <a:ext uri="{FF2B5EF4-FFF2-40B4-BE49-F238E27FC236}">
-                <a16:creationId xmlns:a16="http://schemas.microsoft.com/office/drawing/2014/main" id="{E7C16589-09D7-9717-2EB9-497A374C291F}"/>
+                <a16:creationId xmlns:a16="http://schemas.microsoft.com/office/drawing/2014/main" id="{9D2F8578-788C-BBA4-A25E-09DE46AEA563}"/>
               </a:ext>
             </a:extLst>
           </p:cNvPr>
@@ -2916,9 +2911,9 @@
             </a:lvl1pPr>
           </a:lstStyle>
           <a:p>
-            <a:fld id="{2E7CC9F0-B487-409B-B9EC-A5FEB68BFF69}" type="datetimeFigureOut">
+            <a:fld id="{786828E8-20EE-4859-BAAE-B9CDE9EE438F}" type="datetimeFigureOut">
               <a:rPr lang="en-US" smtClean="0"/>
-              <a:t>3/14/2026</a:t>
+              <a:t>3/15/2026</a:t>
             </a:fld>
             <a:endParaRPr lang="en-US"/>
           </a:p>
@@ -2929,7 +2924,7 @@
           <p:cNvPr id="5" name="Footer Placeholder 4">
             <a:extLst>
               <a:ext uri="{FF2B5EF4-FFF2-40B4-BE49-F238E27FC236}">
-                <a16:creationId xmlns:a16="http://schemas.microsoft.com/office/drawing/2014/main" id="{2586C4C5-0F5D-4982-B6DF-D3F188B0BC42}"/>
+                <a16:creationId xmlns:a16="http://schemas.microsoft.com/office/drawing/2014/main" id="{85A8CAAE-F1BC-A677-29E9-26BA2114E837}"/>
               </a:ext>
             </a:extLst>
           </p:cNvPr>
@@ -2972,7 +2967,7 @@
           <p:cNvPr id="6" name="Slide Number Placeholder 5">
             <a:extLst>
               <a:ext uri="{FF2B5EF4-FFF2-40B4-BE49-F238E27FC236}">
-                <a16:creationId xmlns:a16="http://schemas.microsoft.com/office/drawing/2014/main" id="{35595DCB-C41D-A614-8E33-1CF202D64F51}"/>
+                <a16:creationId xmlns:a16="http://schemas.microsoft.com/office/drawing/2014/main" id="{1678ECD2-11EE-A4EC-DD9B-9EA4A52FDB85}"/>
               </a:ext>
             </a:extLst>
           </p:cNvPr>
@@ -3006,7 +3001,7 @@
             </a:lvl1pPr>
           </a:lstStyle>
           <a:p>
-            <a:fld id="{7995F91C-4081-451F-BC6A-865794E1C2C2}" type="slidenum">
+            <a:fld id="{054C1CFB-DF71-4524-B094-74DF5D3566FA}" type="slidenum">
               <a:rPr lang="en-US" smtClean="0"/>
               <a:t>‹#›</a:t>
             </a:fld>
@@ -3014,60 +3009,10 @@
           </a:p>
         </p:txBody>
       </p:sp>
-      <p:sp>
-        <p:nvSpPr>
-          <p:cNvPr id="8" name="TextBox 7">
-            <a:extLst>
-              <a:ext uri="{FF2B5EF4-FFF2-40B4-BE49-F238E27FC236}">
-                <a16:creationId xmlns:a16="http://schemas.microsoft.com/office/drawing/2014/main" id="{6AA614A2-33A3-8699-D0DE-0435563FF286}"/>
-              </a:ext>
-            </a:extLst>
-          </p:cNvPr>
-          <p:cNvSpPr txBox="1"/>
-          <p:nvPr userDrawn="1">
-            <p:extLst>
-              <p:ext uri="{1162E1C5-73C7-4A58-AE30-91384D911F3F}">
-                <p184:classification xmlns:p184="http://schemas.microsoft.com/office/powerpoint/2018/4/main" val="ftr"/>
-              </p:ext>
-            </p:extLst>
-          </p:nvPr>
-        </p:nvSpPr>
-        <p:spPr>
-          <a:xfrm>
-            <a:off x="5661787" y="6672580"/>
-            <a:ext cx="890588" cy="121920"/>
-          </a:xfrm>
-          <a:prstGeom prst="rect">
-            <a:avLst/>
-          </a:prstGeom>
-        </p:spPr>
-        <p:txBody>
-          <a:bodyPr horzOverflow="overflow" lIns="0" tIns="0" rIns="0" bIns="0">
-            <a:spAutoFit/>
-          </a:bodyPr>
-          <a:lstStyle/>
-          <a:p>
-            <a:pPr algn="l"/>
-            <a:r>
-              <a:rPr lang="en-US" sz="800">
-                <a:solidFill>
-                  <a:srgbClr val="000000">
-                    <a:alpha val="50000"/>
-                  </a:srgbClr>
-                </a:solidFill>
-                <a:latin typeface="Calibri" panose="020F0502020204030204" pitchFamily="34" charset="0"/>
-                <a:ea typeface="Calibri" panose="020F0502020204030204" pitchFamily="34" charset="0"/>
-                <a:cs typeface="Calibri" panose="020F0502020204030204" pitchFamily="34" charset="0"/>
-              </a:rPr>
-              <a:t>-Bruker Confidential-</a:t>
-            </a:r>
-          </a:p>
-        </p:txBody>
-      </p:sp>
     </p:spTree>
     <p:extLst>
       <p:ext uri="{BB962C8B-B14F-4D97-AF65-F5344CB8AC3E}">
-        <p14:creationId xmlns:p14="http://schemas.microsoft.com/office/powerpoint/2010/main" val="826971478"/>
+        <p14:creationId xmlns:p14="http://schemas.microsoft.com/office/powerpoint/2010/main" val="626482043"/>
       </p:ext>
     </p:extLst>
   </p:cSld>
@@ -3390,7 +3335,7 @@
           <p:cNvPr id="2" name="Title 1">
             <a:extLst>
               <a:ext uri="{FF2B5EF4-FFF2-40B4-BE49-F238E27FC236}">
-                <a16:creationId xmlns:a16="http://schemas.microsoft.com/office/drawing/2014/main" id="{392DCF7F-4038-4CEB-BFE4-246803BCE100}"/>
+                <a16:creationId xmlns:a16="http://schemas.microsoft.com/office/drawing/2014/main" id="{A1349707-2E76-C7FA-E7AB-1539F7354694}"/>
               </a:ext>
             </a:extLst>
           </p:cNvPr>
@@ -3418,7 +3363,7 @@
           <p:cNvPr id="3" name="Subtitle 2">
             <a:extLst>
               <a:ext uri="{FF2B5EF4-FFF2-40B4-BE49-F238E27FC236}">
-                <a16:creationId xmlns:a16="http://schemas.microsoft.com/office/drawing/2014/main" id="{D2DC4A7C-A4A6-4E19-B358-A5D20686A4D0}"/>
+                <a16:creationId xmlns:a16="http://schemas.microsoft.com/office/drawing/2014/main" id="{274BF248-61C7-C3B7-6855-53D018BF3230}"/>
               </a:ext>
             </a:extLst>
           </p:cNvPr>
@@ -3436,7 +3381,7 @@
           <a:p>
             <a:r>
               <a:rPr lang="en-US" dirty="0"/>
-              <a:t>12/14/2024</a:t>
+              <a:t>03/15/2026</a:t>
             </a:r>
           </a:p>
         </p:txBody>
@@ -3444,7 +3389,7 @@
     </p:spTree>
     <p:extLst>
       <p:ext uri="{BB962C8B-B14F-4D97-AF65-F5344CB8AC3E}">
-        <p14:creationId xmlns:p14="http://schemas.microsoft.com/office/powerpoint/2010/main" val="3877000392"/>
+        <p14:creationId xmlns:p14="http://schemas.microsoft.com/office/powerpoint/2010/main" val="3812947566"/>
       </p:ext>
     </p:extLst>
   </p:cSld>
@@ -3459,13 +3404,7 @@
   <p:cSld>
     <p:spTree>
       <p:nvGrpSpPr>
-        <p:cNvPr id="1" name="">
-          <a:extLst>
-            <a:ext uri="{FF2B5EF4-FFF2-40B4-BE49-F238E27FC236}">
-              <a16:creationId xmlns:a16="http://schemas.microsoft.com/office/drawing/2014/main" id="{8BEEC054-DD2A-EB4E-682E-AB080E885367}"/>
-            </a:ext>
-          </a:extLst>
-        </p:cNvPr>
+        <p:cNvPr id="1" name=""/>
         <p:cNvGrpSpPr/>
         <p:nvPr/>
       </p:nvGrpSpPr>
@@ -3482,7 +3421,7 @@
           <p:cNvPr id="2" name="Title 1">
             <a:extLst>
               <a:ext uri="{FF2B5EF4-FFF2-40B4-BE49-F238E27FC236}">
-                <a16:creationId xmlns:a16="http://schemas.microsoft.com/office/drawing/2014/main" id="{52A3FB3F-242A-2982-140E-F63ACF6E10C4}"/>
+                <a16:creationId xmlns:a16="http://schemas.microsoft.com/office/drawing/2014/main" id="{F17DDD3E-88D7-AFD3-9F2F-7436C1B373CC}"/>
               </a:ext>
             </a:extLst>
           </p:cNvPr>
@@ -3510,7 +3449,7 @@
           <p:cNvPr id="4" name="TextBox 3">
             <a:extLst>
               <a:ext uri="{FF2B5EF4-FFF2-40B4-BE49-F238E27FC236}">
-                <a16:creationId xmlns:a16="http://schemas.microsoft.com/office/drawing/2014/main" id="{C4988A63-7D86-337A-45C2-8FDE406C2480}"/>
+                <a16:creationId xmlns:a16="http://schemas.microsoft.com/office/drawing/2014/main" id="{CE68A530-16DC-21F5-9B61-98F56694AC97}"/>
               </a:ext>
             </a:extLst>
           </p:cNvPr>
@@ -3562,10 +3501,10 @@
       </p:sp>
       <p:sp>
         <p:nvSpPr>
-          <p:cNvPr id="3" name="TextBox 2">
-            <a:extLst>
-              <a:ext uri="{FF2B5EF4-FFF2-40B4-BE49-F238E27FC236}">
-                <a16:creationId xmlns:a16="http://schemas.microsoft.com/office/drawing/2014/main" id="{3595C6AF-0AA8-0F1E-E826-71D7A8E5D015}"/>
+          <p:cNvPr id="5" name="TextBox 4">
+            <a:extLst>
+              <a:ext uri="{FF2B5EF4-FFF2-40B4-BE49-F238E27FC236}">
+                <a16:creationId xmlns:a16="http://schemas.microsoft.com/office/drawing/2014/main" id="{DEBEBD2D-3422-3D9A-51E9-B8C86C50D8D6}"/>
               </a:ext>
             </a:extLst>
           </p:cNvPr>
@@ -3597,10 +3536,10 @@
       </p:sp>
       <p:sp>
         <p:nvSpPr>
-          <p:cNvPr id="5" name="TextBox 4">
-            <a:extLst>
-              <a:ext uri="{FF2B5EF4-FFF2-40B4-BE49-F238E27FC236}">
-                <a16:creationId xmlns:a16="http://schemas.microsoft.com/office/drawing/2014/main" id="{BE9AE51F-606F-EEE7-FA4C-52F64F031B79}"/>
+          <p:cNvPr id="6" name="TextBox 5">
+            <a:extLst>
+              <a:ext uri="{FF2B5EF4-FFF2-40B4-BE49-F238E27FC236}">
+                <a16:creationId xmlns:a16="http://schemas.microsoft.com/office/drawing/2014/main" id="{C0F01673-0C9F-2809-7235-2FBCDF69C029}"/>
               </a:ext>
             </a:extLst>
           </p:cNvPr>
@@ -3637,7 +3576,7 @@
     </p:spTree>
     <p:extLst>
       <p:ext uri="{BB962C8B-B14F-4D97-AF65-F5344CB8AC3E}">
-        <p14:creationId xmlns:p14="http://schemas.microsoft.com/office/powerpoint/2010/main" val="2842314208"/>
+        <p14:creationId xmlns:p14="http://schemas.microsoft.com/office/powerpoint/2010/main" val="268889006"/>
       </p:ext>
     </p:extLst>
   </p:cSld>
@@ -3669,7 +3608,7 @@
           <p:cNvPr id="2" name="Title 1">
             <a:extLst>
               <a:ext uri="{FF2B5EF4-FFF2-40B4-BE49-F238E27FC236}">
-                <a16:creationId xmlns:a16="http://schemas.microsoft.com/office/drawing/2014/main" id="{A7B874E7-5581-EAEF-C06C-6362B92FEBD1}"/>
+                <a16:creationId xmlns:a16="http://schemas.microsoft.com/office/drawing/2014/main" id="{9760C90B-65D8-C472-6812-BCD62AF000AB}"/>
               </a:ext>
             </a:extLst>
           </p:cNvPr>
@@ -3687,122 +3626,79 @@
           <a:p>
             <a:r>
               <a:rPr lang="en-US" dirty="0"/>
-              <a:t>Pulse Programmer Instruction</a:t>
-            </a:r>
-          </a:p>
-        </p:txBody>
-      </p:sp>
-      <p:sp>
-        <p:nvSpPr>
-          <p:cNvPr id="4" name="TextBox 3">
-            <a:extLst>
-              <a:ext uri="{FF2B5EF4-FFF2-40B4-BE49-F238E27FC236}">
-                <a16:creationId xmlns:a16="http://schemas.microsoft.com/office/drawing/2014/main" id="{CF560418-F109-F67B-C3FB-837F59004862}"/>
-              </a:ext>
-            </a:extLst>
-          </p:cNvPr>
-          <p:cNvSpPr txBox="1"/>
-          <p:nvPr/>
-        </p:nvSpPr>
-        <p:spPr>
-          <a:xfrm>
-            <a:off x="2350008" y="2532659"/>
-            <a:ext cx="7233070" cy="923330"/>
-          </a:xfrm>
-          <a:prstGeom prst="rect">
-            <a:avLst/>
-          </a:prstGeom>
-          <a:noFill/>
-        </p:spPr>
-        <p:txBody>
-          <a:bodyPr wrap="none" rtlCol="0">
-            <a:spAutoFit/>
-          </a:bodyPr>
+              <a:t>Specifications</a:t>
+            </a:r>
+          </a:p>
+        </p:txBody>
+      </p:sp>
+      <p:sp>
+        <p:nvSpPr>
+          <p:cNvPr id="3" name="Content Placeholder 2">
+            <a:extLst>
+              <a:ext uri="{FF2B5EF4-FFF2-40B4-BE49-F238E27FC236}">
+                <a16:creationId xmlns:a16="http://schemas.microsoft.com/office/drawing/2014/main" id="{D5526F27-6304-521F-7B0E-4BBF785DE91B}"/>
+              </a:ext>
+            </a:extLst>
+          </p:cNvPr>
+          <p:cNvSpPr>
+            <a:spLocks noGrp="1"/>
+          </p:cNvSpPr>
+          <p:nvPr>
+            <p:ph idx="1"/>
+          </p:nvPr>
+        </p:nvSpPr>
+        <p:spPr/>
+        <p:txBody>
+          <a:bodyPr/>
           <a:lstStyle/>
           <a:p>
             <a:r>
               <a:rPr lang="en-US" dirty="0"/>
-              <a:t>pulse	|	data	|	op code		|	delay</a:t>
-            </a:r>
-          </a:p>
-          <a:p>
+              <a:t>System Clock: 125 MHz</a:t>
+            </a:r>
+          </a:p>
+          <a:p>
+            <a:pPr lvl="1"/>
             <a:r>
               <a:rPr lang="en-US" dirty="0"/>
-              <a:t>8-bit		20-bit		4-bit			32-bit</a:t>
-            </a:r>
-          </a:p>
-          <a:p>
+              <a:t>8 ns period</a:t>
+            </a:r>
+          </a:p>
+          <a:p>
+            <a:pPr lvl="1"/>
             <a:r>
               <a:rPr lang="en-US" dirty="0"/>
-              <a:t>[63:56]		[55:36]		[35:32]			[31:0]</a:t>
-            </a:r>
-          </a:p>
-        </p:txBody>
-      </p:sp>
-      <p:pic>
-        <p:nvPicPr>
-          <p:cNvPr id="5" name="Picture 4">
-            <a:extLst>
-              <a:ext uri="{FF2B5EF4-FFF2-40B4-BE49-F238E27FC236}">
-                <a16:creationId xmlns:a16="http://schemas.microsoft.com/office/drawing/2014/main" id="{C1EF69F0-313B-92BA-39CF-167787B5E0FC}"/>
-              </a:ext>
-            </a:extLst>
-          </p:cNvPr>
-          <p:cNvPicPr>
-            <a:picLocks noChangeAspect="1"/>
-          </p:cNvPicPr>
-          <p:nvPr/>
-        </p:nvPicPr>
-        <p:blipFill>
-          <a:blip r:embed="rId2"/>
-          <a:stretch>
-            <a:fillRect/>
-          </a:stretch>
-        </p:blipFill>
-        <p:spPr>
-          <a:xfrm>
-            <a:off x="1437480" y="4167078"/>
-            <a:ext cx="2572109" cy="1228896"/>
-          </a:xfrm>
-          <a:prstGeom prst="rect">
-            <a:avLst/>
-          </a:prstGeom>
-        </p:spPr>
-      </p:pic>
-      <p:pic>
-        <p:nvPicPr>
-          <p:cNvPr id="7" name="Picture 6">
-            <a:extLst>
-              <a:ext uri="{FF2B5EF4-FFF2-40B4-BE49-F238E27FC236}">
-                <a16:creationId xmlns:a16="http://schemas.microsoft.com/office/drawing/2014/main" id="{65D1EA9E-0B9E-3915-633D-E0C93FFFA152}"/>
-              </a:ext>
-            </a:extLst>
-          </p:cNvPr>
-          <p:cNvPicPr>
-            <a:picLocks noChangeAspect="1"/>
-          </p:cNvPicPr>
-          <p:nvPr/>
-        </p:nvPicPr>
-        <p:blipFill>
-          <a:blip r:embed="rId3"/>
-          <a:stretch>
-            <a:fillRect/>
-          </a:stretch>
-        </p:blipFill>
-        <p:spPr>
-          <a:xfrm>
-            <a:off x="4866623" y="4510025"/>
-            <a:ext cx="2734057" cy="885949"/>
-          </a:xfrm>
-          <a:prstGeom prst="rect">
-            <a:avLst/>
-          </a:prstGeom>
-        </p:spPr>
-      </p:pic>
+              <a:t>LUT requires 3.5 ns</a:t>
+            </a:r>
+          </a:p>
+          <a:p>
+            <a:pPr lvl="1"/>
+            <a:r>
+              <a:rPr lang="en-US" dirty="0"/>
+              <a:t>250 MHz does not meet timing requirement</a:t>
+            </a:r>
+          </a:p>
+          <a:p>
+            <a:r>
+              <a:rPr lang="en-US" dirty="0"/>
+              <a:t>Pulse Programmer Outputs: 8</a:t>
+            </a:r>
+          </a:p>
+          <a:p>
+            <a:r>
+              <a:rPr lang="en-US" dirty="0"/>
+              <a:t>Memory Size: 12-bit (4096 addresses)</a:t>
+            </a:r>
+          </a:p>
+          <a:p>
+            <a:endParaRPr lang="en-US" dirty="0"/>
+          </a:p>
+        </p:txBody>
+      </p:sp>
     </p:spTree>
     <p:extLst>
       <p:ext uri="{BB962C8B-B14F-4D97-AF65-F5344CB8AC3E}">
-        <p14:creationId xmlns:p14="http://schemas.microsoft.com/office/powerpoint/2010/main" val="140642942"/>
+        <p14:creationId xmlns:p14="http://schemas.microsoft.com/office/powerpoint/2010/main" val="2915726403"/>
       </p:ext>
     </p:extLst>
   </p:cSld>
@@ -3834,7 +3730,7 @@
           <p:cNvPr id="2" name="Title 1">
             <a:extLst>
               <a:ext uri="{FF2B5EF4-FFF2-40B4-BE49-F238E27FC236}">
-                <a16:creationId xmlns:a16="http://schemas.microsoft.com/office/drawing/2014/main" id="{45CAC404-D806-6C8D-A657-2B7AB09A4430}"/>
+                <a16:creationId xmlns:a16="http://schemas.microsoft.com/office/drawing/2014/main" id="{412781B4-3B1E-6C30-0BD2-85069AF10DD6}"/>
               </a:ext>
             </a:extLst>
           </p:cNvPr>
@@ -3852,658 +3748,122 @@
           <a:p>
             <a:r>
               <a:rPr lang="en-US" dirty="0"/>
-              <a:t>Op Codes</a:t>
-            </a:r>
-          </a:p>
-        </p:txBody>
-      </p:sp>
-      <p:graphicFrame>
-        <p:nvGraphicFramePr>
-          <p:cNvPr id="4" name="Table 3">
-            <a:extLst>
-              <a:ext uri="{FF2B5EF4-FFF2-40B4-BE49-F238E27FC236}">
-                <a16:creationId xmlns:a16="http://schemas.microsoft.com/office/drawing/2014/main" id="{89A0579B-BB56-1EC4-3568-E92569F824EA}"/>
-              </a:ext>
-            </a:extLst>
-          </p:cNvPr>
-          <p:cNvGraphicFramePr>
-            <a:graphicFrameLocks noGrp="1"/>
-          </p:cNvGraphicFramePr>
-          <p:nvPr>
-            <p:extLst>
-              <p:ext uri="{D42A27DB-BD31-4B8C-83A1-F6EECF244321}">
-                <p14:modId xmlns:p14="http://schemas.microsoft.com/office/powerpoint/2010/main" val="1598966454"/>
-              </p:ext>
-            </p:extLst>
-          </p:nvPr>
-        </p:nvGraphicFramePr>
-        <p:xfrm>
-          <a:off x="566993" y="1845749"/>
-          <a:ext cx="11058014" cy="3571240"/>
-        </p:xfrm>
-        <a:graphic>
-          <a:graphicData uri="http://schemas.openxmlformats.org/drawingml/2006/table">
-            <a:tbl>
-              <a:tblPr firstRow="1" bandRow="1">
-                <a:tableStyleId>{5C22544A-7EE6-4342-B048-85BDC9FD1C3A}</a:tableStyleId>
-              </a:tblPr>
-              <a:tblGrid>
-                <a:gridCol w="1999786">
-                  <a:extLst>
-                    <a:ext uri="{9D8B030D-6E8A-4147-A177-3AD203B41FA5}">
-                      <a16:colId xmlns:a16="http://schemas.microsoft.com/office/drawing/2014/main" val="40757123"/>
-                    </a:ext>
-                  </a:extLst>
-                </a:gridCol>
-                <a:gridCol w="1547202">
-                  <a:extLst>
-                    <a:ext uri="{9D8B030D-6E8A-4147-A177-3AD203B41FA5}">
-                      <a16:colId xmlns:a16="http://schemas.microsoft.com/office/drawing/2014/main" val="4052018327"/>
-                    </a:ext>
-                  </a:extLst>
-                </a:gridCol>
-                <a:gridCol w="1504335">
-                  <a:extLst>
-                    <a:ext uri="{9D8B030D-6E8A-4147-A177-3AD203B41FA5}">
-                      <a16:colId xmlns:a16="http://schemas.microsoft.com/office/drawing/2014/main" val="978270031"/>
-                    </a:ext>
-                  </a:extLst>
-                </a:gridCol>
-                <a:gridCol w="2007121">
-                  <a:extLst>
-                    <a:ext uri="{9D8B030D-6E8A-4147-A177-3AD203B41FA5}">
-                      <a16:colId xmlns:a16="http://schemas.microsoft.com/office/drawing/2014/main" val="3865882804"/>
-                    </a:ext>
-                  </a:extLst>
-                </a:gridCol>
-                <a:gridCol w="1233428">
-                  <a:extLst>
-                    <a:ext uri="{9D8B030D-6E8A-4147-A177-3AD203B41FA5}">
-                      <a16:colId xmlns:a16="http://schemas.microsoft.com/office/drawing/2014/main" val="1540856599"/>
-                    </a:ext>
-                  </a:extLst>
-                </a:gridCol>
-                <a:gridCol w="2766142">
-                  <a:extLst>
-                    <a:ext uri="{9D8B030D-6E8A-4147-A177-3AD203B41FA5}">
-                      <a16:colId xmlns:a16="http://schemas.microsoft.com/office/drawing/2014/main" val="2786182465"/>
-                    </a:ext>
-                  </a:extLst>
-                </a:gridCol>
-              </a:tblGrid>
-              <a:tr h="370840">
-                <a:tc>
-                  <a:txBody>
-                    <a:bodyPr/>
-                    <a:lstStyle/>
-                    <a:p>
-                      <a:r>
-                        <a:rPr lang="en-US" dirty="0"/>
-                        <a:t>NAME</a:t>
-                      </a:r>
-                    </a:p>
-                  </a:txBody>
-                  <a:tcPr/>
-                </a:tc>
-                <a:tc>
-                  <a:txBody>
-                    <a:bodyPr/>
-                    <a:lstStyle/>
-                    <a:p>
-                      <a:r>
-                        <a:rPr lang="en-US" dirty="0"/>
-                        <a:t>OP CODE (BIN)</a:t>
-                      </a:r>
-                    </a:p>
-                  </a:txBody>
-                  <a:tcPr/>
-                </a:tc>
-                <a:tc>
-                  <a:txBody>
-                    <a:bodyPr/>
-                    <a:lstStyle/>
-                    <a:p>
-                      <a:r>
-                        <a:rPr lang="en-US" dirty="0"/>
-                        <a:t>OP CODE (INT)</a:t>
-                      </a:r>
-                    </a:p>
-                  </a:txBody>
-                  <a:tcPr/>
-                </a:tc>
-                <a:tc>
-                  <a:txBody>
-                    <a:bodyPr/>
-                    <a:lstStyle/>
-                    <a:p>
-                      <a:r>
-                        <a:rPr lang="en-US" dirty="0"/>
-                        <a:t>DELAY</a:t>
-                      </a:r>
-                    </a:p>
-                    <a:p>
-                      <a:r>
-                        <a:rPr lang="en-US" dirty="0"/>
-                        <a:t>VALUES</a:t>
-                      </a:r>
-                    </a:p>
-                  </a:txBody>
-                  <a:tcPr/>
-                </a:tc>
-                <a:tc>
-                  <a:txBody>
-                    <a:bodyPr/>
-                    <a:lstStyle/>
-                    <a:p>
-                      <a:r>
-                        <a:rPr lang="en-US" dirty="0"/>
-                        <a:t>DATA</a:t>
-                      </a:r>
-                    </a:p>
-                    <a:p>
-                      <a:r>
-                        <a:rPr lang="en-US" dirty="0"/>
-                        <a:t>VALUES</a:t>
-                      </a:r>
-                    </a:p>
-                  </a:txBody>
-                  <a:tcPr/>
-                </a:tc>
-                <a:tc>
-                  <a:txBody>
-                    <a:bodyPr/>
-                    <a:lstStyle/>
-                    <a:p>
-                      <a:r>
-                        <a:rPr lang="en-US" dirty="0"/>
-                        <a:t>DESC</a:t>
-                      </a:r>
-                    </a:p>
-                  </a:txBody>
-                  <a:tcPr/>
-                </a:tc>
-                <a:extLst>
-                  <a:ext uri="{0D108BD9-81ED-4DB2-BD59-A6C34878D82A}">
-                    <a16:rowId xmlns:a16="http://schemas.microsoft.com/office/drawing/2014/main" val="1433844262"/>
-                  </a:ext>
-                </a:extLst>
-              </a:tr>
-              <a:tr h="370840">
-                <a:tc>
-                  <a:txBody>
-                    <a:bodyPr/>
-                    <a:lstStyle/>
-                    <a:p>
-                      <a:r>
-                        <a:rPr lang="en-US" dirty="0"/>
-                        <a:t>NO OP</a:t>
-                      </a:r>
-                    </a:p>
-                  </a:txBody>
-                  <a:tcPr/>
-                </a:tc>
-                <a:tc>
-                  <a:txBody>
-                    <a:bodyPr/>
-                    <a:lstStyle/>
-                    <a:p>
-                      <a:r>
-                        <a:rPr lang="en-US" dirty="0"/>
-                        <a:t>0b0000</a:t>
-                      </a:r>
-                    </a:p>
-                  </a:txBody>
-                  <a:tcPr/>
-                </a:tc>
-                <a:tc>
-                  <a:txBody>
-                    <a:bodyPr/>
-                    <a:lstStyle/>
-                    <a:p>
-                      <a:r>
-                        <a:rPr lang="en-US" dirty="0"/>
-                        <a:t>0</a:t>
-                      </a:r>
-                    </a:p>
-                  </a:txBody>
-                  <a:tcPr/>
-                </a:tc>
-                <a:tc>
-                  <a:txBody>
-                    <a:bodyPr/>
-                    <a:lstStyle/>
-                    <a:p>
-                      <a:r>
-                        <a:rPr lang="en-US" dirty="0"/>
-                        <a:t>NA</a:t>
-                      </a:r>
-                    </a:p>
-                  </a:txBody>
-                  <a:tcPr/>
-                </a:tc>
-                <a:tc>
-                  <a:txBody>
-                    <a:bodyPr/>
-                    <a:lstStyle/>
-                    <a:p>
-                      <a:endParaRPr lang="en-US" dirty="0"/>
-                    </a:p>
-                  </a:txBody>
-                  <a:tcPr/>
-                </a:tc>
-                <a:tc>
-                  <a:txBody>
-                    <a:bodyPr/>
-                    <a:lstStyle/>
-                    <a:p>
-                      <a:r>
-                        <a:rPr lang="en-US" dirty="0"/>
-                        <a:t>NO OPERATION, GO TO NEXT ADDRESS</a:t>
-                      </a:r>
-                    </a:p>
-                  </a:txBody>
-                  <a:tcPr/>
-                </a:tc>
-                <a:extLst>
-                  <a:ext uri="{0D108BD9-81ED-4DB2-BD59-A6C34878D82A}">
-                    <a16:rowId xmlns:a16="http://schemas.microsoft.com/office/drawing/2014/main" val="3006052280"/>
-                  </a:ext>
-                </a:extLst>
-              </a:tr>
-              <a:tr h="370840">
-                <a:tc>
-                  <a:txBody>
-                    <a:bodyPr/>
-                    <a:lstStyle/>
-                    <a:p>
-                      <a:r>
-                        <a:rPr lang="en-US" dirty="0"/>
-                        <a:t>DELAY</a:t>
-                      </a:r>
-                    </a:p>
-                  </a:txBody>
-                  <a:tcPr/>
-                </a:tc>
-                <a:tc>
-                  <a:txBody>
-                    <a:bodyPr/>
-                    <a:lstStyle/>
-                    <a:p>
-                      <a:r>
-                        <a:rPr lang="en-US" dirty="0"/>
-                        <a:t>0b0001</a:t>
-                      </a:r>
-                    </a:p>
-                  </a:txBody>
-                  <a:tcPr/>
-                </a:tc>
-                <a:tc>
-                  <a:txBody>
-                    <a:bodyPr/>
-                    <a:lstStyle/>
-                    <a:p>
-                      <a:r>
-                        <a:rPr lang="en-US" dirty="0"/>
-                        <a:t>1</a:t>
-                      </a:r>
-                    </a:p>
-                  </a:txBody>
-                  <a:tcPr/>
-                </a:tc>
-                <a:tc>
-                  <a:txBody>
-                    <a:bodyPr/>
-                    <a:lstStyle/>
-                    <a:p>
-                      <a:r>
-                        <a:rPr lang="en-US" dirty="0"/>
-                        <a:t>0 to 2</a:t>
-                      </a:r>
-                      <a:r>
-                        <a:rPr lang="en-US" baseline="30000" dirty="0"/>
-                        <a:t>32</a:t>
-                      </a:r>
-                      <a:r>
-                        <a:rPr lang="en-US" baseline="0" dirty="0"/>
-                        <a:t>-1</a:t>
-                      </a:r>
-                    </a:p>
-                  </a:txBody>
-                  <a:tcPr/>
-                </a:tc>
-                <a:tc>
-                  <a:txBody>
-                    <a:bodyPr/>
-                    <a:lstStyle/>
-                    <a:p>
-                      <a:r>
-                        <a:rPr lang="en-US" dirty="0"/>
-                        <a:t>NA</a:t>
-                      </a:r>
-                    </a:p>
-                  </a:txBody>
-                  <a:tcPr/>
-                </a:tc>
-                <a:tc>
-                  <a:txBody>
-                    <a:bodyPr/>
-                    <a:lstStyle/>
-                    <a:p>
-                      <a:r>
-                        <a:rPr lang="en-US" dirty="0"/>
-                        <a:t>WAIT DELAY CLOCK CYCLES</a:t>
-                      </a:r>
-                    </a:p>
-                  </a:txBody>
-                  <a:tcPr/>
-                </a:tc>
-                <a:extLst>
-                  <a:ext uri="{0D108BD9-81ED-4DB2-BD59-A6C34878D82A}">
-                    <a16:rowId xmlns:a16="http://schemas.microsoft.com/office/drawing/2014/main" val="3071420913"/>
-                  </a:ext>
-                </a:extLst>
-              </a:tr>
-              <a:tr h="370840">
-                <a:tc>
-                  <a:txBody>
-                    <a:bodyPr/>
-                    <a:lstStyle/>
-                    <a:p>
-                      <a:r>
-                        <a:rPr lang="en-US" dirty="0"/>
-                        <a:t>LONG DELAY</a:t>
-                      </a:r>
-                    </a:p>
-                  </a:txBody>
-                  <a:tcPr/>
-                </a:tc>
-                <a:tc>
-                  <a:txBody>
-                    <a:bodyPr/>
-                    <a:lstStyle/>
-                    <a:p>
-                      <a:r>
-                        <a:rPr lang="en-US" dirty="0"/>
-                        <a:t>0b0010</a:t>
-                      </a:r>
-                    </a:p>
-                  </a:txBody>
-                  <a:tcPr/>
-                </a:tc>
-                <a:tc>
-                  <a:txBody>
-                    <a:bodyPr/>
-                    <a:lstStyle/>
-                    <a:p>
-                      <a:r>
-                        <a:rPr lang="en-US" dirty="0"/>
-                        <a:t>2</a:t>
-                      </a:r>
-                    </a:p>
-                  </a:txBody>
-                  <a:tcPr/>
-                </a:tc>
-                <a:tc>
-                  <a:txBody>
-                    <a:bodyPr/>
-                    <a:lstStyle/>
-                    <a:p>
-                      <a:r>
-                        <a:rPr lang="en-US" dirty="0"/>
-                        <a:t>0 to 2</a:t>
-                      </a:r>
-                      <a:r>
-                        <a:rPr lang="en-US" baseline="30000" dirty="0"/>
-                        <a:t>32</a:t>
-                      </a:r>
-                      <a:r>
-                        <a:rPr lang="en-US" baseline="0" dirty="0"/>
-                        <a:t>-1</a:t>
-                      </a:r>
-                      <a:endParaRPr lang="en-US" dirty="0"/>
-                    </a:p>
-                  </a:txBody>
-                  <a:tcPr/>
-                </a:tc>
-                <a:tc>
-                  <a:txBody>
-                    <a:bodyPr/>
-                    <a:lstStyle/>
-                    <a:p>
-                      <a:pPr marL="0" marR="0" lvl="0" indent="0" algn="l" defTabSz="914400" rtl="0" eaLnBrk="1" fontAlgn="auto" latinLnBrk="0" hangingPunct="1">
-                        <a:lnSpc>
-                          <a:spcPct val="100000"/>
-                        </a:lnSpc>
-                        <a:spcBef>
-                          <a:spcPts val="0"/>
-                        </a:spcBef>
-                        <a:spcAft>
-                          <a:spcPts val="0"/>
-                        </a:spcAft>
-                        <a:buClrTx/>
-                        <a:buSzTx/>
-                        <a:buFontTx/>
-                        <a:buNone/>
-                        <a:tabLst/>
-                        <a:defRPr/>
-                      </a:pPr>
-                      <a:r>
-                        <a:rPr lang="en-US" dirty="0"/>
-                        <a:t>0 to 2</a:t>
-                      </a:r>
-                      <a:r>
-                        <a:rPr lang="en-US" baseline="30000" dirty="0"/>
-                        <a:t>20</a:t>
-                      </a:r>
-                      <a:r>
-                        <a:rPr lang="en-US" baseline="0" dirty="0"/>
-                        <a:t>-1</a:t>
-                      </a:r>
-                      <a:endParaRPr lang="en-US" dirty="0"/>
-                    </a:p>
-                    <a:p>
-                      <a:endParaRPr lang="en-US" dirty="0"/>
-                    </a:p>
-                  </a:txBody>
-                  <a:tcPr/>
-                </a:tc>
-                <a:tc>
-                  <a:txBody>
-                    <a:bodyPr/>
-                    <a:lstStyle/>
-                    <a:p>
-                      <a:r>
-                        <a:rPr lang="en-US" dirty="0"/>
-                        <a:t>WAIT DELAY * DATA CLOCK CYCLES</a:t>
-                      </a:r>
-                    </a:p>
-                  </a:txBody>
-                  <a:tcPr/>
-                </a:tc>
-                <a:extLst>
-                  <a:ext uri="{0D108BD9-81ED-4DB2-BD59-A6C34878D82A}">
-                    <a16:rowId xmlns:a16="http://schemas.microsoft.com/office/drawing/2014/main" val="3244617026"/>
-                  </a:ext>
-                </a:extLst>
-              </a:tr>
-              <a:tr h="370840">
-                <a:tc>
-                  <a:txBody>
-                    <a:bodyPr/>
-                    <a:lstStyle/>
-                    <a:p>
-                      <a:r>
-                        <a:rPr lang="en-US" dirty="0"/>
-                        <a:t>JUMP</a:t>
-                      </a:r>
-                    </a:p>
-                  </a:txBody>
-                  <a:tcPr/>
-                </a:tc>
-                <a:tc>
-                  <a:txBody>
-                    <a:bodyPr/>
-                    <a:lstStyle/>
-                    <a:p>
-                      <a:r>
-                        <a:rPr lang="en-US" dirty="0"/>
-                        <a:t>0b0011</a:t>
-                      </a:r>
-                    </a:p>
-                  </a:txBody>
-                  <a:tcPr/>
-                </a:tc>
-                <a:tc>
-                  <a:txBody>
-                    <a:bodyPr/>
-                    <a:lstStyle/>
-                    <a:p>
-                      <a:r>
-                        <a:rPr lang="en-US" dirty="0"/>
-                        <a:t>3</a:t>
-                      </a:r>
-                    </a:p>
-                  </a:txBody>
-                  <a:tcPr/>
-                </a:tc>
-                <a:tc>
-                  <a:txBody>
-                    <a:bodyPr/>
-                    <a:lstStyle/>
-                    <a:p>
-                      <a:r>
-                        <a:rPr lang="en-US" dirty="0"/>
-                        <a:t>NA</a:t>
-                      </a:r>
-                    </a:p>
-                  </a:txBody>
-                  <a:tcPr/>
-                </a:tc>
-                <a:tc>
-                  <a:txBody>
-                    <a:bodyPr/>
-                    <a:lstStyle/>
-                    <a:p>
-                      <a:r>
-                        <a:rPr lang="en-US" dirty="0"/>
-                        <a:t>ADDRESS</a:t>
-                      </a:r>
-                    </a:p>
-                  </a:txBody>
-                  <a:tcPr/>
-                </a:tc>
-                <a:tc>
-                  <a:txBody>
-                    <a:bodyPr/>
-                    <a:lstStyle/>
-                    <a:p>
-                      <a:r>
-                        <a:rPr lang="en-US" dirty="0"/>
-                        <a:t>JUMP TO ADDRESS</a:t>
-                      </a:r>
-                    </a:p>
-                  </a:txBody>
-                  <a:tcPr/>
-                </a:tc>
-                <a:extLst>
-                  <a:ext uri="{0D108BD9-81ED-4DB2-BD59-A6C34878D82A}">
-                    <a16:rowId xmlns:a16="http://schemas.microsoft.com/office/drawing/2014/main" val="3161441252"/>
-                  </a:ext>
-                </a:extLst>
-              </a:tr>
-              <a:tr h="370840">
-                <a:tc>
-                  <a:txBody>
-                    <a:bodyPr/>
-                    <a:lstStyle/>
-                    <a:p>
-                      <a:r>
-                        <a:rPr lang="en-US" dirty="0"/>
-                        <a:t>WAIT</a:t>
-                      </a:r>
-                    </a:p>
-                  </a:txBody>
-                  <a:tcPr/>
-                </a:tc>
-                <a:tc>
-                  <a:txBody>
-                    <a:bodyPr/>
-                    <a:lstStyle/>
-                    <a:p>
-                      <a:r>
-                        <a:rPr lang="en-US" dirty="0"/>
-                        <a:t>0b0100</a:t>
-                      </a:r>
-                    </a:p>
-                  </a:txBody>
-                  <a:tcPr/>
-                </a:tc>
-                <a:tc>
-                  <a:txBody>
-                    <a:bodyPr/>
-                    <a:lstStyle/>
-                    <a:p>
-                      <a:r>
-                        <a:rPr lang="en-US" dirty="0"/>
-                        <a:t>4</a:t>
-                      </a:r>
-                    </a:p>
-                  </a:txBody>
-                  <a:tcPr/>
-                </a:tc>
-                <a:tc>
-                  <a:txBody>
-                    <a:bodyPr/>
-                    <a:lstStyle/>
-                    <a:p>
-                      <a:r>
-                        <a:rPr lang="en-US" dirty="0"/>
-                        <a:t>NA</a:t>
-                      </a:r>
-                    </a:p>
-                  </a:txBody>
-                  <a:tcPr/>
-                </a:tc>
-                <a:tc>
-                  <a:txBody>
-                    <a:bodyPr/>
-                    <a:lstStyle/>
-                    <a:p>
-                      <a:r>
-                        <a:rPr lang="en-US" dirty="0"/>
-                        <a:t>NA</a:t>
-                      </a:r>
-                    </a:p>
-                  </a:txBody>
-                  <a:tcPr/>
-                </a:tc>
-                <a:tc>
-                  <a:txBody>
-                    <a:bodyPr/>
-                    <a:lstStyle/>
-                    <a:p>
-                      <a:r>
-                        <a:rPr lang="en-US" dirty="0"/>
-                        <a:t>WAIT FOR TIGGER SIGNAL (POS ENABLE)</a:t>
-                      </a:r>
-                    </a:p>
-                  </a:txBody>
-                  <a:tcPr/>
-                </a:tc>
-                <a:extLst>
-                  <a:ext uri="{0D108BD9-81ED-4DB2-BD59-A6C34878D82A}">
-                    <a16:rowId xmlns:a16="http://schemas.microsoft.com/office/drawing/2014/main" val="1157835799"/>
-                  </a:ext>
-                </a:extLst>
-              </a:tr>
-            </a:tbl>
-          </a:graphicData>
-        </a:graphic>
-      </p:graphicFrame>
+              <a:t>Instructions</a:t>
+            </a:r>
+          </a:p>
+        </p:txBody>
+      </p:sp>
+      <p:sp>
+        <p:nvSpPr>
+          <p:cNvPr id="5" name="TextBox 4">
+            <a:extLst>
+              <a:ext uri="{FF2B5EF4-FFF2-40B4-BE49-F238E27FC236}">
+                <a16:creationId xmlns:a16="http://schemas.microsoft.com/office/drawing/2014/main" id="{04D6D090-8EFE-F0D3-0A2B-E94EACA27B2A}"/>
+              </a:ext>
+            </a:extLst>
+          </p:cNvPr>
+          <p:cNvSpPr txBox="1"/>
+          <p:nvPr/>
+        </p:nvSpPr>
+        <p:spPr>
+          <a:xfrm>
+            <a:off x="2350008" y="2532659"/>
+            <a:ext cx="7233070" cy="923330"/>
+          </a:xfrm>
+          <a:prstGeom prst="rect">
+            <a:avLst/>
+          </a:prstGeom>
+          <a:noFill/>
+        </p:spPr>
+        <p:txBody>
+          <a:bodyPr wrap="none" rtlCol="0">
+            <a:spAutoFit/>
+          </a:bodyPr>
+          <a:lstStyle/>
+          <a:p>
+            <a:r>
+              <a:rPr lang="en-US" dirty="0"/>
+              <a:t>pulse	|	data	|	op code		|	delay</a:t>
+            </a:r>
+          </a:p>
+          <a:p>
+            <a:r>
+              <a:rPr lang="en-US" dirty="0"/>
+              <a:t>8-bit		20-bit		4-bit			32-bit</a:t>
+            </a:r>
+          </a:p>
+          <a:p>
+            <a:r>
+              <a:rPr lang="en-US" dirty="0"/>
+              <a:t>[63:56]		[55:36]		[35:32]			[31:0]</a:t>
+            </a:r>
+          </a:p>
+        </p:txBody>
+      </p:sp>
+      <p:pic>
+        <p:nvPicPr>
+          <p:cNvPr id="6" name="Picture 5">
+            <a:extLst>
+              <a:ext uri="{FF2B5EF4-FFF2-40B4-BE49-F238E27FC236}">
+                <a16:creationId xmlns:a16="http://schemas.microsoft.com/office/drawing/2014/main" id="{22B20F72-63DC-66FE-A797-3821C7B8EA83}"/>
+              </a:ext>
+            </a:extLst>
+          </p:cNvPr>
+          <p:cNvPicPr>
+            <a:picLocks noChangeAspect="1"/>
+          </p:cNvPicPr>
+          <p:nvPr/>
+        </p:nvPicPr>
+        <p:blipFill>
+          <a:blip r:embed="rId2"/>
+          <a:stretch>
+            <a:fillRect/>
+          </a:stretch>
+        </p:blipFill>
+        <p:spPr>
+          <a:xfrm>
+            <a:off x="1437480" y="4167078"/>
+            <a:ext cx="2572109" cy="1228896"/>
+          </a:xfrm>
+          <a:prstGeom prst="rect">
+            <a:avLst/>
+          </a:prstGeom>
+        </p:spPr>
+      </p:pic>
+      <p:pic>
+        <p:nvPicPr>
+          <p:cNvPr id="7" name="Picture 6">
+            <a:extLst>
+              <a:ext uri="{FF2B5EF4-FFF2-40B4-BE49-F238E27FC236}">
+                <a16:creationId xmlns:a16="http://schemas.microsoft.com/office/drawing/2014/main" id="{D77F3DD4-71E7-8CA1-053A-C01DFA16CC1C}"/>
+              </a:ext>
+            </a:extLst>
+          </p:cNvPr>
+          <p:cNvPicPr>
+            <a:picLocks noChangeAspect="1"/>
+          </p:cNvPicPr>
+          <p:nvPr/>
+        </p:nvPicPr>
+        <p:blipFill>
+          <a:blip r:embed="rId3"/>
+          <a:stretch>
+            <a:fillRect/>
+          </a:stretch>
+        </p:blipFill>
+        <p:spPr>
+          <a:xfrm>
+            <a:off x="4866623" y="4510025"/>
+            <a:ext cx="2734057" cy="885949"/>
+          </a:xfrm>
+          <a:prstGeom prst="rect">
+            <a:avLst/>
+          </a:prstGeom>
+        </p:spPr>
+      </p:pic>
     </p:spTree>
     <p:extLst>
       <p:ext uri="{BB962C8B-B14F-4D97-AF65-F5344CB8AC3E}">
-        <p14:creationId xmlns:p14="http://schemas.microsoft.com/office/powerpoint/2010/main" val="4279889304"/>
+        <p14:creationId xmlns:p14="http://schemas.microsoft.com/office/powerpoint/2010/main" val="1839359544"/>
       </p:ext>
     </p:extLst>
   </p:cSld>
@@ -4535,7 +3895,7 @@
           <p:cNvPr id="2" name="Title 1">
             <a:extLst>
               <a:ext uri="{FF2B5EF4-FFF2-40B4-BE49-F238E27FC236}">
-                <a16:creationId xmlns:a16="http://schemas.microsoft.com/office/drawing/2014/main" id="{8984A156-FE75-3D8F-9580-18E11DDB2DE3}"/>
+                <a16:creationId xmlns:a16="http://schemas.microsoft.com/office/drawing/2014/main" id="{267F2981-B252-11B2-8F34-BAED06EF58F0}"/>
               </a:ext>
             </a:extLst>
           </p:cNvPr>
@@ -4563,7 +3923,7 @@
           <p:cNvPr id="3" name="Content Placeholder 2">
             <a:extLst>
               <a:ext uri="{FF2B5EF4-FFF2-40B4-BE49-F238E27FC236}">
-                <a16:creationId xmlns:a16="http://schemas.microsoft.com/office/drawing/2014/main" id="{48DDE207-E5E1-8F55-50FB-24AC2722C9A8}"/>
+                <a16:creationId xmlns:a16="http://schemas.microsoft.com/office/drawing/2014/main" id="{8778FB06-1A30-5A96-548F-80DD2FC7A7DA}"/>
               </a:ext>
             </a:extLst>
           </p:cNvPr>
@@ -4645,14 +4005,17 @@
               <a:t>External Clock?</a:t>
             </a:r>
           </a:p>
+          <a:p>
+            <a:endParaRPr lang="en-US" dirty="0"/>
+          </a:p>
         </p:txBody>
       </p:sp>
       <p:pic>
         <p:nvPicPr>
-          <p:cNvPr id="5" name="Picture 4">
-            <a:extLst>
-              <a:ext uri="{FF2B5EF4-FFF2-40B4-BE49-F238E27FC236}">
-                <a16:creationId xmlns:a16="http://schemas.microsoft.com/office/drawing/2014/main" id="{BF1EF15A-7ACA-BE49-19A4-C6EA5EEA5D77}"/>
+          <p:cNvPr id="4" name="Picture 3">
+            <a:extLst>
+              <a:ext uri="{FF2B5EF4-FFF2-40B4-BE49-F238E27FC236}">
+                <a16:creationId xmlns:a16="http://schemas.microsoft.com/office/drawing/2014/main" id="{F3B08860-21F7-4808-F39D-47A69BF8B5E1}"/>
               </a:ext>
             </a:extLst>
           </p:cNvPr>
@@ -4669,7 +4032,7 @@
         </p:blipFill>
         <p:spPr>
           <a:xfrm>
-            <a:off x="8055084" y="3811225"/>
+            <a:off x="8222233" y="3358941"/>
             <a:ext cx="2534004" cy="838317"/>
           </a:xfrm>
           <a:prstGeom prst="rect">
@@ -4679,10 +4042,10 @@
       </p:pic>
       <p:pic>
         <p:nvPicPr>
-          <p:cNvPr id="6" name="Picture 5">
-            <a:extLst>
-              <a:ext uri="{FF2B5EF4-FFF2-40B4-BE49-F238E27FC236}">
-                <a16:creationId xmlns:a16="http://schemas.microsoft.com/office/drawing/2014/main" id="{5FF0A7DA-433E-1289-16D8-9BFD4DF1BFD0}"/>
+          <p:cNvPr id="5" name="Picture 4">
+            <a:extLst>
+              <a:ext uri="{FF2B5EF4-FFF2-40B4-BE49-F238E27FC236}">
+                <a16:creationId xmlns:a16="http://schemas.microsoft.com/office/drawing/2014/main" id="{6B7440BC-4130-9004-A19E-89CCA4F29774}"/>
               </a:ext>
             </a:extLst>
           </p:cNvPr>
@@ -4699,7 +4062,7 @@
         </p:blipFill>
         <p:spPr>
           <a:xfrm>
-            <a:off x="6947394" y="5361680"/>
+            <a:off x="7114543" y="4909396"/>
             <a:ext cx="4153480" cy="552527"/>
           </a:xfrm>
           <a:prstGeom prst="rect">
@@ -4710,7 +4073,7 @@
     </p:spTree>
     <p:extLst>
       <p:ext uri="{BB962C8B-B14F-4D97-AF65-F5344CB8AC3E}">
-        <p14:creationId xmlns:p14="http://schemas.microsoft.com/office/powerpoint/2010/main" val="3518080426"/>
+        <p14:creationId xmlns:p14="http://schemas.microsoft.com/office/powerpoint/2010/main" val="4031349663"/>
       </p:ext>
     </p:extLst>
   </p:cSld>
@@ -4742,7 +4105,7 @@
           <p:cNvPr id="2" name="Title 1">
             <a:extLst>
               <a:ext uri="{FF2B5EF4-FFF2-40B4-BE49-F238E27FC236}">
-                <a16:creationId xmlns:a16="http://schemas.microsoft.com/office/drawing/2014/main" id="{FC1DC592-52EF-EBF3-E604-C3DC939DE985}"/>
+                <a16:creationId xmlns:a16="http://schemas.microsoft.com/office/drawing/2014/main" id="{0184B01D-DD63-F243-1B39-E71A506075D4}"/>
               </a:ext>
             </a:extLst>
           </p:cNvPr>
@@ -4770,7 +4133,7 @@
           <p:cNvPr id="3" name="Content Placeholder 2">
             <a:extLst>
               <a:ext uri="{FF2B5EF4-FFF2-40B4-BE49-F238E27FC236}">
-                <a16:creationId xmlns:a16="http://schemas.microsoft.com/office/drawing/2014/main" id="{35BA7925-2B72-AF96-A274-BBBFC5930197}"/>
+                <a16:creationId xmlns:a16="http://schemas.microsoft.com/office/drawing/2014/main" id="{ACC21095-81BE-4B29-C5F3-DEC6FA22043D}"/>
               </a:ext>
             </a:extLst>
           </p:cNvPr>
@@ -4788,19 +4151,19 @@
           <a:p>
             <a:r>
               <a:rPr lang="en-US" dirty="0"/>
-              <a:t>250 MHz clock</a:t>
+              <a:t>125 MHz clock</a:t>
             </a:r>
           </a:p>
           <a:p>
             <a:r>
               <a:rPr lang="en-US" dirty="0"/>
-              <a:t>4 ns resolution</a:t>
+              <a:t>8 ns pulse programmer time resolution</a:t>
             </a:r>
           </a:p>
           <a:p>
             <a:r>
               <a:rPr lang="en-US" dirty="0"/>
-              <a:t>Minimum delay/pulse = 4 ns (1 clock cycles)</a:t>
+              <a:t>Minimum delay/pulse = 8 ns (1 clock cycles)</a:t>
             </a:r>
           </a:p>
           <a:p>
@@ -4833,14 +4196,17 @@
               <a:t> (6,000,000) needs testing</a:t>
             </a:r>
           </a:p>
+          <a:p>
+            <a:endParaRPr lang="en-US" dirty="0"/>
+          </a:p>
         </p:txBody>
       </p:sp>
       <p:pic>
         <p:nvPicPr>
-          <p:cNvPr id="8" name="Picture 7">
-            <a:extLst>
-              <a:ext uri="{FF2B5EF4-FFF2-40B4-BE49-F238E27FC236}">
-                <a16:creationId xmlns:a16="http://schemas.microsoft.com/office/drawing/2014/main" id="{27FFB317-83D0-5FE3-477E-AE4B099D2956}"/>
+          <p:cNvPr id="4" name="Picture 3">
+            <a:extLst>
+              <a:ext uri="{FF2B5EF4-FFF2-40B4-BE49-F238E27FC236}">
+                <a16:creationId xmlns:a16="http://schemas.microsoft.com/office/drawing/2014/main" id="{648E21B2-4B51-533C-06B1-CAA8C423A86B}"/>
               </a:ext>
             </a:extLst>
           </p:cNvPr>
@@ -4868,7 +4234,7 @@
     </p:spTree>
     <p:extLst>
       <p:ext uri="{BB962C8B-B14F-4D97-AF65-F5344CB8AC3E}">
-        <p14:creationId xmlns:p14="http://schemas.microsoft.com/office/powerpoint/2010/main" val="379861110"/>
+        <p14:creationId xmlns:p14="http://schemas.microsoft.com/office/powerpoint/2010/main" val="2433444881"/>
       </p:ext>
     </p:extLst>
   </p:cSld>
@@ -4900,7 +4266,7 @@
           <p:cNvPr id="2" name="Title 1">
             <a:extLst>
               <a:ext uri="{FF2B5EF4-FFF2-40B4-BE49-F238E27FC236}">
-                <a16:creationId xmlns:a16="http://schemas.microsoft.com/office/drawing/2014/main" id="{F4BA3CC6-714E-ABA4-DF99-3166C805F515}"/>
+                <a16:creationId xmlns:a16="http://schemas.microsoft.com/office/drawing/2014/main" id="{6DC6A49D-6AE7-B5DF-E7E1-F65D54B52692}"/>
               </a:ext>
             </a:extLst>
           </p:cNvPr>
@@ -4925,19 +4291,17 @@
       </p:sp>
       <p:pic>
         <p:nvPicPr>
-          <p:cNvPr id="5" name="Content Placeholder 4" descr="A green circuit board with black wires&#10;&#10;AI-generated content may be incorrect.">
-            <a:extLst>
-              <a:ext uri="{FF2B5EF4-FFF2-40B4-BE49-F238E27FC236}">
-                <a16:creationId xmlns:a16="http://schemas.microsoft.com/office/drawing/2014/main" id="{3592D1A4-EC3C-8C9A-95A4-B9BBF14BE5FF}"/>
+          <p:cNvPr id="4" name="Content Placeholder 4" descr="A green circuit board with black wires&#10;&#10;AI-generated content may be incorrect.">
+            <a:extLst>
+              <a:ext uri="{FF2B5EF4-FFF2-40B4-BE49-F238E27FC236}">
+                <a16:creationId xmlns:a16="http://schemas.microsoft.com/office/drawing/2014/main" id="{16A99191-8E0A-73D5-4E8E-81C22795D367}"/>
               </a:ext>
             </a:extLst>
           </p:cNvPr>
           <p:cNvPicPr>
-            <a:picLocks noGrp="1" noChangeAspect="1"/>
+            <a:picLocks noChangeAspect="1"/>
           </p:cNvPicPr>
-          <p:nvPr>
-            <p:ph idx="1"/>
-          </p:nvPr>
+          <p:nvPr/>
         </p:nvPicPr>
         <p:blipFill>
           <a:blip r:embed="rId2">
@@ -4956,14 +4320,17 @@
             <a:off x="1750142" y="4042239"/>
             <a:ext cx="3458496" cy="2593872"/>
           </a:xfrm>
+          <a:prstGeom prst="rect">
+            <a:avLst/>
+          </a:prstGeom>
         </p:spPr>
       </p:pic>
       <p:pic>
         <p:nvPicPr>
-          <p:cNvPr id="7" name="Picture 6" descr="A group of electronic components on a table&#10;&#10;AI-generated content may be incorrect.">
-            <a:extLst>
-              <a:ext uri="{FF2B5EF4-FFF2-40B4-BE49-F238E27FC236}">
-                <a16:creationId xmlns:a16="http://schemas.microsoft.com/office/drawing/2014/main" id="{74132016-6BFA-7990-1D26-306E99903AB8}"/>
+          <p:cNvPr id="5" name="Picture 4" descr="A group of electronic components on a table&#10;&#10;AI-generated content may be incorrect.">
+            <a:extLst>
+              <a:ext uri="{FF2B5EF4-FFF2-40B4-BE49-F238E27FC236}">
+                <a16:creationId xmlns:a16="http://schemas.microsoft.com/office/drawing/2014/main" id="{B05BC794-EE79-6710-19D9-BB4BD0131D5D}"/>
               </a:ext>
             </a:extLst>
           </p:cNvPr>
@@ -4996,10 +4363,10 @@
       </p:pic>
       <p:pic>
         <p:nvPicPr>
-          <p:cNvPr id="9" name="Picture 8" descr="A black electronic device with buttons and switches&#10;&#10;AI-generated content may be incorrect.">
-            <a:extLst>
-              <a:ext uri="{FF2B5EF4-FFF2-40B4-BE49-F238E27FC236}">
-                <a16:creationId xmlns:a16="http://schemas.microsoft.com/office/drawing/2014/main" id="{0DB086C0-887C-0B37-A1C2-9F375827392C}"/>
+          <p:cNvPr id="6" name="Picture 5" descr="A black electronic device with buttons and switches&#10;&#10;AI-generated content may be incorrect.">
+            <a:extLst>
+              <a:ext uri="{FF2B5EF4-FFF2-40B4-BE49-F238E27FC236}">
+                <a16:creationId xmlns:a16="http://schemas.microsoft.com/office/drawing/2014/main" id="{80139D5F-BD26-5DA3-B5E9-94EC80621BAD}"/>
               </a:ext>
             </a:extLst>
           </p:cNvPr>
@@ -5032,10 +4399,10 @@
       </p:pic>
       <p:pic>
         <p:nvPicPr>
-          <p:cNvPr id="11" name="Picture 10" descr="A circuit board with lights on it&#10;&#10;AI-generated content may be incorrect.">
-            <a:extLst>
-              <a:ext uri="{FF2B5EF4-FFF2-40B4-BE49-F238E27FC236}">
-                <a16:creationId xmlns:a16="http://schemas.microsoft.com/office/drawing/2014/main" id="{5B9F0832-18A3-82DB-B7F3-D10BDFAC39F4}"/>
+          <p:cNvPr id="7" name="Picture 6" descr="A circuit board with lights on it&#10;&#10;AI-generated content may be incorrect.">
+            <a:extLst>
+              <a:ext uri="{FF2B5EF4-FFF2-40B4-BE49-F238E27FC236}">
+                <a16:creationId xmlns:a16="http://schemas.microsoft.com/office/drawing/2014/main" id="{8637E75A-E7D3-04CE-B883-1B43BB460FEF}"/>
               </a:ext>
             </a:extLst>
           </p:cNvPr>
@@ -5069,7 +4436,7 @@
     </p:spTree>
     <p:extLst>
       <p:ext uri="{BB962C8B-B14F-4D97-AF65-F5344CB8AC3E}">
-        <p14:creationId xmlns:p14="http://schemas.microsoft.com/office/powerpoint/2010/main" val="1820235582"/>
+        <p14:creationId xmlns:p14="http://schemas.microsoft.com/office/powerpoint/2010/main" val="2854145329"/>
       </p:ext>
     </p:extLst>
   </p:cSld>
@@ -5101,7 +4468,7 @@
           <p:cNvPr id="2" name="Title 1">
             <a:extLst>
               <a:ext uri="{FF2B5EF4-FFF2-40B4-BE49-F238E27FC236}">
-                <a16:creationId xmlns:a16="http://schemas.microsoft.com/office/drawing/2014/main" id="{BD5D0770-C4F4-F98C-EC6D-F569008110B1}"/>
+                <a16:creationId xmlns:a16="http://schemas.microsoft.com/office/drawing/2014/main" id="{DB03FD78-DBCE-369B-5C55-793EACB972C2}"/>
               </a:ext>
             </a:extLst>
           </p:cNvPr>
@@ -5126,19 +4493,17 @@
       </p:sp>
       <p:pic>
         <p:nvPicPr>
-          <p:cNvPr id="5" name="Content Placeholder 4">
-            <a:extLst>
-              <a:ext uri="{FF2B5EF4-FFF2-40B4-BE49-F238E27FC236}">
-                <a16:creationId xmlns:a16="http://schemas.microsoft.com/office/drawing/2014/main" id="{E6F1FBF8-C3D5-DCD9-E821-AAB9247DA208}"/>
+          <p:cNvPr id="4" name="Content Placeholder 4">
+            <a:extLst>
+              <a:ext uri="{FF2B5EF4-FFF2-40B4-BE49-F238E27FC236}">
+                <a16:creationId xmlns:a16="http://schemas.microsoft.com/office/drawing/2014/main" id="{CD0CDD3C-509D-B79B-F12E-EEE3C908D7B6}"/>
               </a:ext>
             </a:extLst>
           </p:cNvPr>
           <p:cNvPicPr>
-            <a:picLocks noGrp="1" noChangeAspect="1"/>
+            <a:picLocks noChangeAspect="1"/>
           </p:cNvPicPr>
-          <p:nvPr>
-            <p:ph idx="1"/>
-          </p:nvPr>
+          <p:nvPr/>
         </p:nvPicPr>
         <p:blipFill>
           <a:blip r:embed="rId2"/>
@@ -5158,10 +4523,10 @@
       </p:pic>
       <p:pic>
         <p:nvPicPr>
-          <p:cNvPr id="7" name="Picture 6">
-            <a:extLst>
-              <a:ext uri="{FF2B5EF4-FFF2-40B4-BE49-F238E27FC236}">
-                <a16:creationId xmlns:a16="http://schemas.microsoft.com/office/drawing/2014/main" id="{2D3EB675-C311-DA5F-2496-E472B810AE23}"/>
+          <p:cNvPr id="5" name="Picture 4">
+            <a:extLst>
+              <a:ext uri="{FF2B5EF4-FFF2-40B4-BE49-F238E27FC236}">
+                <a16:creationId xmlns:a16="http://schemas.microsoft.com/office/drawing/2014/main" id="{819F6BDD-BBC5-61F2-CC45-B69AA6A6FE47}"/>
               </a:ext>
             </a:extLst>
           </p:cNvPr>
@@ -5189,7 +4554,7 @@
     </p:spTree>
     <p:extLst>
       <p:ext uri="{BB962C8B-B14F-4D97-AF65-F5344CB8AC3E}">
-        <p14:creationId xmlns:p14="http://schemas.microsoft.com/office/powerpoint/2010/main" val="3148821995"/>
+        <p14:creationId xmlns:p14="http://schemas.microsoft.com/office/powerpoint/2010/main" val="67811131"/>
       </p:ext>
     </p:extLst>
   </p:cSld>
@@ -5221,7 +4586,7 @@
           <p:cNvPr id="2" name="Title 1">
             <a:extLst>
               <a:ext uri="{FF2B5EF4-FFF2-40B4-BE49-F238E27FC236}">
-                <a16:creationId xmlns:a16="http://schemas.microsoft.com/office/drawing/2014/main" id="{AE7EDC0B-7999-44C2-69A7-DD2F09BD0728}"/>
+                <a16:creationId xmlns:a16="http://schemas.microsoft.com/office/drawing/2014/main" id="{2C86F24F-C1D1-D254-4127-6CCD35A97D33}"/>
               </a:ext>
             </a:extLst>
           </p:cNvPr>
@@ -5246,6 +4611,41 @@
               <a:t>Vivado</a:t>
             </a:r>
             <a:endParaRPr lang="en-US" dirty="0"/>
+          </a:p>
+        </p:txBody>
+      </p:sp>
+      <p:sp>
+        <p:nvSpPr>
+          <p:cNvPr id="4" name="TextBox 3">
+            <a:extLst>
+              <a:ext uri="{FF2B5EF4-FFF2-40B4-BE49-F238E27FC236}">
+                <a16:creationId xmlns:a16="http://schemas.microsoft.com/office/drawing/2014/main" id="{F5F19769-A503-065F-74AB-03237F9F4D46}"/>
+              </a:ext>
+            </a:extLst>
+          </p:cNvPr>
+          <p:cNvSpPr txBox="1"/>
+          <p:nvPr/>
+        </p:nvSpPr>
+        <p:spPr>
+          <a:xfrm>
+            <a:off x="838200" y="1321356"/>
+            <a:ext cx="4576317" cy="369332"/>
+          </a:xfrm>
+          <a:prstGeom prst="rect">
+            <a:avLst/>
+          </a:prstGeom>
+          <a:noFill/>
+        </p:spPr>
+        <p:txBody>
+          <a:bodyPr wrap="none" rtlCol="0">
+            <a:spAutoFit/>
+          </a:bodyPr>
+          <a:lstStyle/>
+          <a:p>
+            <a:r>
+              <a:rPr lang="en-US" dirty="0"/>
+              <a:t>Tools -&gt; Generate Memory Configuration File</a:t>
+            </a:r>
           </a:p>
         </p:txBody>
       </p:sp>
@@ -5254,7 +4654,7 @@
           <p:cNvPr id="5" name="Content Placeholder 4">
             <a:extLst>
               <a:ext uri="{FF2B5EF4-FFF2-40B4-BE49-F238E27FC236}">
-                <a16:creationId xmlns:a16="http://schemas.microsoft.com/office/drawing/2014/main" id="{FBEF7FE2-2519-C2B5-8733-E223665C4BFE}"/>
+                <a16:creationId xmlns:a16="http://schemas.microsoft.com/office/drawing/2014/main" id="{8AC895EC-8DF4-4E9B-22F8-3E2B6877DDE6}"/>
               </a:ext>
             </a:extLst>
           </p:cNvPr>
@@ -5273,53 +4673,18 @@
         </p:blipFill>
         <p:spPr>
           <a:xfrm>
-            <a:off x="1448316" y="2141537"/>
-            <a:ext cx="9295367" cy="4351338"/>
+            <a:off x="690717" y="1690687"/>
+            <a:ext cx="10775911" cy="5044409"/>
           </a:xfrm>
           <a:prstGeom prst="rect">
             <a:avLst/>
           </a:prstGeom>
         </p:spPr>
       </p:pic>
-      <p:sp>
-        <p:nvSpPr>
-          <p:cNvPr id="6" name="TextBox 5">
-            <a:extLst>
-              <a:ext uri="{FF2B5EF4-FFF2-40B4-BE49-F238E27FC236}">
-                <a16:creationId xmlns:a16="http://schemas.microsoft.com/office/drawing/2014/main" id="{E9A6F9EE-D96F-38FD-6B4E-5F6BC82E69D5}"/>
-              </a:ext>
-            </a:extLst>
-          </p:cNvPr>
-          <p:cNvSpPr txBox="1"/>
-          <p:nvPr/>
-        </p:nvSpPr>
-        <p:spPr>
-          <a:xfrm>
-            <a:off x="1219200" y="1514168"/>
-            <a:ext cx="4576317" cy="369332"/>
-          </a:xfrm>
-          <a:prstGeom prst="rect">
-            <a:avLst/>
-          </a:prstGeom>
-          <a:noFill/>
-        </p:spPr>
-        <p:txBody>
-          <a:bodyPr wrap="none" rtlCol="0">
-            <a:spAutoFit/>
-          </a:bodyPr>
-          <a:lstStyle/>
-          <a:p>
-            <a:r>
-              <a:rPr lang="en-US" dirty="0"/>
-              <a:t>Tools -&gt; Generate Memory Configuration File</a:t>
-            </a:r>
-          </a:p>
-        </p:txBody>
-      </p:sp>
     </p:spTree>
     <p:extLst>
       <p:ext uri="{BB962C8B-B14F-4D97-AF65-F5344CB8AC3E}">
-        <p14:creationId xmlns:p14="http://schemas.microsoft.com/office/powerpoint/2010/main" val="1146547650"/>
+        <p14:creationId xmlns:p14="http://schemas.microsoft.com/office/powerpoint/2010/main" val="1733111884"/>
       </p:ext>
     </p:extLst>
   </p:cSld>
@@ -5351,7 +4716,7 @@
           <p:cNvPr id="2" name="Title 1">
             <a:extLst>
               <a:ext uri="{FF2B5EF4-FFF2-40B4-BE49-F238E27FC236}">
-                <a16:creationId xmlns:a16="http://schemas.microsoft.com/office/drawing/2014/main" id="{5FBF23FC-361E-3111-2F16-8D4660CC4FD7}"/>
+                <a16:creationId xmlns:a16="http://schemas.microsoft.com/office/drawing/2014/main" id="{B7382ED8-D6CA-DEBF-3C71-1D1667DCAEE3}"/>
               </a:ext>
             </a:extLst>
           </p:cNvPr>
@@ -5376,19 +4741,17 @@
       </p:sp>
       <p:pic>
         <p:nvPicPr>
-          <p:cNvPr id="5" name="Content Placeholder 4">
-            <a:extLst>
-              <a:ext uri="{FF2B5EF4-FFF2-40B4-BE49-F238E27FC236}">
-                <a16:creationId xmlns:a16="http://schemas.microsoft.com/office/drawing/2014/main" id="{32F04DB4-F764-86EA-9211-116ADB5AADFB}"/>
+          <p:cNvPr id="4" name="Content Placeholder 4">
+            <a:extLst>
+              <a:ext uri="{FF2B5EF4-FFF2-40B4-BE49-F238E27FC236}">
+                <a16:creationId xmlns:a16="http://schemas.microsoft.com/office/drawing/2014/main" id="{A41F5CE5-8577-A9F9-4CA3-C51E8B724BB4}"/>
               </a:ext>
             </a:extLst>
           </p:cNvPr>
           <p:cNvPicPr>
-            <a:picLocks noGrp="1" noChangeAspect="1"/>
+            <a:picLocks noChangeAspect="1"/>
           </p:cNvPicPr>
-          <p:nvPr>
-            <p:ph idx="1"/>
-          </p:nvPr>
+          <p:nvPr/>
         </p:nvPicPr>
         <p:blipFill>
           <a:blip r:embed="rId2"/>
@@ -5408,10 +4771,10 @@
       </p:pic>
       <p:pic>
         <p:nvPicPr>
-          <p:cNvPr id="7" name="Picture 6">
-            <a:extLst>
-              <a:ext uri="{FF2B5EF4-FFF2-40B4-BE49-F238E27FC236}">
-                <a16:creationId xmlns:a16="http://schemas.microsoft.com/office/drawing/2014/main" id="{D29B073B-D39B-37AC-D41B-27B6B94DC3E0}"/>
+          <p:cNvPr id="5" name="Picture 4">
+            <a:extLst>
+              <a:ext uri="{FF2B5EF4-FFF2-40B4-BE49-F238E27FC236}">
+                <a16:creationId xmlns:a16="http://schemas.microsoft.com/office/drawing/2014/main" id="{AB2D375F-E676-4F3D-4A9F-6F018C7DB748}"/>
               </a:ext>
             </a:extLst>
           </p:cNvPr>
@@ -5439,7 +4802,7 @@
     </p:spTree>
     <p:extLst>
       <p:ext uri="{BB962C8B-B14F-4D97-AF65-F5344CB8AC3E}">
-        <p14:creationId xmlns:p14="http://schemas.microsoft.com/office/powerpoint/2010/main" val="2170002627"/>
+        <p14:creationId xmlns:p14="http://schemas.microsoft.com/office/powerpoint/2010/main" val="1629658309"/>
       </p:ext>
     </p:extLst>
   </p:cSld>

</xml_diff>

<commit_message>
Updating documentation, adding table for instructions
</commit_message>
<xml_diff>
--- a/Documentation/Pulse Programmer Documentation.pptx
+++ b/Documentation/Pulse Programmer Documentation.pptx
@@ -7,14 +7,15 @@
   <p:sldIdLst>
     <p:sldId id="256" r:id="rId2"/>
     <p:sldId id="257" r:id="rId3"/>
-    <p:sldId id="258" r:id="rId4"/>
-    <p:sldId id="259" r:id="rId5"/>
-    <p:sldId id="260" r:id="rId6"/>
-    <p:sldId id="261" r:id="rId7"/>
-    <p:sldId id="262" r:id="rId8"/>
-    <p:sldId id="263" r:id="rId9"/>
-    <p:sldId id="264" r:id="rId10"/>
-    <p:sldId id="265" r:id="rId11"/>
+    <p:sldId id="266" r:id="rId4"/>
+    <p:sldId id="258" r:id="rId5"/>
+    <p:sldId id="259" r:id="rId6"/>
+    <p:sldId id="260" r:id="rId7"/>
+    <p:sldId id="261" r:id="rId8"/>
+    <p:sldId id="262" r:id="rId9"/>
+    <p:sldId id="263" r:id="rId10"/>
+    <p:sldId id="264" r:id="rId11"/>
+    <p:sldId id="265" r:id="rId12"/>
   </p:sldIdLst>
   <p:sldSz cx="12192000" cy="6858000"/>
   <p:notesSz cx="6858000" cy="9144000"/>
@@ -113,6 +114,11 @@
       </a:defRPr>
     </a:lvl9pPr>
   </p:defaultTextStyle>
+  <p:extLst>
+    <p:ext uri="{EFAFB233-063F-42B5-8137-9DF3F51BA10A}">
+      <p15:sldGuideLst xmlns:p15="http://schemas.microsoft.com/office/powerpoint/2012/main"/>
+    </p:ext>
+  </p:extLst>
 </p:presentation>
 </file>
 
@@ -3421,6 +3427,124 @@
           <p:cNvPr id="2" name="Title 1">
             <a:extLst>
               <a:ext uri="{FF2B5EF4-FFF2-40B4-BE49-F238E27FC236}">
+                <a16:creationId xmlns:a16="http://schemas.microsoft.com/office/drawing/2014/main" id="{B7382ED8-D6CA-DEBF-3C71-1D1667DCAEE3}"/>
+              </a:ext>
+            </a:extLst>
+          </p:cNvPr>
+          <p:cNvSpPr>
+            <a:spLocks noGrp="1"/>
+          </p:cNvSpPr>
+          <p:nvPr>
+            <p:ph type="title"/>
+          </p:nvPr>
+        </p:nvSpPr>
+        <p:spPr/>
+        <p:txBody>
+          <a:bodyPr/>
+          <a:lstStyle/>
+          <a:p>
+            <a:r>
+              <a:rPr lang="en-US" dirty="0"/>
+              <a:t>Writing Memory Configuration</a:t>
+            </a:r>
+          </a:p>
+        </p:txBody>
+      </p:sp>
+      <p:pic>
+        <p:nvPicPr>
+          <p:cNvPr id="4" name="Content Placeholder 4">
+            <a:extLst>
+              <a:ext uri="{FF2B5EF4-FFF2-40B4-BE49-F238E27FC236}">
+                <a16:creationId xmlns:a16="http://schemas.microsoft.com/office/drawing/2014/main" id="{A41F5CE5-8577-A9F9-4CA3-C51E8B724BB4}"/>
+              </a:ext>
+            </a:extLst>
+          </p:cNvPr>
+          <p:cNvPicPr>
+            <a:picLocks noChangeAspect="1"/>
+          </p:cNvPicPr>
+          <p:nvPr/>
+        </p:nvPicPr>
+        <p:blipFill>
+          <a:blip r:embed="rId2"/>
+          <a:stretch>
+            <a:fillRect/>
+          </a:stretch>
+        </p:blipFill>
+        <p:spPr>
+          <a:xfrm>
+            <a:off x="4992918" y="2141537"/>
+            <a:ext cx="6571688" cy="4351338"/>
+          </a:xfrm>
+          <a:prstGeom prst="rect">
+            <a:avLst/>
+          </a:prstGeom>
+        </p:spPr>
+      </p:pic>
+      <p:pic>
+        <p:nvPicPr>
+          <p:cNvPr id="5" name="Picture 4">
+            <a:extLst>
+              <a:ext uri="{FF2B5EF4-FFF2-40B4-BE49-F238E27FC236}">
+                <a16:creationId xmlns:a16="http://schemas.microsoft.com/office/drawing/2014/main" id="{AB2D375F-E676-4F3D-4A9F-6F018C7DB748}"/>
+              </a:ext>
+            </a:extLst>
+          </p:cNvPr>
+          <p:cNvPicPr>
+            <a:picLocks noChangeAspect="1"/>
+          </p:cNvPicPr>
+          <p:nvPr/>
+        </p:nvPicPr>
+        <p:blipFill>
+          <a:blip r:embed="rId3"/>
+          <a:stretch>
+            <a:fillRect/>
+          </a:stretch>
+        </p:blipFill>
+        <p:spPr>
+          <a:xfrm>
+            <a:off x="237656" y="2141537"/>
+            <a:ext cx="3559256" cy="2779145"/>
+          </a:xfrm>
+          <a:prstGeom prst="rect">
+            <a:avLst/>
+          </a:prstGeom>
+        </p:spPr>
+      </p:pic>
+    </p:spTree>
+    <p:extLst>
+      <p:ext uri="{BB962C8B-B14F-4D97-AF65-F5344CB8AC3E}">
+        <p14:creationId xmlns:p14="http://schemas.microsoft.com/office/powerpoint/2010/main" val="1629658309"/>
+      </p:ext>
+    </p:extLst>
+  </p:cSld>
+  <p:clrMapOvr>
+    <a:masterClrMapping/>
+  </p:clrMapOvr>
+</p:sld>
+</file>
+
+<file path=ppt/slides/slide11.xml><?xml version="1.0" encoding="utf-8"?>
+<p:sld xmlns:a="http://schemas.openxmlformats.org/drawingml/2006/main" xmlns:r="http://schemas.openxmlformats.org/officeDocument/2006/relationships" xmlns:p="http://schemas.openxmlformats.org/presentationml/2006/main">
+  <p:cSld>
+    <p:spTree>
+      <p:nvGrpSpPr>
+        <p:cNvPr id="1" name=""/>
+        <p:cNvGrpSpPr/>
+        <p:nvPr/>
+      </p:nvGrpSpPr>
+      <p:grpSpPr>
+        <a:xfrm>
+          <a:off x="0" y="0"/>
+          <a:ext cx="0" cy="0"/>
+          <a:chOff x="0" y="0"/>
+          <a:chExt cx="0" cy="0"/>
+        </a:xfrm>
+      </p:grpSpPr>
+      <p:sp>
+        <p:nvSpPr>
+          <p:cNvPr id="2" name="Title 1">
+            <a:extLst>
+              <a:ext uri="{FF2B5EF4-FFF2-40B4-BE49-F238E27FC236}">
                 <a16:creationId xmlns:a16="http://schemas.microsoft.com/office/drawing/2014/main" id="{F17DDD3E-88D7-AFD3-9F2F-7436C1B373CC}"/>
               </a:ext>
             </a:extLst>
@@ -3709,6 +3833,633 @@
 </file>
 
 <file path=ppt/slides/slide3.xml><?xml version="1.0" encoding="utf-8"?>
+<p:sld xmlns:a="http://schemas.openxmlformats.org/drawingml/2006/main" xmlns:r="http://schemas.openxmlformats.org/officeDocument/2006/relationships" xmlns:p="http://schemas.openxmlformats.org/presentationml/2006/main">
+  <p:cSld>
+    <p:spTree>
+      <p:nvGrpSpPr>
+        <p:cNvPr id="1" name=""/>
+        <p:cNvGrpSpPr/>
+        <p:nvPr/>
+      </p:nvGrpSpPr>
+      <p:grpSpPr>
+        <a:xfrm>
+          <a:off x="0" y="0"/>
+          <a:ext cx="0" cy="0"/>
+          <a:chOff x="0" y="0"/>
+          <a:chExt cx="0" cy="0"/>
+        </a:xfrm>
+      </p:grpSpPr>
+      <p:sp>
+        <p:nvSpPr>
+          <p:cNvPr id="2" name="Title 1">
+            <a:extLst>
+              <a:ext uri="{FF2B5EF4-FFF2-40B4-BE49-F238E27FC236}">
+                <a16:creationId xmlns:a16="http://schemas.microsoft.com/office/drawing/2014/main" id="{D7800F9D-B115-CE37-90A3-0DEF6DE0456F}"/>
+              </a:ext>
+            </a:extLst>
+          </p:cNvPr>
+          <p:cNvSpPr>
+            <a:spLocks noGrp="1"/>
+          </p:cNvSpPr>
+          <p:nvPr>
+            <p:ph type="title"/>
+          </p:nvPr>
+        </p:nvSpPr>
+        <p:spPr/>
+        <p:txBody>
+          <a:bodyPr/>
+          <a:lstStyle/>
+          <a:p>
+            <a:r>
+              <a:rPr lang="en-US" dirty="0"/>
+              <a:t>Pulse Programmer Instructions</a:t>
+            </a:r>
+          </a:p>
+        </p:txBody>
+      </p:sp>
+      <p:graphicFrame>
+        <p:nvGraphicFramePr>
+          <p:cNvPr id="4" name="Content Placeholder 3">
+            <a:extLst>
+              <a:ext uri="{FF2B5EF4-FFF2-40B4-BE49-F238E27FC236}">
+                <a16:creationId xmlns:a16="http://schemas.microsoft.com/office/drawing/2014/main" id="{177682C3-047A-38AC-4CE9-3DE54C1F2208}"/>
+              </a:ext>
+            </a:extLst>
+          </p:cNvPr>
+          <p:cNvGraphicFramePr>
+            <a:graphicFrameLocks noGrp="1"/>
+          </p:cNvGraphicFramePr>
+          <p:nvPr>
+            <p:ph idx="1"/>
+            <p:extLst>
+              <p:ext uri="{D42A27DB-BD31-4B8C-83A1-F6EECF244321}">
+                <p14:modId xmlns:p14="http://schemas.microsoft.com/office/powerpoint/2010/main" val="2441350426"/>
+              </p:ext>
+            </p:extLst>
+          </p:nvPr>
+        </p:nvGraphicFramePr>
+        <p:xfrm>
+          <a:off x="267928" y="1825625"/>
+          <a:ext cx="11678268" cy="3484880"/>
+        </p:xfrm>
+        <a:graphic>
+          <a:graphicData uri="http://schemas.openxmlformats.org/drawingml/2006/table">
+            <a:tbl>
+              <a:tblPr firstRow="1" bandRow="1">
+                <a:tableStyleId>{5C22544A-7EE6-4342-B048-85BDC9FD1C3A}</a:tableStyleId>
+              </a:tblPr>
+              <a:tblGrid>
+                <a:gridCol w="1946378">
+                  <a:extLst>
+                    <a:ext uri="{9D8B030D-6E8A-4147-A177-3AD203B41FA5}">
+                      <a16:colId xmlns:a16="http://schemas.microsoft.com/office/drawing/2014/main" val="3381540407"/>
+                    </a:ext>
+                  </a:extLst>
+                </a:gridCol>
+                <a:gridCol w="1946378">
+                  <a:extLst>
+                    <a:ext uri="{9D8B030D-6E8A-4147-A177-3AD203B41FA5}">
+                      <a16:colId xmlns:a16="http://schemas.microsoft.com/office/drawing/2014/main" val="2224021200"/>
+                    </a:ext>
+                  </a:extLst>
+                </a:gridCol>
+                <a:gridCol w="1946378">
+                  <a:extLst>
+                    <a:ext uri="{9D8B030D-6E8A-4147-A177-3AD203B41FA5}">
+                      <a16:colId xmlns:a16="http://schemas.microsoft.com/office/drawing/2014/main" val="950614021"/>
+                    </a:ext>
+                  </a:extLst>
+                </a:gridCol>
+                <a:gridCol w="1946378">
+                  <a:extLst>
+                    <a:ext uri="{9D8B030D-6E8A-4147-A177-3AD203B41FA5}">
+                      <a16:colId xmlns:a16="http://schemas.microsoft.com/office/drawing/2014/main" val="4262837244"/>
+                    </a:ext>
+                  </a:extLst>
+                </a:gridCol>
+                <a:gridCol w="1946378">
+                  <a:extLst>
+                    <a:ext uri="{9D8B030D-6E8A-4147-A177-3AD203B41FA5}">
+                      <a16:colId xmlns:a16="http://schemas.microsoft.com/office/drawing/2014/main" val="2504356897"/>
+                    </a:ext>
+                  </a:extLst>
+                </a:gridCol>
+                <a:gridCol w="1946378">
+                  <a:extLst>
+                    <a:ext uri="{9D8B030D-6E8A-4147-A177-3AD203B41FA5}">
+                      <a16:colId xmlns:a16="http://schemas.microsoft.com/office/drawing/2014/main" val="2782323102"/>
+                    </a:ext>
+                  </a:extLst>
+                </a:gridCol>
+              </a:tblGrid>
+              <a:tr h="370840">
+                <a:tc>
+                  <a:txBody>
+                    <a:bodyPr/>
+                    <a:lstStyle/>
+                    <a:p>
+                      <a:r>
+                        <a:rPr lang="en-US" dirty="0"/>
+                        <a:t>OP NAME</a:t>
+                      </a:r>
+                    </a:p>
+                  </a:txBody>
+                  <a:tcPr/>
+                </a:tc>
+                <a:tc>
+                  <a:txBody>
+                    <a:bodyPr/>
+                    <a:lstStyle/>
+                    <a:p>
+                      <a:r>
+                        <a:rPr lang="en-US" dirty="0"/>
+                        <a:t>OP CODE (BIN)</a:t>
+                      </a:r>
+                    </a:p>
+                  </a:txBody>
+                  <a:tcPr/>
+                </a:tc>
+                <a:tc>
+                  <a:txBody>
+                    <a:bodyPr/>
+                    <a:lstStyle/>
+                    <a:p>
+                      <a:r>
+                        <a:rPr lang="en-US" dirty="0"/>
+                        <a:t>OP CODE (INT)</a:t>
+                      </a:r>
+                    </a:p>
+                  </a:txBody>
+                  <a:tcPr/>
+                </a:tc>
+                <a:tc>
+                  <a:txBody>
+                    <a:bodyPr/>
+                    <a:lstStyle/>
+                    <a:p>
+                      <a:r>
+                        <a:rPr lang="en-US" dirty="0"/>
+                        <a:t>DATA</a:t>
+                      </a:r>
+                    </a:p>
+                  </a:txBody>
+                  <a:tcPr/>
+                </a:tc>
+                <a:tc>
+                  <a:txBody>
+                    <a:bodyPr/>
+                    <a:lstStyle/>
+                    <a:p>
+                      <a:r>
+                        <a:rPr lang="en-US" dirty="0"/>
+                        <a:t>DELAY</a:t>
+                      </a:r>
+                    </a:p>
+                  </a:txBody>
+                  <a:tcPr/>
+                </a:tc>
+                <a:tc>
+                  <a:txBody>
+                    <a:bodyPr/>
+                    <a:lstStyle/>
+                    <a:p>
+                      <a:r>
+                        <a:rPr lang="en-US" dirty="0"/>
+                        <a:t>DESCRIPTION</a:t>
+                      </a:r>
+                    </a:p>
+                  </a:txBody>
+                  <a:tcPr/>
+                </a:tc>
+                <a:extLst>
+                  <a:ext uri="{0D108BD9-81ED-4DB2-BD59-A6C34878D82A}">
+                    <a16:rowId xmlns:a16="http://schemas.microsoft.com/office/drawing/2014/main" val="2063154371"/>
+                  </a:ext>
+                </a:extLst>
+              </a:tr>
+              <a:tr h="370840">
+                <a:tc>
+                  <a:txBody>
+                    <a:bodyPr/>
+                    <a:lstStyle/>
+                    <a:p>
+                      <a:r>
+                        <a:rPr lang="en-US" dirty="0"/>
+                        <a:t>NO OP</a:t>
+                      </a:r>
+                    </a:p>
+                  </a:txBody>
+                  <a:tcPr/>
+                </a:tc>
+                <a:tc>
+                  <a:txBody>
+                    <a:bodyPr/>
+                    <a:lstStyle/>
+                    <a:p>
+                      <a:r>
+                        <a:rPr lang="en-US" dirty="0"/>
+                        <a:t>0b00</a:t>
+                      </a:r>
+                    </a:p>
+                  </a:txBody>
+                  <a:tcPr/>
+                </a:tc>
+                <a:tc>
+                  <a:txBody>
+                    <a:bodyPr/>
+                    <a:lstStyle/>
+                    <a:p>
+                      <a:r>
+                        <a:rPr lang="en-US" dirty="0"/>
+                        <a:t>0</a:t>
+                      </a:r>
+                    </a:p>
+                  </a:txBody>
+                  <a:tcPr/>
+                </a:tc>
+                <a:tc>
+                  <a:txBody>
+                    <a:bodyPr/>
+                    <a:lstStyle/>
+                    <a:p>
+                      <a:r>
+                        <a:rPr lang="en-US" dirty="0"/>
+                        <a:t>NA</a:t>
+                      </a:r>
+                    </a:p>
+                  </a:txBody>
+                  <a:tcPr/>
+                </a:tc>
+                <a:tc>
+                  <a:txBody>
+                    <a:bodyPr/>
+                    <a:lstStyle/>
+                    <a:p>
+                      <a:r>
+                        <a:rPr lang="en-US" dirty="0"/>
+                        <a:t>NA</a:t>
+                      </a:r>
+                    </a:p>
+                  </a:txBody>
+                  <a:tcPr/>
+                </a:tc>
+                <a:tc>
+                  <a:txBody>
+                    <a:bodyPr/>
+                    <a:lstStyle/>
+                    <a:p>
+                      <a:r>
+                        <a:rPr lang="en-US" dirty="0"/>
+                        <a:t>NO OPERATION</a:t>
+                      </a:r>
+                    </a:p>
+                  </a:txBody>
+                  <a:tcPr/>
+                </a:tc>
+                <a:extLst>
+                  <a:ext uri="{0D108BD9-81ED-4DB2-BD59-A6C34878D82A}">
+                    <a16:rowId xmlns:a16="http://schemas.microsoft.com/office/drawing/2014/main" val="3558065638"/>
+                  </a:ext>
+                </a:extLst>
+              </a:tr>
+              <a:tr h="370840">
+                <a:tc>
+                  <a:txBody>
+                    <a:bodyPr/>
+                    <a:lstStyle/>
+                    <a:p>
+                      <a:r>
+                        <a:rPr lang="en-US" dirty="0"/>
+                        <a:t>DELAY</a:t>
+                      </a:r>
+                    </a:p>
+                  </a:txBody>
+                  <a:tcPr/>
+                </a:tc>
+                <a:tc>
+                  <a:txBody>
+                    <a:bodyPr/>
+                    <a:lstStyle/>
+                    <a:p>
+                      <a:r>
+                        <a:rPr lang="en-US" dirty="0"/>
+                        <a:t>0b01</a:t>
+                      </a:r>
+                    </a:p>
+                  </a:txBody>
+                  <a:tcPr/>
+                </a:tc>
+                <a:tc>
+                  <a:txBody>
+                    <a:bodyPr/>
+                    <a:lstStyle/>
+                    <a:p>
+                      <a:r>
+                        <a:rPr lang="en-US" dirty="0"/>
+                        <a:t>1</a:t>
+                      </a:r>
+                    </a:p>
+                  </a:txBody>
+                  <a:tcPr/>
+                </a:tc>
+                <a:tc>
+                  <a:txBody>
+                    <a:bodyPr/>
+                    <a:lstStyle/>
+                    <a:p>
+                      <a:r>
+                        <a:rPr lang="en-US" dirty="0"/>
+                        <a:t>NA</a:t>
+                      </a:r>
+                    </a:p>
+                  </a:txBody>
+                  <a:tcPr/>
+                </a:tc>
+                <a:tc>
+                  <a:txBody>
+                    <a:bodyPr/>
+                    <a:lstStyle/>
+                    <a:p>
+                      <a:r>
+                        <a:rPr lang="en-US" dirty="0"/>
+                        <a:t>0 to 2</a:t>
+                      </a:r>
+                      <a:r>
+                        <a:rPr lang="en-US" baseline="30000" dirty="0"/>
+                        <a:t>32</a:t>
+                      </a:r>
+                      <a:r>
+                        <a:rPr lang="en-US" baseline="0" dirty="0"/>
+                        <a:t> - 1</a:t>
+                      </a:r>
+                      <a:endParaRPr lang="en-US" dirty="0"/>
+                    </a:p>
+                  </a:txBody>
+                  <a:tcPr/>
+                </a:tc>
+                <a:tc>
+                  <a:txBody>
+                    <a:bodyPr/>
+                    <a:lstStyle/>
+                    <a:p>
+                      <a:r>
+                        <a:rPr lang="en-US" dirty="0"/>
+                        <a:t>DELAY FOR DELAY*CLOCK PERIOD NS</a:t>
+                      </a:r>
+                    </a:p>
+                  </a:txBody>
+                  <a:tcPr/>
+                </a:tc>
+                <a:extLst>
+                  <a:ext uri="{0D108BD9-81ED-4DB2-BD59-A6C34878D82A}">
+                    <a16:rowId xmlns:a16="http://schemas.microsoft.com/office/drawing/2014/main" val="3214577987"/>
+                  </a:ext>
+                </a:extLst>
+              </a:tr>
+              <a:tr h="370840">
+                <a:tc>
+                  <a:txBody>
+                    <a:bodyPr/>
+                    <a:lstStyle/>
+                    <a:p>
+                      <a:r>
+                        <a:rPr lang="en-US" dirty="0"/>
+                        <a:t>LONG DELAY</a:t>
+                      </a:r>
+                    </a:p>
+                  </a:txBody>
+                  <a:tcPr/>
+                </a:tc>
+                <a:tc>
+                  <a:txBody>
+                    <a:bodyPr/>
+                    <a:lstStyle/>
+                    <a:p>
+                      <a:r>
+                        <a:rPr lang="en-US" dirty="0"/>
+                        <a:t>0b10</a:t>
+                      </a:r>
+                    </a:p>
+                  </a:txBody>
+                  <a:tcPr/>
+                </a:tc>
+                <a:tc>
+                  <a:txBody>
+                    <a:bodyPr/>
+                    <a:lstStyle/>
+                    <a:p>
+                      <a:r>
+                        <a:rPr lang="en-US" dirty="0"/>
+                        <a:t>2</a:t>
+                      </a:r>
+                    </a:p>
+                  </a:txBody>
+                  <a:tcPr/>
+                </a:tc>
+                <a:tc>
+                  <a:txBody>
+                    <a:bodyPr/>
+                    <a:lstStyle/>
+                    <a:p>
+                      <a:r>
+                        <a:rPr lang="en-US" dirty="0"/>
+                        <a:t>0 TO 2</a:t>
+                      </a:r>
+                      <a:r>
+                        <a:rPr lang="en-US" baseline="30000" dirty="0"/>
+                        <a:t>20</a:t>
+                      </a:r>
+                      <a:r>
+                        <a:rPr lang="en-US" baseline="0" dirty="0"/>
+                        <a:t> – 1</a:t>
+                      </a:r>
+                      <a:endParaRPr lang="en-US" dirty="0"/>
+                    </a:p>
+                  </a:txBody>
+                  <a:tcPr/>
+                </a:tc>
+                <a:tc>
+                  <a:txBody>
+                    <a:bodyPr/>
+                    <a:lstStyle/>
+                    <a:p>
+                      <a:pPr marL="0" marR="0" lvl="0" indent="0" algn="l" defTabSz="914400" rtl="0" eaLnBrk="1" fontAlgn="auto" latinLnBrk="0" hangingPunct="1">
+                        <a:lnSpc>
+                          <a:spcPct val="100000"/>
+                        </a:lnSpc>
+                        <a:spcBef>
+                          <a:spcPts val="0"/>
+                        </a:spcBef>
+                        <a:spcAft>
+                          <a:spcPts val="0"/>
+                        </a:spcAft>
+                        <a:buClrTx/>
+                        <a:buSzTx/>
+                        <a:buFontTx/>
+                        <a:buNone/>
+                        <a:tabLst/>
+                        <a:defRPr/>
+                      </a:pPr>
+                      <a:r>
+                        <a:rPr lang="en-US" dirty="0"/>
+                        <a:t>0 to 2</a:t>
+                      </a:r>
+                      <a:r>
+                        <a:rPr lang="en-US" baseline="30000" dirty="0"/>
+                        <a:t>32</a:t>
+                      </a:r>
+                      <a:r>
+                        <a:rPr lang="en-US" baseline="0" dirty="0"/>
+                        <a:t> - 1</a:t>
+                      </a:r>
+                      <a:endParaRPr lang="en-US" dirty="0"/>
+                    </a:p>
+                    <a:p>
+                      <a:endParaRPr lang="en-US" dirty="0"/>
+                    </a:p>
+                  </a:txBody>
+                  <a:tcPr/>
+                </a:tc>
+                <a:tc>
+                  <a:txBody>
+                    <a:bodyPr/>
+                    <a:lstStyle/>
+                    <a:p>
+                      <a:r>
+                        <a:rPr lang="en-US" dirty="0"/>
+                        <a:t>DELAY FOR</a:t>
+                      </a:r>
+                    </a:p>
+                    <a:p>
+                      <a:r>
+                        <a:rPr lang="en-US" dirty="0"/>
+                        <a:t>DATA*DELAY*</a:t>
+                      </a:r>
+                    </a:p>
+                    <a:p>
+                      <a:r>
+                        <a:rPr lang="en-US" dirty="0"/>
+                        <a:t>CLOCK PERIOD NS</a:t>
+                      </a:r>
+                    </a:p>
+                  </a:txBody>
+                  <a:tcPr/>
+                </a:tc>
+                <a:extLst>
+                  <a:ext uri="{0D108BD9-81ED-4DB2-BD59-A6C34878D82A}">
+                    <a16:rowId xmlns:a16="http://schemas.microsoft.com/office/drawing/2014/main" val="2813050817"/>
+                  </a:ext>
+                </a:extLst>
+              </a:tr>
+              <a:tr h="370840">
+                <a:tc>
+                  <a:txBody>
+                    <a:bodyPr/>
+                    <a:lstStyle/>
+                    <a:p>
+                      <a:r>
+                        <a:rPr lang="en-US" dirty="0"/>
+                        <a:t>JUMP</a:t>
+                      </a:r>
+                    </a:p>
+                  </a:txBody>
+                  <a:tcPr/>
+                </a:tc>
+                <a:tc>
+                  <a:txBody>
+                    <a:bodyPr/>
+                    <a:lstStyle/>
+                    <a:p>
+                      <a:r>
+                        <a:rPr lang="en-US" dirty="0"/>
+                        <a:t>0b11</a:t>
+                      </a:r>
+                    </a:p>
+                  </a:txBody>
+                  <a:tcPr/>
+                </a:tc>
+                <a:tc>
+                  <a:txBody>
+                    <a:bodyPr/>
+                    <a:lstStyle/>
+                    <a:p>
+                      <a:r>
+                        <a:rPr lang="en-US" dirty="0"/>
+                        <a:t>3</a:t>
+                      </a:r>
+                    </a:p>
+                  </a:txBody>
+                  <a:tcPr/>
+                </a:tc>
+                <a:tc>
+                  <a:txBody>
+                    <a:bodyPr/>
+                    <a:lstStyle/>
+                    <a:p>
+                      <a:r>
+                        <a:rPr lang="en-US" dirty="0"/>
+                        <a:t>BRAM</a:t>
+                      </a:r>
+                    </a:p>
+                    <a:p>
+                      <a:r>
+                        <a:rPr lang="en-US" dirty="0"/>
+                        <a:t>ADDRESS</a:t>
+                      </a:r>
+                    </a:p>
+                  </a:txBody>
+                  <a:tcPr/>
+                </a:tc>
+                <a:tc>
+                  <a:txBody>
+                    <a:bodyPr/>
+                    <a:lstStyle/>
+                    <a:p>
+                      <a:r>
+                        <a:rPr lang="en-US" dirty="0"/>
+                        <a:t>NA</a:t>
+                      </a:r>
+                    </a:p>
+                  </a:txBody>
+                  <a:tcPr/>
+                </a:tc>
+                <a:tc>
+                  <a:txBody>
+                    <a:bodyPr/>
+                    <a:lstStyle/>
+                    <a:p>
+                      <a:r>
+                        <a:rPr lang="en-US" dirty="0"/>
+                        <a:t>JUMP TO ADDRESS</a:t>
+                      </a:r>
+                    </a:p>
+                  </a:txBody>
+                  <a:tcPr/>
+                </a:tc>
+                <a:extLst>
+                  <a:ext uri="{0D108BD9-81ED-4DB2-BD59-A6C34878D82A}">
+                    <a16:rowId xmlns:a16="http://schemas.microsoft.com/office/drawing/2014/main" val="3262130638"/>
+                  </a:ext>
+                </a:extLst>
+              </a:tr>
+            </a:tbl>
+          </a:graphicData>
+        </a:graphic>
+      </p:graphicFrame>
+    </p:spTree>
+    <p:extLst>
+      <p:ext uri="{BB962C8B-B14F-4D97-AF65-F5344CB8AC3E}">
+        <p14:creationId xmlns:p14="http://schemas.microsoft.com/office/powerpoint/2010/main" val="3336198450"/>
+      </p:ext>
+    </p:extLst>
+  </p:cSld>
+  <p:clrMapOvr>
+    <a:masterClrMapping/>
+  </p:clrMapOvr>
+</p:sld>
+</file>
+
+<file path=ppt/slides/slide4.xml><?xml version="1.0" encoding="utf-8"?>
 <p:sld xmlns:a="http://schemas.openxmlformats.org/drawingml/2006/main" xmlns:r="http://schemas.openxmlformats.org/officeDocument/2006/relationships" xmlns:p="http://schemas.openxmlformats.org/presentationml/2006/main">
   <p:cSld>
     <p:spTree>
@@ -3873,7 +4624,7 @@
 </p:sld>
 </file>
 
-<file path=ppt/slides/slide4.xml><?xml version="1.0" encoding="utf-8"?>
+<file path=ppt/slides/slide5.xml><?xml version="1.0" encoding="utf-8"?>
 <p:sld xmlns:a="http://schemas.openxmlformats.org/drawingml/2006/main" xmlns:r="http://schemas.openxmlformats.org/officeDocument/2006/relationships" xmlns:p="http://schemas.openxmlformats.org/presentationml/2006/main">
   <p:cSld>
     <p:spTree>
@@ -4083,7 +4834,7 @@
 </p:sld>
 </file>
 
-<file path=ppt/slides/slide5.xml><?xml version="1.0" encoding="utf-8"?>
+<file path=ppt/slides/slide6.xml><?xml version="1.0" encoding="utf-8"?>
 <p:sld xmlns:a="http://schemas.openxmlformats.org/drawingml/2006/main" xmlns:r="http://schemas.openxmlformats.org/officeDocument/2006/relationships" xmlns:p="http://schemas.openxmlformats.org/presentationml/2006/main">
   <p:cSld>
     <p:spTree>
@@ -4244,7 +4995,7 @@
 </p:sld>
 </file>
 
-<file path=ppt/slides/slide6.xml><?xml version="1.0" encoding="utf-8"?>
+<file path=ppt/slides/slide7.xml><?xml version="1.0" encoding="utf-8"?>
 <p:sld xmlns:a="http://schemas.openxmlformats.org/drawingml/2006/main" xmlns:r="http://schemas.openxmlformats.org/officeDocument/2006/relationships" xmlns:p="http://schemas.openxmlformats.org/presentationml/2006/main">
   <p:cSld>
     <p:spTree>
@@ -4446,7 +5197,7 @@
 </p:sld>
 </file>
 
-<file path=ppt/slides/slide7.xml><?xml version="1.0" encoding="utf-8"?>
+<file path=ppt/slides/slide8.xml><?xml version="1.0" encoding="utf-8"?>
 <p:sld xmlns:a="http://schemas.openxmlformats.org/drawingml/2006/main" xmlns:r="http://schemas.openxmlformats.org/officeDocument/2006/relationships" xmlns:p="http://schemas.openxmlformats.org/presentationml/2006/main">
   <p:cSld>
     <p:spTree>
@@ -4564,7 +5315,7 @@
 </p:sld>
 </file>
 
-<file path=ppt/slides/slide8.xml><?xml version="1.0" encoding="utf-8"?>
+<file path=ppt/slides/slide9.xml><?xml version="1.0" encoding="utf-8"?>
 <p:sld xmlns:a="http://schemas.openxmlformats.org/drawingml/2006/main" xmlns:r="http://schemas.openxmlformats.org/officeDocument/2006/relationships" xmlns:p="http://schemas.openxmlformats.org/presentationml/2006/main">
   <p:cSld>
     <p:spTree>
@@ -4685,124 +5436,6 @@
     <p:extLst>
       <p:ext uri="{BB962C8B-B14F-4D97-AF65-F5344CB8AC3E}">
         <p14:creationId xmlns:p14="http://schemas.microsoft.com/office/powerpoint/2010/main" val="1733111884"/>
-      </p:ext>
-    </p:extLst>
-  </p:cSld>
-  <p:clrMapOvr>
-    <a:masterClrMapping/>
-  </p:clrMapOvr>
-</p:sld>
-</file>
-
-<file path=ppt/slides/slide9.xml><?xml version="1.0" encoding="utf-8"?>
-<p:sld xmlns:a="http://schemas.openxmlformats.org/drawingml/2006/main" xmlns:r="http://schemas.openxmlformats.org/officeDocument/2006/relationships" xmlns:p="http://schemas.openxmlformats.org/presentationml/2006/main">
-  <p:cSld>
-    <p:spTree>
-      <p:nvGrpSpPr>
-        <p:cNvPr id="1" name=""/>
-        <p:cNvGrpSpPr/>
-        <p:nvPr/>
-      </p:nvGrpSpPr>
-      <p:grpSpPr>
-        <a:xfrm>
-          <a:off x="0" y="0"/>
-          <a:ext cx="0" cy="0"/>
-          <a:chOff x="0" y="0"/>
-          <a:chExt cx="0" cy="0"/>
-        </a:xfrm>
-      </p:grpSpPr>
-      <p:sp>
-        <p:nvSpPr>
-          <p:cNvPr id="2" name="Title 1">
-            <a:extLst>
-              <a:ext uri="{FF2B5EF4-FFF2-40B4-BE49-F238E27FC236}">
-                <a16:creationId xmlns:a16="http://schemas.microsoft.com/office/drawing/2014/main" id="{B7382ED8-D6CA-DEBF-3C71-1D1667DCAEE3}"/>
-              </a:ext>
-            </a:extLst>
-          </p:cNvPr>
-          <p:cNvSpPr>
-            <a:spLocks noGrp="1"/>
-          </p:cNvSpPr>
-          <p:nvPr>
-            <p:ph type="title"/>
-          </p:nvPr>
-        </p:nvSpPr>
-        <p:spPr/>
-        <p:txBody>
-          <a:bodyPr/>
-          <a:lstStyle/>
-          <a:p>
-            <a:r>
-              <a:rPr lang="en-US" dirty="0"/>
-              <a:t>Writing Memory Configuration</a:t>
-            </a:r>
-          </a:p>
-        </p:txBody>
-      </p:sp>
-      <p:pic>
-        <p:nvPicPr>
-          <p:cNvPr id="4" name="Content Placeholder 4">
-            <a:extLst>
-              <a:ext uri="{FF2B5EF4-FFF2-40B4-BE49-F238E27FC236}">
-                <a16:creationId xmlns:a16="http://schemas.microsoft.com/office/drawing/2014/main" id="{A41F5CE5-8577-A9F9-4CA3-C51E8B724BB4}"/>
-              </a:ext>
-            </a:extLst>
-          </p:cNvPr>
-          <p:cNvPicPr>
-            <a:picLocks noChangeAspect="1"/>
-          </p:cNvPicPr>
-          <p:nvPr/>
-        </p:nvPicPr>
-        <p:blipFill>
-          <a:blip r:embed="rId2"/>
-          <a:stretch>
-            <a:fillRect/>
-          </a:stretch>
-        </p:blipFill>
-        <p:spPr>
-          <a:xfrm>
-            <a:off x="4992918" y="2141537"/>
-            <a:ext cx="6571688" cy="4351338"/>
-          </a:xfrm>
-          <a:prstGeom prst="rect">
-            <a:avLst/>
-          </a:prstGeom>
-        </p:spPr>
-      </p:pic>
-      <p:pic>
-        <p:nvPicPr>
-          <p:cNvPr id="5" name="Picture 4">
-            <a:extLst>
-              <a:ext uri="{FF2B5EF4-FFF2-40B4-BE49-F238E27FC236}">
-                <a16:creationId xmlns:a16="http://schemas.microsoft.com/office/drawing/2014/main" id="{AB2D375F-E676-4F3D-4A9F-6F018C7DB748}"/>
-              </a:ext>
-            </a:extLst>
-          </p:cNvPr>
-          <p:cNvPicPr>
-            <a:picLocks noChangeAspect="1"/>
-          </p:cNvPicPr>
-          <p:nvPr/>
-        </p:nvPicPr>
-        <p:blipFill>
-          <a:blip r:embed="rId3"/>
-          <a:stretch>
-            <a:fillRect/>
-          </a:stretch>
-        </p:blipFill>
-        <p:spPr>
-          <a:xfrm>
-            <a:off x="237656" y="2141537"/>
-            <a:ext cx="3559256" cy="2779145"/>
-          </a:xfrm>
-          <a:prstGeom prst="rect">
-            <a:avLst/>
-          </a:prstGeom>
-        </p:spPr>
-      </p:pic>
-    </p:spTree>
-    <p:extLst>
-      <p:ext uri="{BB962C8B-B14F-4D97-AF65-F5344CB8AC3E}">
-        <p14:creationId xmlns:p14="http://schemas.microsoft.com/office/powerpoint/2010/main" val="1629658309"/>
       </p:ext>
     </p:extLst>
   </p:cSld>

</xml_diff>

<commit_message>
Working on fixing bug with jump
</commit_message>
<xml_diff>
--- a/Documentation/Pulse Programmer Documentation.pptx
+++ b/Documentation/Pulse Programmer Documentation.pptx
@@ -3893,14 +3893,14 @@
             <p:ph idx="1"/>
             <p:extLst>
               <p:ext uri="{D42A27DB-BD31-4B8C-83A1-F6EECF244321}">
-                <p14:modId xmlns:p14="http://schemas.microsoft.com/office/powerpoint/2010/main" val="2441350426"/>
+                <p14:modId xmlns:p14="http://schemas.microsoft.com/office/powerpoint/2010/main" val="1276317434"/>
               </p:ext>
             </p:extLst>
           </p:nvPr>
         </p:nvGraphicFramePr>
         <p:xfrm>
           <a:off x="267928" y="1825625"/>
-          <a:ext cx="11678268" cy="3484880"/>
+          <a:ext cx="11678268" cy="4124960"/>
         </p:xfrm>
         <a:graphic>
           <a:graphicData uri="http://schemas.openxmlformats.org/drawingml/2006/table">
@@ -4058,7 +4058,7 @@
                     <a:p>
                       <a:r>
                         <a:rPr lang="en-US" dirty="0"/>
-                        <a:t>0b00</a:t>
+                        <a:t>0b0000</a:t>
                       </a:r>
                     </a:p>
                   </a:txBody>
@@ -4143,7 +4143,7 @@
                     <a:p>
                       <a:r>
                         <a:rPr lang="en-US" dirty="0"/>
-                        <a:t>0b01</a:t>
+                        <a:t>0b0001</a:t>
                       </a:r>
                     </a:p>
                   </a:txBody>
@@ -4237,7 +4237,7 @@
                     <a:p>
                       <a:r>
                         <a:rPr lang="en-US" dirty="0"/>
-                        <a:t>0b10</a:t>
+                        <a:t>0b0010</a:t>
                       </a:r>
                     </a:p>
                   </a:txBody>
@@ -4372,7 +4372,7 @@
                     <a:p>
                       <a:r>
                         <a:rPr lang="en-US" dirty="0"/>
-                        <a:t>0b11</a:t>
+                        <a:t>0b0011</a:t>
                       </a:r>
                     </a:p>
                   </a:txBody>
@@ -4439,6 +4439,91 @@
                 <a:extLst>
                   <a:ext uri="{0D108BD9-81ED-4DB2-BD59-A6C34878D82A}">
                     <a16:rowId xmlns:a16="http://schemas.microsoft.com/office/drawing/2014/main" val="3262130638"/>
+                  </a:ext>
+                </a:extLst>
+              </a:tr>
+              <a:tr h="370840">
+                <a:tc>
+                  <a:txBody>
+                    <a:bodyPr/>
+                    <a:lstStyle/>
+                    <a:p>
+                      <a:r>
+                        <a:rPr lang="en-US" dirty="0"/>
+                        <a:t>WAIT</a:t>
+                      </a:r>
+                    </a:p>
+                  </a:txBody>
+                  <a:tcPr/>
+                </a:tc>
+                <a:tc>
+                  <a:txBody>
+                    <a:bodyPr/>
+                    <a:lstStyle/>
+                    <a:p>
+                      <a:r>
+                        <a:rPr lang="en-US" dirty="0"/>
+                        <a:t>0b1000</a:t>
+                      </a:r>
+                    </a:p>
+                  </a:txBody>
+                  <a:tcPr/>
+                </a:tc>
+                <a:tc>
+                  <a:txBody>
+                    <a:bodyPr/>
+                    <a:lstStyle/>
+                    <a:p>
+                      <a:r>
+                        <a:rPr lang="en-US" dirty="0"/>
+                        <a:t>8</a:t>
+                      </a:r>
+                    </a:p>
+                  </a:txBody>
+                  <a:tcPr/>
+                </a:tc>
+                <a:tc>
+                  <a:txBody>
+                    <a:bodyPr/>
+                    <a:lstStyle/>
+                    <a:p>
+                      <a:r>
+                        <a:rPr lang="en-US" dirty="0"/>
+                        <a:t>NA</a:t>
+                      </a:r>
+                    </a:p>
+                  </a:txBody>
+                  <a:tcPr/>
+                </a:tc>
+                <a:tc>
+                  <a:txBody>
+                    <a:bodyPr/>
+                    <a:lstStyle/>
+                    <a:p>
+                      <a:r>
+                        <a:rPr lang="en-US" dirty="0"/>
+                        <a:t>NA</a:t>
+                      </a:r>
+                    </a:p>
+                  </a:txBody>
+                  <a:tcPr/>
+                </a:tc>
+                <a:tc>
+                  <a:txBody>
+                    <a:bodyPr/>
+                    <a:lstStyle/>
+                    <a:p>
+                      <a:r>
+                        <a:rPr lang="en-US" dirty="0"/>
+                        <a:t>WAIT FOR TRIGGER INPUT</a:t>
+                      </a:r>
+                    </a:p>
+                  </a:txBody>
+                  <a:tcPr/>
+                </a:tc>
+                <a:extLst>
+                  <a:ext uri="{0D108BD9-81ED-4DB2-BD59-A6C34878D82A}">
+                    <a16:rowId xmlns:a16="http://schemas.microsoft.com/office/drawing/2014/main" val="655988707"/>
                   </a:ext>
                 </a:extLst>
               </a:tr>

</xml_diff>